<commit_message>
docs(pitch): surface Swagger/OpenAPI and MLflow as demonstrable surfaces
Slide 9 becomes a 2x2 grid of live surfaces — Decision Console, Swagger/OpenAPI
(FastAPI /docs), Observability Board and MLflow Tracking (:5000). Slide 11's
Serving step now names OpenAPI/Swagger explicitly.

Co-Authored-By: Claude Opus 4.8 <noreply@anthropic.com>
</commit_message>
<xml_diff>
--- a/docs/Adaptive-Offers-Pitch-Grupo64.pptx
+++ b/docs/Adaptive-Offers-Pitch-Grupo64.pptx
@@ -4407,7 +4407,7 @@
                 <a:ea typeface="Calibri" pitchFamily="34" charset="-122"/>
                 <a:cs typeface="Calibri" pitchFamily="34" charset="-120"/>
               </a:rPr>
-              <a:t>FastAPI com contrato, reason codes e log auditável.</a:t>
+              <a:t>FastAPI + OpenAPI/Swagger, reason codes e log auditável.</a:t>
             </a:r>
             <a:endParaRPr lang="en-US" sz="1250" dirty="0"/>
           </a:p>
@@ -13988,7 +13988,7 @@
                 <a:ea typeface="Trebuchet MS" pitchFamily="34" charset="-122"/>
                 <a:cs typeface="Trebuchet MS" pitchFamily="34" charset="-120"/>
               </a:rPr>
-              <a:t>Produto demonstrável: console + observabilidade</a:t>
+              <a:t>Quatro superfícies demonstráveis — ao vivo</a:t>
             </a:r>
             <a:endParaRPr lang="en-US" sz="2800" dirty="0"/>
           </a:p>
@@ -14002,12 +14002,12 @@
         </p:nvSpPr>
         <p:spPr>
           <a:xfrm>
-            <a:off x="566928" y="1965960"/>
-            <a:ext cx="5298948" cy="3611880"/>
+            <a:off x="566928" y="1874520"/>
+            <a:ext cx="5298948" cy="1755648"/>
           </a:xfrm>
           <a:prstGeom prst="roundRect">
             <a:avLst>
-              <a:gd name="adj" fmla="val 2278"/>
+              <a:gd name="adj" fmla="val 4688"/>
             </a:avLst>
           </a:prstGeom>
           <a:solidFill>
@@ -14036,8 +14036,8 @@
         </p:nvSpPr>
         <p:spPr>
           <a:xfrm>
-            <a:off x="566928" y="1965960"/>
-            <a:ext cx="5298948" cy="91440"/>
+            <a:off x="566928" y="1874520"/>
+            <a:ext cx="5298948" cy="82296"/>
           </a:xfrm>
           <a:prstGeom prst="rect">
             <a:avLst/>
@@ -14056,8 +14056,8 @@
         </p:nvSpPr>
         <p:spPr>
           <a:xfrm>
-            <a:off x="932688" y="2240280"/>
-            <a:ext cx="4567428" cy="457200"/>
+            <a:off x="886968" y="2093976"/>
+            <a:ext cx="3332988" cy="411480"/>
           </a:xfrm>
           <a:prstGeom prst="rect">
             <a:avLst/>
@@ -14073,7 +14073,7 @@
               <a:buNone/>
             </a:pPr>
             <a:r>
-              <a:rPr lang="en-US" sz="2100" b="1" dirty="0">
+              <a:rPr lang="en-US" sz="1800" b="1" dirty="0">
                 <a:solidFill>
                   <a:srgbClr val="EDEDED"/>
                 </a:solidFill>
@@ -14083,7 +14083,7 @@
               </a:rPr>
               <a:t>Decision Console</a:t>
             </a:r>
-            <a:endParaRPr lang="en-US" sz="2100" dirty="0"/>
+            <a:endParaRPr lang="en-US" sz="1800" dirty="0"/>
           </a:p>
         </p:txBody>
       </p:sp>
@@ -14095,24 +14095,24 @@
         </p:nvSpPr>
         <p:spPr>
           <a:xfrm>
-            <a:off x="932688" y="2724912"/>
-            <a:ext cx="4567428" cy="320040"/>
-          </a:xfrm>
-          <a:prstGeom prst="rect">
-            <a:avLst/>
-          </a:prstGeom>
-          <a:noFill/>
-          <a:ln/>
-        </p:spPr>
-        <p:txBody>
-          <a:bodyPr wrap="square" lIns="0" tIns="0" rIns="0" bIns="0" rtlCol="0" anchor="ctr"/>
-          <a:lstStyle/>
-          <a:p>
-            <a:pPr indent="0" marL="0">
-              <a:buNone/>
-            </a:pPr>
-            <a:r>
-              <a:rPr lang="en-US" sz="1150" b="1" dirty="0">
+            <a:off x="4037076" y="2093976"/>
+            <a:ext cx="1645920" cy="411480"/>
+          </a:xfrm>
+          <a:prstGeom prst="rect">
+            <a:avLst/>
+          </a:prstGeom>
+          <a:noFill/>
+          <a:ln/>
+        </p:spPr>
+        <p:txBody>
+          <a:bodyPr wrap="square" lIns="0" tIns="0" rIns="0" bIns="0" rtlCol="0" anchor="ctr"/>
+          <a:lstStyle/>
+          <a:p>
+            <a:pPr algn="r" indent="0" marL="0">
+              <a:buNone/>
+            </a:pPr>
+            <a:r>
+              <a:rPr lang="en-US" sz="1100" b="1" dirty="0">
                 <a:solidFill>
                   <a:srgbClr val="0070F3"/>
                 </a:solidFill>
@@ -14120,9 +14120,9 @@
                 <a:ea typeface="Consolas" pitchFamily="34" charset="-122"/>
                 <a:cs typeface="Consolas" pitchFamily="34" charset="-120"/>
               </a:rPr>
-              <a:t>Next.js 15 · Tailwind v4</a:t>
-            </a:r>
-            <a:endParaRPr lang="en-US" sz="1150" dirty="0"/>
+              <a:t>Next.js · :3000</a:t>
+            </a:r>
+            <a:endParaRPr lang="en-US" sz="1100" dirty="0"/>
           </a:p>
         </p:txBody>
       </p:sp>
@@ -14134,8 +14134,8 @@
         </p:nvSpPr>
         <p:spPr>
           <a:xfrm>
-            <a:off x="932688" y="3246120"/>
-            <a:ext cx="4567428" cy="2103120"/>
+            <a:off x="886968" y="2587752"/>
+            <a:ext cx="4658868" cy="932688"/>
           </a:xfrm>
           <a:prstGeom prst="rect">
             <a:avLst/>
@@ -14147,17 +14147,17 @@
           <a:bodyPr wrap="square" lIns="0" tIns="0" rIns="0" bIns="0" rtlCol="0" anchor="t"/>
           <a:lstStyle/>
           <a:p>
-            <a:pPr marL="203200" indent="-203200">
+            <a:pPr marL="177800" indent="-177800">
               <a:spcAft>
-                <a:spcPts val="900"/>
+                <a:spcPts val="600"/>
               </a:spcAft>
               <a:buSzPct val="100000"/>
               <a:buChar char="•"/>
             </a:pPr>
             <a:r>
-              <a:rPr lang="en-US" sz="1450" dirty="0">
-                <a:solidFill>
-                  <a:srgbClr val="D2D2DA"/>
+              <a:rPr lang="en-US" sz="1300" dirty="0">
+                <a:solidFill>
+                  <a:srgbClr val="CFCFD8"/>
                 </a:solidFill>
                 <a:latin typeface="Calibri" pitchFamily="34" charset="0"/>
                 <a:ea typeface="Calibri" pitchFamily="34" charset="-122"/>
@@ -14165,70 +14165,49 @@
               </a:rPr>
               <a:t>Explorador de decisão interativo</a:t>
             </a:r>
-            <a:endParaRPr lang="en-US" sz="1450" dirty="0"/>
-          </a:p>
-          <a:p>
-            <a:pPr marL="203200" indent="-203200">
+            <a:endParaRPr lang="en-US" sz="1300" dirty="0"/>
+          </a:p>
+          <a:p>
+            <a:pPr marL="177800" indent="-177800">
               <a:spcAft>
-                <a:spcPts val="900"/>
+                <a:spcPts val="600"/>
               </a:spcAft>
               <a:buSzPct val="100000"/>
               <a:buChar char="•"/>
             </a:pPr>
             <a:r>
-              <a:rPr lang="en-US" sz="1450" dirty="0">
-                <a:solidFill>
-                  <a:srgbClr val="D2D2DA"/>
+              <a:rPr lang="en-US" sz="1300" dirty="0">
+                <a:solidFill>
+                  <a:srgbClr val="CFCFD8"/>
                 </a:solidFill>
                 <a:latin typeface="Calibri" pitchFamily="34" charset="0"/>
                 <a:ea typeface="Calibri" pitchFamily="34" charset="-122"/>
                 <a:cs typeface="Calibri" pitchFamily="34" charset="-120"/>
               </a:rPr>
-              <a:t>Catálogo de 6 ofertas elegíveis</a:t>
-            </a:r>
-            <a:endParaRPr lang="en-US" sz="1450" dirty="0"/>
-          </a:p>
-          <a:p>
-            <a:pPr marL="203200" indent="-203200">
+              <a:t>Valor = P × margem por oferta</a:t>
+            </a:r>
+            <a:endParaRPr lang="en-US" sz="1300" dirty="0"/>
+          </a:p>
+          <a:p>
+            <a:pPr marL="177800" indent="-177800">
               <a:spcAft>
-                <a:spcPts val="900"/>
+                <a:spcPts val="600"/>
               </a:spcAft>
               <a:buSzPct val="100000"/>
               <a:buChar char="•"/>
             </a:pPr>
             <a:r>
-              <a:rPr lang="en-US" sz="1450" dirty="0">
-                <a:solidFill>
-                  <a:srgbClr val="D2D2DA"/>
+              <a:rPr lang="en-US" sz="1300" dirty="0">
+                <a:solidFill>
+                  <a:srgbClr val="CFCFD8"/>
                 </a:solidFill>
                 <a:latin typeface="Calibri" pitchFamily="34" charset="0"/>
                 <a:ea typeface="Calibri" pitchFamily="34" charset="-122"/>
                 <a:cs typeface="Calibri" pitchFamily="34" charset="-120"/>
               </a:rPr>
-              <a:t>Decomposição valor = P × margem</a:t>
-            </a:r>
-            <a:endParaRPr lang="en-US" sz="1450" dirty="0"/>
-          </a:p>
-          <a:p>
-            <a:pPr marL="203200" indent="-203200">
-              <a:spcAft>
-                <a:spcPts val="900"/>
-              </a:spcAft>
-              <a:buSzPct val="100000"/>
-              <a:buChar char="•"/>
-            </a:pPr>
-            <a:r>
-              <a:rPr lang="en-US" sz="1450" dirty="0">
-                <a:solidFill>
-                  <a:srgbClr val="D2D2DA"/>
-                </a:solidFill>
-                <a:latin typeface="Calibri" pitchFamily="34" charset="0"/>
-                <a:ea typeface="Calibri" pitchFamily="34" charset="-122"/>
-                <a:cs typeface="Calibri" pitchFamily="34" charset="-120"/>
-              </a:rPr>
               <a:t>Explicação do assistente (LLM/RAG)</a:t>
             </a:r>
-            <a:endParaRPr lang="en-US" sz="1450" dirty="0"/>
+            <a:endParaRPr lang="en-US" sz="1300" dirty="0"/>
           </a:p>
         </p:txBody>
       </p:sp>
@@ -14240,12 +14219,12 @@
         </p:nvSpPr>
         <p:spPr>
           <a:xfrm>
-            <a:off x="6323076" y="1965960"/>
-            <a:ext cx="5298948" cy="3611880"/>
+            <a:off x="6323076" y="1874520"/>
+            <a:ext cx="5298948" cy="1755648"/>
           </a:xfrm>
           <a:prstGeom prst="roundRect">
             <a:avLst>
-              <a:gd name="adj" fmla="val 2278"/>
+              <a:gd name="adj" fmla="val 4688"/>
             </a:avLst>
           </a:prstGeom>
           <a:solidFill>
@@ -14274,8 +14253,225 @@
         </p:nvSpPr>
         <p:spPr>
           <a:xfrm>
-            <a:off x="6323076" y="1965960"/>
-            <a:ext cx="5298948" cy="91440"/>
+            <a:off x="6323076" y="1874520"/>
+            <a:ext cx="5298948" cy="82296"/>
+          </a:xfrm>
+          <a:prstGeom prst="rect">
+            <a:avLst/>
+          </a:prstGeom>
+          <a:solidFill>
+            <a:srgbClr val="34D399"/>
+          </a:solidFill>
+          <a:ln/>
+        </p:spPr>
+      </p:sp>
+      <p:sp>
+        <p:nvSpPr>
+          <p:cNvPr id="11" name="Text 9"/>
+          <p:cNvSpPr/>
+          <p:nvPr/>
+        </p:nvSpPr>
+        <p:spPr>
+          <a:xfrm>
+            <a:off x="6643116" y="2093976"/>
+            <a:ext cx="3332988" cy="411480"/>
+          </a:xfrm>
+          <a:prstGeom prst="rect">
+            <a:avLst/>
+          </a:prstGeom>
+          <a:noFill/>
+          <a:ln/>
+        </p:spPr>
+        <p:txBody>
+          <a:bodyPr wrap="square" lIns="0" tIns="0" rIns="0" bIns="0" rtlCol="0" anchor="ctr"/>
+          <a:lstStyle/>
+          <a:p>
+            <a:pPr indent="0" marL="0">
+              <a:buNone/>
+            </a:pPr>
+            <a:r>
+              <a:rPr lang="en-US" sz="1800" b="1" dirty="0">
+                <a:solidFill>
+                  <a:srgbClr val="EDEDED"/>
+                </a:solidFill>
+                <a:latin typeface="Trebuchet MS" pitchFamily="34" charset="0"/>
+                <a:ea typeface="Trebuchet MS" pitchFamily="34" charset="-122"/>
+                <a:cs typeface="Trebuchet MS" pitchFamily="34" charset="-120"/>
+              </a:rPr>
+              <a:t>Swagger / OpenAPI</a:t>
+            </a:r>
+            <a:endParaRPr lang="en-US" sz="1800" dirty="0"/>
+          </a:p>
+        </p:txBody>
+      </p:sp>
+      <p:sp>
+        <p:nvSpPr>
+          <p:cNvPr id="12" name="Text 10"/>
+          <p:cNvSpPr/>
+          <p:nvPr/>
+        </p:nvSpPr>
+        <p:spPr>
+          <a:xfrm>
+            <a:off x="9793224" y="2093976"/>
+            <a:ext cx="1645920" cy="411480"/>
+          </a:xfrm>
+          <a:prstGeom prst="rect">
+            <a:avLst/>
+          </a:prstGeom>
+          <a:noFill/>
+          <a:ln/>
+        </p:spPr>
+        <p:txBody>
+          <a:bodyPr wrap="square" lIns="0" tIns="0" rIns="0" bIns="0" rtlCol="0" anchor="ctr"/>
+          <a:lstStyle/>
+          <a:p>
+            <a:pPr algn="r" indent="0" marL="0">
+              <a:buNone/>
+            </a:pPr>
+            <a:r>
+              <a:rPr lang="en-US" sz="1100" b="1" dirty="0">
+                <a:solidFill>
+                  <a:srgbClr val="34D399"/>
+                </a:solidFill>
+                <a:latin typeface="Consolas" pitchFamily="34" charset="0"/>
+                <a:ea typeface="Consolas" pitchFamily="34" charset="-122"/>
+                <a:cs typeface="Consolas" pitchFamily="34" charset="-120"/>
+              </a:rPr>
+              <a:t>FastAPI · /docs</a:t>
+            </a:r>
+            <a:endParaRPr lang="en-US" sz="1100" dirty="0"/>
+          </a:p>
+        </p:txBody>
+      </p:sp>
+      <p:sp>
+        <p:nvSpPr>
+          <p:cNvPr id="13" name="Text 11"/>
+          <p:cNvSpPr/>
+          <p:nvPr/>
+        </p:nvSpPr>
+        <p:spPr>
+          <a:xfrm>
+            <a:off x="6643116" y="2587752"/>
+            <a:ext cx="4658868" cy="932688"/>
+          </a:xfrm>
+          <a:prstGeom prst="rect">
+            <a:avLst/>
+          </a:prstGeom>
+          <a:noFill/>
+          <a:ln/>
+        </p:spPr>
+        <p:txBody>
+          <a:bodyPr wrap="square" lIns="0" tIns="0" rIns="0" bIns="0" rtlCol="0" anchor="t"/>
+          <a:lstStyle/>
+          <a:p>
+            <a:pPr marL="177800" indent="-177800">
+              <a:spcAft>
+                <a:spcPts val="600"/>
+              </a:spcAft>
+              <a:buSzPct val="100000"/>
+              <a:buChar char="•"/>
+            </a:pPr>
+            <a:r>
+              <a:rPr lang="en-US" sz="1300" dirty="0">
+                <a:solidFill>
+                  <a:srgbClr val="CFCFD8"/>
+                </a:solidFill>
+                <a:latin typeface="Calibri" pitchFamily="34" charset="0"/>
+                <a:ea typeface="Calibri" pitchFamily="34" charset="-122"/>
+                <a:cs typeface="Calibri" pitchFamily="34" charset="-120"/>
+              </a:rPr>
+              <a:t>Contrato interativo da API</a:t>
+            </a:r>
+            <a:endParaRPr lang="en-US" sz="1300" dirty="0"/>
+          </a:p>
+          <a:p>
+            <a:pPr marL="177800" indent="-177800">
+              <a:spcAft>
+                <a:spcPts val="600"/>
+              </a:spcAft>
+              <a:buSzPct val="100000"/>
+              <a:buChar char="•"/>
+            </a:pPr>
+            <a:r>
+              <a:rPr lang="en-US" sz="1300" dirty="0">
+                <a:solidFill>
+                  <a:srgbClr val="CFCFD8"/>
+                </a:solidFill>
+                <a:latin typeface="Calibri" pitchFamily="34" charset="0"/>
+                <a:ea typeface="Calibri" pitchFamily="34" charset="-122"/>
+                <a:cs typeface="Calibri" pitchFamily="34" charset="-120"/>
+              </a:rPr>
+              <a:t>Testa POST /decide no navegador</a:t>
+            </a:r>
+            <a:endParaRPr lang="en-US" sz="1300" dirty="0"/>
+          </a:p>
+          <a:p>
+            <a:pPr marL="177800" indent="-177800">
+              <a:spcAft>
+                <a:spcPts val="600"/>
+              </a:spcAft>
+              <a:buSzPct val="100000"/>
+              <a:buChar char="•"/>
+            </a:pPr>
+            <a:r>
+              <a:rPr lang="en-US" sz="1300" dirty="0">
+                <a:solidFill>
+                  <a:srgbClr val="CFCFD8"/>
+                </a:solidFill>
+                <a:latin typeface="Calibri" pitchFamily="34" charset="0"/>
+                <a:ea typeface="Calibri" pitchFamily="34" charset="-122"/>
+                <a:cs typeface="Calibri" pitchFamily="34" charset="-120"/>
+              </a:rPr>
+              <a:t>Schemas, exemplos e reason codes</a:t>
+            </a:r>
+            <a:endParaRPr lang="en-US" sz="1300" dirty="0"/>
+          </a:p>
+        </p:txBody>
+      </p:sp>
+      <p:sp>
+        <p:nvSpPr>
+          <p:cNvPr id="14" name="Shape 12"/>
+          <p:cNvSpPr/>
+          <p:nvPr/>
+        </p:nvSpPr>
+        <p:spPr>
+          <a:xfrm>
+            <a:off x="566928" y="3904488"/>
+            <a:ext cx="5298948" cy="1755648"/>
+          </a:xfrm>
+          <a:prstGeom prst="roundRect">
+            <a:avLst>
+              <a:gd name="adj" fmla="val 4688"/>
+            </a:avLst>
+          </a:prstGeom>
+          <a:solidFill>
+            <a:srgbClr val="0C0C0E"/>
+          </a:solidFill>
+          <a:ln w="12700">
+            <a:solidFill>
+              <a:srgbClr val="2A2A30"/>
+            </a:solidFill>
+            <a:prstDash val="solid"/>
+          </a:ln>
+          <a:effectLst>
+            <a:outerShdw sx="100000" sy="100000" kx="0" ky="0" algn="bl" rotWithShape="0" blurRad="114300" dist="38100" dir="8100000">
+              <a:srgbClr val="000000">
+                <a:alpha val="45000"/>
+              </a:srgbClr>
+            </a:outerShdw>
+          </a:effectLst>
+        </p:spPr>
+      </p:sp>
+      <p:sp>
+        <p:nvSpPr>
+          <p:cNvPr id="15" name="Shape 13"/>
+          <p:cNvSpPr/>
+          <p:nvPr/>
+        </p:nvSpPr>
+        <p:spPr>
+          <a:xfrm>
+            <a:off x="566928" y="3904488"/>
+            <a:ext cx="5298948" cy="82296"/>
           </a:xfrm>
           <a:prstGeom prst="rect">
             <a:avLst/>
@@ -14288,14 +14484,14 @@
       </p:sp>
       <p:sp>
         <p:nvSpPr>
-          <p:cNvPr id="11" name="Text 9"/>
-          <p:cNvSpPr/>
-          <p:nvPr/>
-        </p:nvSpPr>
-        <p:spPr>
-          <a:xfrm>
-            <a:off x="6688836" y="2240280"/>
-            <a:ext cx="4567428" cy="457200"/>
+          <p:cNvPr id="16" name="Text 14"/>
+          <p:cNvSpPr/>
+          <p:nvPr/>
+        </p:nvSpPr>
+        <p:spPr>
+          <a:xfrm>
+            <a:off x="886968" y="4123944"/>
+            <a:ext cx="3332988" cy="411480"/>
           </a:xfrm>
           <a:prstGeom prst="rect">
             <a:avLst/>
@@ -14311,7 +14507,7 @@
               <a:buNone/>
             </a:pPr>
             <a:r>
-              <a:rPr lang="en-US" sz="2100" b="1" dirty="0">
+              <a:rPr lang="en-US" sz="1800" b="1" dirty="0">
                 <a:solidFill>
                   <a:srgbClr val="EDEDED"/>
                 </a:solidFill>
@@ -14321,36 +14517,36 @@
               </a:rPr>
               <a:t>Observability Board</a:t>
             </a:r>
-            <a:endParaRPr lang="en-US" sz="2100" dirty="0"/>
-          </a:p>
-        </p:txBody>
-      </p:sp>
-      <p:sp>
-        <p:nvSpPr>
-          <p:cNvPr id="12" name="Text 10"/>
-          <p:cNvSpPr/>
-          <p:nvPr/>
-        </p:nvSpPr>
-        <p:spPr>
-          <a:xfrm>
-            <a:off x="6688836" y="2724912"/>
-            <a:ext cx="4567428" cy="320040"/>
-          </a:xfrm>
-          <a:prstGeom prst="rect">
-            <a:avLst/>
-          </a:prstGeom>
-          <a:noFill/>
-          <a:ln/>
-        </p:spPr>
-        <p:txBody>
-          <a:bodyPr wrap="square" lIns="0" tIns="0" rIns="0" bIns="0" rtlCol="0" anchor="ctr"/>
-          <a:lstStyle/>
-          <a:p>
-            <a:pPr indent="0" marL="0">
-              <a:buNone/>
-            </a:pPr>
-            <a:r>
-              <a:rPr lang="en-US" sz="1150" b="1" dirty="0">
+            <a:endParaRPr lang="en-US" sz="1800" dirty="0"/>
+          </a:p>
+        </p:txBody>
+      </p:sp>
+      <p:sp>
+        <p:nvSpPr>
+          <p:cNvPr id="17" name="Text 15"/>
+          <p:cNvSpPr/>
+          <p:nvPr/>
+        </p:nvSpPr>
+        <p:spPr>
+          <a:xfrm>
+            <a:off x="4037076" y="4123944"/>
+            <a:ext cx="1645920" cy="411480"/>
+          </a:xfrm>
+          <a:prstGeom prst="rect">
+            <a:avLst/>
+          </a:prstGeom>
+          <a:noFill/>
+          <a:ln/>
+        </p:spPr>
+        <p:txBody>
+          <a:bodyPr wrap="square" lIns="0" tIns="0" rIns="0" bIns="0" rtlCol="0" anchor="ctr"/>
+          <a:lstStyle/>
+          <a:p>
+            <a:pPr algn="r" indent="0" marL="0">
+              <a:buNone/>
+            </a:pPr>
+            <a:r>
+              <a:rPr lang="en-US" sz="1100" b="1" dirty="0">
                 <a:solidFill>
                   <a:srgbClr val="3291FF"/>
                 </a:solidFill>
@@ -14358,22 +14554,22 @@
                 <a:ea typeface="Consolas" pitchFamily="34" charset="-122"/>
                 <a:cs typeface="Consolas" pitchFamily="34" charset="-120"/>
               </a:rPr>
-              <a:t>Streamlit · Plotly</a:t>
-            </a:r>
-            <a:endParaRPr lang="en-US" sz="1150" dirty="0"/>
-          </a:p>
-        </p:txBody>
-      </p:sp>
-      <p:sp>
-        <p:nvSpPr>
-          <p:cNvPr id="13" name="Text 11"/>
-          <p:cNvSpPr/>
-          <p:nvPr/>
-        </p:nvSpPr>
-        <p:spPr>
-          <a:xfrm>
-            <a:off x="6688836" y="3246120"/>
-            <a:ext cx="4567428" cy="2103120"/>
+              <a:t>Streamlit · :8510</a:t>
+            </a:r>
+            <a:endParaRPr lang="en-US" sz="1100" dirty="0"/>
+          </a:p>
+        </p:txBody>
+      </p:sp>
+      <p:sp>
+        <p:nvSpPr>
+          <p:cNvPr id="18" name="Text 16"/>
+          <p:cNvSpPr/>
+          <p:nvPr/>
+        </p:nvSpPr>
+        <p:spPr>
+          <a:xfrm>
+            <a:off x="886968" y="4617720"/>
+            <a:ext cx="4658868" cy="932688"/>
           </a:xfrm>
           <a:prstGeom prst="rect">
             <a:avLst/>
@@ -14385,220 +14581,360 @@
           <a:bodyPr wrap="square" lIns="0" tIns="0" rIns="0" bIns="0" rtlCol="0" anchor="t"/>
           <a:lstStyle/>
           <a:p>
-            <a:pPr marL="203200" indent="-203200">
+            <a:pPr marL="177800" indent="-177800">
               <a:spcAft>
-                <a:spcPts val="900"/>
+                <a:spcPts val="600"/>
               </a:spcAft>
               <a:buSzPct val="100000"/>
               <a:buChar char="•"/>
             </a:pPr>
             <a:r>
-              <a:rPr lang="en-US" sz="1450" dirty="0">
-                <a:solidFill>
-                  <a:srgbClr val="D2D2DA"/>
+              <a:rPr lang="en-US" sz="1300" dirty="0">
+                <a:solidFill>
+                  <a:srgbClr val="CFCFD8"/>
                 </a:solidFill>
                 <a:latin typeface="Calibri" pitchFamily="34" charset="0"/>
                 <a:ea typeface="Calibri" pitchFamily="34" charset="-122"/>
                 <a:cs typeface="Calibri" pitchFamily="34" charset="-120"/>
               </a:rPr>
-              <a:t>KPIs em tempo real + sparklines</a:t>
-            </a:r>
-            <a:endParaRPr lang="en-US" sz="1450" dirty="0"/>
-          </a:p>
-          <a:p>
-            <a:pPr marL="203200" indent="-203200">
+              <a:t>KPIs em tempo real + gauges</a:t>
+            </a:r>
+            <a:endParaRPr lang="en-US" sz="1300" dirty="0"/>
+          </a:p>
+          <a:p>
+            <a:pPr marL="177800" indent="-177800">
               <a:spcAft>
-                <a:spcPts val="900"/>
+                <a:spcPts val="600"/>
               </a:spcAft>
               <a:buSzPct val="100000"/>
               <a:buChar char="•"/>
             </a:pPr>
             <a:r>
-              <a:rPr lang="en-US" sz="1450" dirty="0">
-                <a:solidFill>
-                  <a:srgbClr val="D2D2DA"/>
+              <a:rPr lang="en-US" sz="1300" dirty="0">
+                <a:solidFill>
+                  <a:srgbClr val="CFCFD8"/>
                 </a:solidFill>
                 <a:latin typeface="Calibri" pitchFamily="34" charset="0"/>
                 <a:ea typeface="Calibri" pitchFamily="34" charset="-122"/>
                 <a:cs typeface="Calibri" pitchFamily="34" charset="-120"/>
               </a:rPr>
-              <a:t>Gauges: regret, exploração, lift</a:t>
-            </a:r>
-            <a:endParaRPr lang="en-US" sz="1450" dirty="0"/>
-          </a:p>
-          <a:p>
-            <a:pPr marL="203200" indent="-203200">
+              <a:t>Comparação entre políticas</a:t>
+            </a:r>
+            <a:endParaRPr lang="en-US" sz="1300" dirty="0"/>
+          </a:p>
+          <a:p>
+            <a:pPr marL="177800" indent="-177800">
               <a:spcAft>
-                <a:spcPts val="900"/>
+                <a:spcPts val="600"/>
               </a:spcAft>
               <a:buSzPct val="100000"/>
               <a:buChar char="•"/>
             </a:pPr>
             <a:r>
-              <a:rPr lang="en-US" sz="1450" dirty="0">
-                <a:solidFill>
-                  <a:srgbClr val="D2D2DA"/>
+              <a:rPr lang="en-US" sz="1300" dirty="0">
+                <a:solidFill>
+                  <a:srgbClr val="CFCFD8"/>
                 </a:solidFill>
                 <a:latin typeface="Calibri" pitchFamily="34" charset="0"/>
                 <a:ea typeface="Calibri" pitchFamily="34" charset="-122"/>
                 <a:cs typeface="Calibri" pitchFamily="34" charset="-120"/>
               </a:rPr>
-              <a:t>Comparação entre políticas</a:t>
-            </a:r>
-            <a:endParaRPr lang="en-US" sz="1450" dirty="0"/>
-          </a:p>
-          <a:p>
-            <a:pPr marL="203200" indent="-203200">
+              <a:t>Feed de decisões auditáveis</a:t>
+            </a:r>
+            <a:endParaRPr lang="en-US" sz="1300" dirty="0"/>
+          </a:p>
+        </p:txBody>
+      </p:sp>
+      <p:sp>
+        <p:nvSpPr>
+          <p:cNvPr id="19" name="Shape 17"/>
+          <p:cNvSpPr/>
+          <p:nvPr/>
+        </p:nvSpPr>
+        <p:spPr>
+          <a:xfrm>
+            <a:off x="6323076" y="3904488"/>
+            <a:ext cx="5298948" cy="1755648"/>
+          </a:xfrm>
+          <a:prstGeom prst="roundRect">
+            <a:avLst>
+              <a:gd name="adj" fmla="val 4688"/>
+            </a:avLst>
+          </a:prstGeom>
+          <a:solidFill>
+            <a:srgbClr val="0C0C0E"/>
+          </a:solidFill>
+          <a:ln w="12700">
+            <a:solidFill>
+              <a:srgbClr val="2A2A30"/>
+            </a:solidFill>
+            <a:prstDash val="solid"/>
+          </a:ln>
+          <a:effectLst>
+            <a:outerShdw sx="100000" sy="100000" kx="0" ky="0" algn="bl" rotWithShape="0" blurRad="114300" dist="38100" dir="8100000">
+              <a:srgbClr val="000000">
+                <a:alpha val="45000"/>
+              </a:srgbClr>
+            </a:outerShdw>
+          </a:effectLst>
+        </p:spPr>
+      </p:sp>
+      <p:sp>
+        <p:nvSpPr>
+          <p:cNvPr id="20" name="Shape 18"/>
+          <p:cNvSpPr/>
+          <p:nvPr/>
+        </p:nvSpPr>
+        <p:spPr>
+          <a:xfrm>
+            <a:off x="6323076" y="3904488"/>
+            <a:ext cx="5298948" cy="82296"/>
+          </a:xfrm>
+          <a:prstGeom prst="rect">
+            <a:avLst/>
+          </a:prstGeom>
+          <a:solidFill>
+            <a:srgbClr val="F5A623"/>
+          </a:solidFill>
+          <a:ln/>
+        </p:spPr>
+      </p:sp>
+      <p:sp>
+        <p:nvSpPr>
+          <p:cNvPr id="21" name="Text 19"/>
+          <p:cNvSpPr/>
+          <p:nvPr/>
+        </p:nvSpPr>
+        <p:spPr>
+          <a:xfrm>
+            <a:off x="6643116" y="4123944"/>
+            <a:ext cx="3332988" cy="411480"/>
+          </a:xfrm>
+          <a:prstGeom prst="rect">
+            <a:avLst/>
+          </a:prstGeom>
+          <a:noFill/>
+          <a:ln/>
+        </p:spPr>
+        <p:txBody>
+          <a:bodyPr wrap="square" lIns="0" tIns="0" rIns="0" bIns="0" rtlCol="0" anchor="ctr"/>
+          <a:lstStyle/>
+          <a:p>
+            <a:pPr indent="0" marL="0">
+              <a:buNone/>
+            </a:pPr>
+            <a:r>
+              <a:rPr lang="en-US" sz="1800" b="1" dirty="0">
+                <a:solidFill>
+                  <a:srgbClr val="EDEDED"/>
+                </a:solidFill>
+                <a:latin typeface="Trebuchet MS" pitchFamily="34" charset="0"/>
+                <a:ea typeface="Trebuchet MS" pitchFamily="34" charset="-122"/>
+                <a:cs typeface="Trebuchet MS" pitchFamily="34" charset="-120"/>
+              </a:rPr>
+              <a:t>MLflow Tracking</a:t>
+            </a:r>
+            <a:endParaRPr lang="en-US" sz="1800" dirty="0"/>
+          </a:p>
+        </p:txBody>
+      </p:sp>
+      <p:sp>
+        <p:nvSpPr>
+          <p:cNvPr id="22" name="Text 20"/>
+          <p:cNvSpPr/>
+          <p:nvPr/>
+        </p:nvSpPr>
+        <p:spPr>
+          <a:xfrm>
+            <a:off x="9793224" y="4123944"/>
+            <a:ext cx="1645920" cy="411480"/>
+          </a:xfrm>
+          <a:prstGeom prst="rect">
+            <a:avLst/>
+          </a:prstGeom>
+          <a:noFill/>
+          <a:ln/>
+        </p:spPr>
+        <p:txBody>
+          <a:bodyPr wrap="square" lIns="0" tIns="0" rIns="0" bIns="0" rtlCol="0" anchor="ctr"/>
+          <a:lstStyle/>
+          <a:p>
+            <a:pPr algn="r" indent="0" marL="0">
+              <a:buNone/>
+            </a:pPr>
+            <a:r>
+              <a:rPr lang="en-US" sz="1100" b="1" dirty="0">
+                <a:solidFill>
+                  <a:srgbClr val="F5A623"/>
+                </a:solidFill>
+                <a:latin typeface="Consolas" pitchFamily="34" charset="0"/>
+                <a:ea typeface="Consolas" pitchFamily="34" charset="-122"/>
+                <a:cs typeface="Consolas" pitchFamily="34" charset="-120"/>
+              </a:rPr>
+              <a:t>mlflow ui · :5000</a:t>
+            </a:r>
+            <a:endParaRPr lang="en-US" sz="1100" dirty="0"/>
+          </a:p>
+        </p:txBody>
+      </p:sp>
+      <p:sp>
+        <p:nvSpPr>
+          <p:cNvPr id="23" name="Text 21"/>
+          <p:cNvSpPr/>
+          <p:nvPr/>
+        </p:nvSpPr>
+        <p:spPr>
+          <a:xfrm>
+            <a:off x="6643116" y="4617720"/>
+            <a:ext cx="4658868" cy="932688"/>
+          </a:xfrm>
+          <a:prstGeom prst="rect">
+            <a:avLst/>
+          </a:prstGeom>
+          <a:noFill/>
+          <a:ln/>
+        </p:spPr>
+        <p:txBody>
+          <a:bodyPr wrap="square" lIns="0" tIns="0" rIns="0" bIns="0" rtlCol="0" anchor="t"/>
+          <a:lstStyle/>
+          <a:p>
+            <a:pPr marL="177800" indent="-177800">
               <a:spcAft>
-                <a:spcPts val="900"/>
+                <a:spcPts val="600"/>
               </a:spcAft>
               <a:buSzPct val="100000"/>
               <a:buChar char="•"/>
             </a:pPr>
             <a:r>
-              <a:rPr lang="en-US" sz="1450" dirty="0">
-                <a:solidFill>
-                  <a:srgbClr val="D2D2DA"/>
+              <a:rPr lang="en-US" sz="1300" dirty="0">
+                <a:solidFill>
+                  <a:srgbClr val="CFCFD8"/>
                 </a:solidFill>
                 <a:latin typeface="Calibri" pitchFamily="34" charset="0"/>
                 <a:ea typeface="Calibri" pitchFamily="34" charset="-122"/>
                 <a:cs typeface="Calibri" pitchFamily="34" charset="-120"/>
               </a:rPr>
-              <a:t>Feed de decisões auditáveis</a:t>
-            </a:r>
-            <a:endParaRPr lang="en-US" sz="1450" dirty="0"/>
-          </a:p>
-        </p:txBody>
-      </p:sp>
-      <p:sp>
-        <p:nvSpPr>
-          <p:cNvPr id="14" name="Text 12"/>
-          <p:cNvSpPr/>
-          <p:nvPr/>
-        </p:nvSpPr>
-        <p:spPr>
-          <a:xfrm>
-            <a:off x="566928" y="5806440"/>
-            <a:ext cx="11055096" cy="411480"/>
-          </a:xfrm>
-          <a:prstGeom prst="rect">
-            <a:avLst/>
-          </a:prstGeom>
-          <a:noFill/>
-          <a:ln/>
-        </p:spPr>
-        <p:txBody>
-          <a:bodyPr wrap="square" lIns="0" tIns="0" rIns="0" bIns="0" rtlCol="0" anchor="ctr"/>
-          <a:lstStyle/>
-          <a:p>
-            <a:pPr indent="0" marL="0">
-              <a:buNone/>
-            </a:pPr>
-            <a:r>
-              <a:rPr lang="en-US" sz="1200" dirty="0">
-                <a:solidFill>
-                  <a:srgbClr val="9A9AA6"/>
+              <a:t>Runs com params + métricas</a:t>
+            </a:r>
+            <a:endParaRPr lang="en-US" sz="1300" dirty="0"/>
+          </a:p>
+          <a:p>
+            <a:pPr marL="177800" indent="-177800">
+              <a:spcAft>
+                <a:spcPts val="600"/>
+              </a:spcAft>
+              <a:buSzPct val="100000"/>
+              <a:buChar char="•"/>
+            </a:pPr>
+            <a:r>
+              <a:rPr lang="en-US" sz="1300" dirty="0">
+                <a:solidFill>
+                  <a:srgbClr val="CFCFD8"/>
+                </a:solidFill>
+                <a:latin typeface="Calibri" pitchFamily="34" charset="0"/>
+                <a:ea typeface="Calibri" pitchFamily="34" charset="-122"/>
+                <a:cs typeface="Calibri" pitchFamily="34" charset="-120"/>
+              </a:rPr>
+              <a:t>Comparação de experimentos</a:t>
+            </a:r>
+            <a:endParaRPr lang="en-US" sz="1300" dirty="0"/>
+          </a:p>
+          <a:p>
+            <a:pPr marL="177800" indent="-177800">
+              <a:spcAft>
+                <a:spcPts val="600"/>
+              </a:spcAft>
+              <a:buSzPct val="100000"/>
+              <a:buChar char="•"/>
+            </a:pPr>
+            <a:r>
+              <a:rPr lang="en-US" sz="1300" dirty="0">
+                <a:solidFill>
+                  <a:srgbClr val="CFCFD8"/>
+                </a:solidFill>
+                <a:latin typeface="Calibri" pitchFamily="34" charset="0"/>
+                <a:ea typeface="Calibri" pitchFamily="34" charset="-122"/>
+                <a:cs typeface="Calibri" pitchFamily="34" charset="-120"/>
+              </a:rPr>
+              <a:t>Versões de política (registry)</a:t>
+            </a:r>
+            <a:endParaRPr lang="en-US" sz="1300" dirty="0"/>
+          </a:p>
+        </p:txBody>
+      </p:sp>
+      <p:sp>
+        <p:nvSpPr>
+          <p:cNvPr id="24" name="Text 22"/>
+          <p:cNvSpPr/>
+          <p:nvPr/>
+        </p:nvSpPr>
+        <p:spPr>
+          <a:xfrm>
+            <a:off x="566928" y="6437376"/>
+            <a:ext cx="4572000" cy="274320"/>
+          </a:xfrm>
+          <a:prstGeom prst="rect">
+            <a:avLst/>
+          </a:prstGeom>
+          <a:noFill/>
+          <a:ln/>
+        </p:spPr>
+        <p:txBody>
+          <a:bodyPr wrap="square" lIns="0" tIns="0" rIns="0" bIns="0" rtlCol="0" anchor="ctr"/>
+          <a:lstStyle/>
+          <a:p>
+            <a:pPr algn="l" indent="0" marL="0">
+              <a:buNone/>
+            </a:pPr>
+            <a:r>
+              <a:rPr lang="en-US" sz="850" spc="200" kern="0" dirty="0">
+                <a:solidFill>
+                  <a:srgbClr val="5A5A63"/>
                 </a:solidFill>
                 <a:latin typeface="Consolas" pitchFamily="34" charset="0"/>
                 <a:ea typeface="Consolas" pitchFamily="34" charset="-122"/>
                 <a:cs typeface="Consolas" pitchFamily="34" charset="-120"/>
               </a:rPr>
-              <a:t>CLI:  </a:t>
-            </a:r>
-            <a:pPr indent="0" marL="0">
-              <a:buNone/>
-            </a:pPr>
-            <a:r>
-              <a:rPr lang="en-US" sz="1200" b="1" dirty="0">
-                <a:solidFill>
-                  <a:srgbClr val="3291FF"/>
+              <a:t>ADAPTIVE OFFERS PLATFORM</a:t>
+            </a:r>
+            <a:endParaRPr lang="en-US" sz="850" dirty="0"/>
+          </a:p>
+        </p:txBody>
+      </p:sp>
+      <p:sp>
+        <p:nvSpPr>
+          <p:cNvPr id="25" name="Text 23"/>
+          <p:cNvSpPr/>
+          <p:nvPr/>
+        </p:nvSpPr>
+        <p:spPr>
+          <a:xfrm>
+            <a:off x="7050024" y="6437376"/>
+            <a:ext cx="4572000" cy="274320"/>
+          </a:xfrm>
+          <a:prstGeom prst="rect">
+            <a:avLst/>
+          </a:prstGeom>
+          <a:noFill/>
+          <a:ln/>
+        </p:spPr>
+        <p:txBody>
+          <a:bodyPr wrap="square" lIns="0" tIns="0" rIns="0" bIns="0" rtlCol="0" anchor="ctr"/>
+          <a:lstStyle/>
+          <a:p>
+            <a:pPr algn="r" indent="0" marL="0">
+              <a:buNone/>
+            </a:pPr>
+            <a:r>
+              <a:rPr lang="en-US" sz="850" spc="200" kern="0" dirty="0">
+                <a:solidFill>
+                  <a:srgbClr val="5A5A63"/>
                 </a:solidFill>
                 <a:latin typeface="Consolas" pitchFamily="34" charset="0"/>
                 <a:ea typeface="Consolas" pitchFamily="34" charset="-122"/>
                 <a:cs typeface="Consolas" pitchFamily="34" charset="-120"/>
               </a:rPr>
-              <a:t>adaptive-offers pipeline</a:t>
-            </a:r>
-            <a:pPr indent="0" marL="0">
-              <a:buNone/>
-            </a:pPr>
-            <a:r>
-              <a:rPr lang="en-US" sz="1200" dirty="0">
-                <a:solidFill>
-                  <a:srgbClr val="9A9AA6"/>
-                </a:solidFill>
-                <a:latin typeface="Consolas" pitchFamily="34" charset="0"/>
-                <a:ea typeface="Consolas" pitchFamily="34" charset="-122"/>
-                <a:cs typeface="Consolas" pitchFamily="34" charset="-120"/>
-              </a:rPr>
-              <a:t>  →  dados · synth · treino · avaliação · serve   |   </a:t>
-            </a:r>
-            <a:pPr indent="0" marL="0">
-              <a:buNone/>
-            </a:pPr>
-            <a:r>
-              <a:rPr lang="en-US" sz="1200" b="1" dirty="0">
-                <a:solidFill>
-                  <a:srgbClr val="34D399"/>
-                </a:solidFill>
-                <a:latin typeface="Consolas" pitchFamily="34" charset="0"/>
-                <a:ea typeface="Consolas" pitchFamily="34" charset="-122"/>
-                <a:cs typeface="Consolas" pitchFamily="34" charset="-120"/>
-              </a:rPr>
-              <a:t>POST /decide</a:t>
-            </a:r>
-            <a:pPr indent="0" marL="0">
-              <a:buNone/>
-            </a:pPr>
-            <a:r>
-              <a:rPr lang="en-US" sz="1200" dirty="0">
-                <a:solidFill>
-                  <a:srgbClr val="9A9AA6"/>
-                </a:solidFill>
-                <a:latin typeface="Consolas" pitchFamily="34" charset="0"/>
-                <a:ea typeface="Consolas" pitchFamily="34" charset="-122"/>
-                <a:cs typeface="Consolas" pitchFamily="34" charset="-120"/>
-              </a:rPr>
-              <a:t>  retorna oferta + reason codes</a:t>
-            </a:r>
-            <a:endParaRPr lang="en-US" sz="1200" dirty="0"/>
-          </a:p>
-        </p:txBody>
-      </p:sp>
-      <p:sp>
-        <p:nvSpPr>
-          <p:cNvPr id="15" name="Text 13"/>
-          <p:cNvSpPr/>
-          <p:nvPr/>
-        </p:nvSpPr>
-        <p:spPr>
-          <a:xfrm>
-            <a:off x="566928" y="6437376"/>
-            <a:ext cx="4572000" cy="274320"/>
-          </a:xfrm>
-          <a:prstGeom prst="rect">
-            <a:avLst/>
-          </a:prstGeom>
-          <a:noFill/>
-          <a:ln/>
-        </p:spPr>
-        <p:txBody>
-          <a:bodyPr wrap="square" lIns="0" tIns="0" rIns="0" bIns="0" rtlCol="0" anchor="ctr"/>
-          <a:lstStyle/>
-          <a:p>
-            <a:pPr algn="l" indent="0" marL="0">
-              <a:buNone/>
-            </a:pPr>
-            <a:r>
-              <a:rPr lang="en-US" sz="850" spc="200" kern="0" dirty="0">
-                <a:solidFill>
-                  <a:srgbClr val="5A5A63"/>
-                </a:solidFill>
-                <a:latin typeface="Consolas" pitchFamily="34" charset="0"/>
-                <a:ea typeface="Consolas" pitchFamily="34" charset="-122"/>
-                <a:cs typeface="Consolas" pitchFamily="34" charset="-120"/>
-              </a:rPr>
-              <a:t>ADAPTIVE OFFERS PLATFORM</a:t>
+              <a:t>GRUPO 64 · FIAP PÓS-TECH 7MLET</a:t>
             </a:r>
             <a:endParaRPr lang="en-US" sz="850" dirty="0"/>
           </a:p>
@@ -14606,46 +14942,7 @@
       </p:sp>
       <p:sp>
         <p:nvSpPr>
-          <p:cNvPr id="16" name="Text 14"/>
-          <p:cNvSpPr/>
-          <p:nvPr/>
-        </p:nvSpPr>
-        <p:spPr>
-          <a:xfrm>
-            <a:off x="7050024" y="6437376"/>
-            <a:ext cx="4572000" cy="274320"/>
-          </a:xfrm>
-          <a:prstGeom prst="rect">
-            <a:avLst/>
-          </a:prstGeom>
-          <a:noFill/>
-          <a:ln/>
-        </p:spPr>
-        <p:txBody>
-          <a:bodyPr wrap="square" lIns="0" tIns="0" rIns="0" bIns="0" rtlCol="0" anchor="ctr"/>
-          <a:lstStyle/>
-          <a:p>
-            <a:pPr algn="r" indent="0" marL="0">
-              <a:buNone/>
-            </a:pPr>
-            <a:r>
-              <a:rPr lang="en-US" sz="850" spc="200" kern="0" dirty="0">
-                <a:solidFill>
-                  <a:srgbClr val="5A5A63"/>
-                </a:solidFill>
-                <a:latin typeface="Consolas" pitchFamily="34" charset="0"/>
-                <a:ea typeface="Consolas" pitchFamily="34" charset="-122"/>
-                <a:cs typeface="Consolas" pitchFamily="34" charset="-120"/>
-              </a:rPr>
-              <a:t>GRUPO 64 · FIAP PÓS-TECH 7MLET</a:t>
-            </a:r>
-            <a:endParaRPr lang="en-US" sz="850" dirty="0"/>
-          </a:p>
-        </p:txBody>
-      </p:sp>
-      <p:sp>
-        <p:nvSpPr>
-          <p:cNvPr id="17" name="Text 15"/>
+          <p:cNvPr id="26" name="Text 24"/>
           <p:cNvSpPr/>
           <p:nvPr/>
         </p:nvSpPr>

</xml_diff>

<commit_message>
docs(pitch): add technical appendix — math + real code per algorithm (19 slides)
Five appendix slides (14–18) with rendered equations (matplotlib mathtext) and
syntax-highlighted real code (Pygments) for: the on-real-data training loop
(reward = margin × conversion, regret vs oracle, delayed rewards), Baseline,
Thompson Sampling (Beta-Bernoulli), Nilos-UCB (UCB-V) and LinUCB — each with its
academic reference (Thompson 1933; Agrawal & Goyal 2012; Audibert et al. 2009;
Li et al. 2010) and source path.

Co-Authored-By: Claude Opus 4.8 <noreply@anthropic.com>
</commit_message>
<xml_diff>
--- a/docs/Adaptive-Offers-Pitch-Grupo64.pptx
+++ b/docs/Adaptive-Offers-Pitch-Grupo64.pptx
@@ -19,9 +19,14 @@
     <p:sldId id="267" r:id="rId13"/>
     <p:sldId id="268" r:id="rId14"/>
     <p:sldId id="269" r:id="rId15"/>
+    <p:sldId id="270" r:id="rId16"/>
+    <p:sldId id="271" r:id="rId17"/>
+    <p:sldId id="272" r:id="rId18"/>
+    <p:sldId id="273" r:id="rId19"/>
+    <p:sldId id="274" r:id="rId20"/>
   </p:sldIdLst>
   <p:notesMasterIdLst>
-    <p:notesMasterId r:id="rId16"/>
+    <p:notesMasterId r:id="rId21"/>
   </p:notesMasterIdLst>
   <p:sldSz cx="12192000" cy="6858000"/>
   <p:notesSz cx="6858000" cy="12192000"/>
@@ -979,6 +984,446 @@
             <a:fld id="{F7021451-1387-4CA6-816F-3879F97B5CBC}" type="slidenum">
               <a:rPr lang="en-US"/>
               <a:t>14</a:t>
+            </a:fld>
+            <a:endParaRPr lang="en-US"/>
+          </a:p>
+        </p:txBody>
+      </p:sp>
+    </p:spTree>
+    <p:extLst>
+      <p:ext uri="{BB962C8B-B14F-4D97-AF65-F5344CB8AC3E}">
+        <p14:creationId xmlns:p14="http://schemas.microsoft.com/office/powerpoint/2010/main" val="1024086991"/>
+      </p:ext>
+    </p:extLst>
+  </p:cSld>
+  <p:clrMapOvr>
+    <a:masterClrMapping/>
+  </p:clrMapOvr>
+</p:notes>
+</file>
+
+<file path=ppt/notesSlides/notesSlide15.xml><?xml version="1.0" encoding="utf-8"?>
+<p:notes xmlns:a="http://schemas.openxmlformats.org/drawingml/2006/main" xmlns:r="http://schemas.openxmlformats.org/officeDocument/2006/relationships" xmlns:p="http://schemas.openxmlformats.org/presentationml/2006/main">
+  <p:cSld>
+    <p:spTree>
+      <p:nvGrpSpPr>
+        <p:cNvPr id="1" name=""/>
+        <p:cNvGrpSpPr/>
+        <p:nvPr/>
+      </p:nvGrpSpPr>
+      <p:grpSpPr>
+        <a:xfrm>
+          <a:off x="0" y="0"/>
+          <a:ext cx="0" cy="0"/>
+          <a:chOff x="0" y="0"/>
+          <a:chExt cx="0" cy="0"/>
+        </a:xfrm>
+      </p:grpSpPr>
+      <p:sp>
+        <p:nvSpPr>
+          <p:cNvPr id="2" name="Slide Image Placeholder 1"/>
+          <p:cNvSpPr>
+            <a:spLocks noGrp="1" noRot="1" noChangeAspect="1"/>
+          </p:cNvSpPr>
+          <p:nvPr>
+            <p:ph type="sldImg"/>
+          </p:nvPr>
+        </p:nvSpPr>
+        <p:spPr/>
+      </p:sp>
+      <p:sp>
+        <p:nvSpPr>
+          <p:cNvPr id="3" name="Notes Placeholder 2"/>
+          <p:cNvSpPr>
+            <a:spLocks noGrp="1"/>
+          </p:cNvSpPr>
+          <p:nvPr>
+            <p:ph type="body" idx="1"/>
+          </p:nvPr>
+        </p:nvSpPr>
+        <p:spPr/>
+        <p:txBody>
+          <a:bodyPr/>
+          <a:lstStyle/>
+          <a:p>
+            <a:r>
+              <a:rPr lang="en-US" dirty="0"/>
+              <a:t/>
+            </a:r>
+            <a:endParaRPr lang="en-US" dirty="0"/>
+          </a:p>
+        </p:txBody>
+      </p:sp>
+      <p:sp>
+        <p:nvSpPr>
+          <p:cNvPr id="4" name="Slide Number Placeholder 3"/>
+          <p:cNvSpPr>
+            <a:spLocks noGrp="1"/>
+          </p:cNvSpPr>
+          <p:nvPr>
+            <p:ph type="sldNum" sz="quarter" idx="10"/>
+          </p:nvPr>
+        </p:nvSpPr>
+        <p:spPr/>
+        <p:txBody>
+          <a:bodyPr/>
+          <a:lstStyle/>
+          <a:p>
+            <a:fld id="{F7021451-1387-4CA6-816F-3879F97B5CBC}" type="slidenum">
+              <a:rPr lang="en-US"/>
+              <a:t>15</a:t>
+            </a:fld>
+            <a:endParaRPr lang="en-US"/>
+          </a:p>
+        </p:txBody>
+      </p:sp>
+    </p:spTree>
+    <p:extLst>
+      <p:ext uri="{BB962C8B-B14F-4D97-AF65-F5344CB8AC3E}">
+        <p14:creationId xmlns:p14="http://schemas.microsoft.com/office/powerpoint/2010/main" val="1024086991"/>
+      </p:ext>
+    </p:extLst>
+  </p:cSld>
+  <p:clrMapOvr>
+    <a:masterClrMapping/>
+  </p:clrMapOvr>
+</p:notes>
+</file>
+
+<file path=ppt/notesSlides/notesSlide16.xml><?xml version="1.0" encoding="utf-8"?>
+<p:notes xmlns:a="http://schemas.openxmlformats.org/drawingml/2006/main" xmlns:r="http://schemas.openxmlformats.org/officeDocument/2006/relationships" xmlns:p="http://schemas.openxmlformats.org/presentationml/2006/main">
+  <p:cSld>
+    <p:spTree>
+      <p:nvGrpSpPr>
+        <p:cNvPr id="1" name=""/>
+        <p:cNvGrpSpPr/>
+        <p:nvPr/>
+      </p:nvGrpSpPr>
+      <p:grpSpPr>
+        <a:xfrm>
+          <a:off x="0" y="0"/>
+          <a:ext cx="0" cy="0"/>
+          <a:chOff x="0" y="0"/>
+          <a:chExt cx="0" cy="0"/>
+        </a:xfrm>
+      </p:grpSpPr>
+      <p:sp>
+        <p:nvSpPr>
+          <p:cNvPr id="2" name="Slide Image Placeholder 1"/>
+          <p:cNvSpPr>
+            <a:spLocks noGrp="1" noRot="1" noChangeAspect="1"/>
+          </p:cNvSpPr>
+          <p:nvPr>
+            <p:ph type="sldImg"/>
+          </p:nvPr>
+        </p:nvSpPr>
+        <p:spPr/>
+      </p:sp>
+      <p:sp>
+        <p:nvSpPr>
+          <p:cNvPr id="3" name="Notes Placeholder 2"/>
+          <p:cNvSpPr>
+            <a:spLocks noGrp="1"/>
+          </p:cNvSpPr>
+          <p:nvPr>
+            <p:ph type="body" idx="1"/>
+          </p:nvPr>
+        </p:nvSpPr>
+        <p:spPr/>
+        <p:txBody>
+          <a:bodyPr/>
+          <a:lstStyle/>
+          <a:p>
+            <a:r>
+              <a:rPr lang="en-US" dirty="0"/>
+              <a:t/>
+            </a:r>
+            <a:endParaRPr lang="en-US" dirty="0"/>
+          </a:p>
+        </p:txBody>
+      </p:sp>
+      <p:sp>
+        <p:nvSpPr>
+          <p:cNvPr id="4" name="Slide Number Placeholder 3"/>
+          <p:cNvSpPr>
+            <a:spLocks noGrp="1"/>
+          </p:cNvSpPr>
+          <p:nvPr>
+            <p:ph type="sldNum" sz="quarter" idx="10"/>
+          </p:nvPr>
+        </p:nvSpPr>
+        <p:spPr/>
+        <p:txBody>
+          <a:bodyPr/>
+          <a:lstStyle/>
+          <a:p>
+            <a:fld id="{F7021451-1387-4CA6-816F-3879F97B5CBC}" type="slidenum">
+              <a:rPr lang="en-US"/>
+              <a:t>16</a:t>
+            </a:fld>
+            <a:endParaRPr lang="en-US"/>
+          </a:p>
+        </p:txBody>
+      </p:sp>
+    </p:spTree>
+    <p:extLst>
+      <p:ext uri="{BB962C8B-B14F-4D97-AF65-F5344CB8AC3E}">
+        <p14:creationId xmlns:p14="http://schemas.microsoft.com/office/powerpoint/2010/main" val="1024086991"/>
+      </p:ext>
+    </p:extLst>
+  </p:cSld>
+  <p:clrMapOvr>
+    <a:masterClrMapping/>
+  </p:clrMapOvr>
+</p:notes>
+</file>
+
+<file path=ppt/notesSlides/notesSlide17.xml><?xml version="1.0" encoding="utf-8"?>
+<p:notes xmlns:a="http://schemas.openxmlformats.org/drawingml/2006/main" xmlns:r="http://schemas.openxmlformats.org/officeDocument/2006/relationships" xmlns:p="http://schemas.openxmlformats.org/presentationml/2006/main">
+  <p:cSld>
+    <p:spTree>
+      <p:nvGrpSpPr>
+        <p:cNvPr id="1" name=""/>
+        <p:cNvGrpSpPr/>
+        <p:nvPr/>
+      </p:nvGrpSpPr>
+      <p:grpSpPr>
+        <a:xfrm>
+          <a:off x="0" y="0"/>
+          <a:ext cx="0" cy="0"/>
+          <a:chOff x="0" y="0"/>
+          <a:chExt cx="0" cy="0"/>
+        </a:xfrm>
+      </p:grpSpPr>
+      <p:sp>
+        <p:nvSpPr>
+          <p:cNvPr id="2" name="Slide Image Placeholder 1"/>
+          <p:cNvSpPr>
+            <a:spLocks noGrp="1" noRot="1" noChangeAspect="1"/>
+          </p:cNvSpPr>
+          <p:nvPr>
+            <p:ph type="sldImg"/>
+          </p:nvPr>
+        </p:nvSpPr>
+        <p:spPr/>
+      </p:sp>
+      <p:sp>
+        <p:nvSpPr>
+          <p:cNvPr id="3" name="Notes Placeholder 2"/>
+          <p:cNvSpPr>
+            <a:spLocks noGrp="1"/>
+          </p:cNvSpPr>
+          <p:nvPr>
+            <p:ph type="body" idx="1"/>
+          </p:nvPr>
+        </p:nvSpPr>
+        <p:spPr/>
+        <p:txBody>
+          <a:bodyPr/>
+          <a:lstStyle/>
+          <a:p>
+            <a:r>
+              <a:rPr lang="en-US" dirty="0"/>
+              <a:t/>
+            </a:r>
+            <a:endParaRPr lang="en-US" dirty="0"/>
+          </a:p>
+        </p:txBody>
+      </p:sp>
+      <p:sp>
+        <p:nvSpPr>
+          <p:cNvPr id="4" name="Slide Number Placeholder 3"/>
+          <p:cNvSpPr>
+            <a:spLocks noGrp="1"/>
+          </p:cNvSpPr>
+          <p:nvPr>
+            <p:ph type="sldNum" sz="quarter" idx="10"/>
+          </p:nvPr>
+        </p:nvSpPr>
+        <p:spPr/>
+        <p:txBody>
+          <a:bodyPr/>
+          <a:lstStyle/>
+          <a:p>
+            <a:fld id="{F7021451-1387-4CA6-816F-3879F97B5CBC}" type="slidenum">
+              <a:rPr lang="en-US"/>
+              <a:t>17</a:t>
+            </a:fld>
+            <a:endParaRPr lang="en-US"/>
+          </a:p>
+        </p:txBody>
+      </p:sp>
+    </p:spTree>
+    <p:extLst>
+      <p:ext uri="{BB962C8B-B14F-4D97-AF65-F5344CB8AC3E}">
+        <p14:creationId xmlns:p14="http://schemas.microsoft.com/office/powerpoint/2010/main" val="1024086991"/>
+      </p:ext>
+    </p:extLst>
+  </p:cSld>
+  <p:clrMapOvr>
+    <a:masterClrMapping/>
+  </p:clrMapOvr>
+</p:notes>
+</file>
+
+<file path=ppt/notesSlides/notesSlide18.xml><?xml version="1.0" encoding="utf-8"?>
+<p:notes xmlns:a="http://schemas.openxmlformats.org/drawingml/2006/main" xmlns:r="http://schemas.openxmlformats.org/officeDocument/2006/relationships" xmlns:p="http://schemas.openxmlformats.org/presentationml/2006/main">
+  <p:cSld>
+    <p:spTree>
+      <p:nvGrpSpPr>
+        <p:cNvPr id="1" name=""/>
+        <p:cNvGrpSpPr/>
+        <p:nvPr/>
+      </p:nvGrpSpPr>
+      <p:grpSpPr>
+        <a:xfrm>
+          <a:off x="0" y="0"/>
+          <a:ext cx="0" cy="0"/>
+          <a:chOff x="0" y="0"/>
+          <a:chExt cx="0" cy="0"/>
+        </a:xfrm>
+      </p:grpSpPr>
+      <p:sp>
+        <p:nvSpPr>
+          <p:cNvPr id="2" name="Slide Image Placeholder 1"/>
+          <p:cNvSpPr>
+            <a:spLocks noGrp="1" noRot="1" noChangeAspect="1"/>
+          </p:cNvSpPr>
+          <p:nvPr>
+            <p:ph type="sldImg"/>
+          </p:nvPr>
+        </p:nvSpPr>
+        <p:spPr/>
+      </p:sp>
+      <p:sp>
+        <p:nvSpPr>
+          <p:cNvPr id="3" name="Notes Placeholder 2"/>
+          <p:cNvSpPr>
+            <a:spLocks noGrp="1"/>
+          </p:cNvSpPr>
+          <p:nvPr>
+            <p:ph type="body" idx="1"/>
+          </p:nvPr>
+        </p:nvSpPr>
+        <p:spPr/>
+        <p:txBody>
+          <a:bodyPr/>
+          <a:lstStyle/>
+          <a:p>
+            <a:r>
+              <a:rPr lang="en-US" dirty="0"/>
+              <a:t/>
+            </a:r>
+            <a:endParaRPr lang="en-US" dirty="0"/>
+          </a:p>
+        </p:txBody>
+      </p:sp>
+      <p:sp>
+        <p:nvSpPr>
+          <p:cNvPr id="4" name="Slide Number Placeholder 3"/>
+          <p:cNvSpPr>
+            <a:spLocks noGrp="1"/>
+          </p:cNvSpPr>
+          <p:nvPr>
+            <p:ph type="sldNum" sz="quarter" idx="10"/>
+          </p:nvPr>
+        </p:nvSpPr>
+        <p:spPr/>
+        <p:txBody>
+          <a:bodyPr/>
+          <a:lstStyle/>
+          <a:p>
+            <a:fld id="{F7021451-1387-4CA6-816F-3879F97B5CBC}" type="slidenum">
+              <a:rPr lang="en-US"/>
+              <a:t>18</a:t>
+            </a:fld>
+            <a:endParaRPr lang="en-US"/>
+          </a:p>
+        </p:txBody>
+      </p:sp>
+    </p:spTree>
+    <p:extLst>
+      <p:ext uri="{BB962C8B-B14F-4D97-AF65-F5344CB8AC3E}">
+        <p14:creationId xmlns:p14="http://schemas.microsoft.com/office/powerpoint/2010/main" val="1024086991"/>
+      </p:ext>
+    </p:extLst>
+  </p:cSld>
+  <p:clrMapOvr>
+    <a:masterClrMapping/>
+  </p:clrMapOvr>
+</p:notes>
+</file>
+
+<file path=ppt/notesSlides/notesSlide19.xml><?xml version="1.0" encoding="utf-8"?>
+<p:notes xmlns:a="http://schemas.openxmlformats.org/drawingml/2006/main" xmlns:r="http://schemas.openxmlformats.org/officeDocument/2006/relationships" xmlns:p="http://schemas.openxmlformats.org/presentationml/2006/main">
+  <p:cSld>
+    <p:spTree>
+      <p:nvGrpSpPr>
+        <p:cNvPr id="1" name=""/>
+        <p:cNvGrpSpPr/>
+        <p:nvPr/>
+      </p:nvGrpSpPr>
+      <p:grpSpPr>
+        <a:xfrm>
+          <a:off x="0" y="0"/>
+          <a:ext cx="0" cy="0"/>
+          <a:chOff x="0" y="0"/>
+          <a:chExt cx="0" cy="0"/>
+        </a:xfrm>
+      </p:grpSpPr>
+      <p:sp>
+        <p:nvSpPr>
+          <p:cNvPr id="2" name="Slide Image Placeholder 1"/>
+          <p:cNvSpPr>
+            <a:spLocks noGrp="1" noRot="1" noChangeAspect="1"/>
+          </p:cNvSpPr>
+          <p:nvPr>
+            <p:ph type="sldImg"/>
+          </p:nvPr>
+        </p:nvSpPr>
+        <p:spPr/>
+      </p:sp>
+      <p:sp>
+        <p:nvSpPr>
+          <p:cNvPr id="3" name="Notes Placeholder 2"/>
+          <p:cNvSpPr>
+            <a:spLocks noGrp="1"/>
+          </p:cNvSpPr>
+          <p:nvPr>
+            <p:ph type="body" idx="1"/>
+          </p:nvPr>
+        </p:nvSpPr>
+        <p:spPr/>
+        <p:txBody>
+          <a:bodyPr/>
+          <a:lstStyle/>
+          <a:p>
+            <a:r>
+              <a:rPr lang="en-US" dirty="0"/>
+              <a:t/>
+            </a:r>
+            <a:endParaRPr lang="en-US" dirty="0"/>
+          </a:p>
+        </p:txBody>
+      </p:sp>
+      <p:sp>
+        <p:nvSpPr>
+          <p:cNvPr id="4" name="Slide Number Placeholder 3"/>
+          <p:cNvSpPr>
+            <a:spLocks noGrp="1"/>
+          </p:cNvSpPr>
+          <p:nvPr>
+            <p:ph type="sldNum" sz="quarter" idx="10"/>
+          </p:nvPr>
+        </p:nvSpPr>
+        <p:spPr/>
+        <p:txBody>
+          <a:bodyPr/>
+          <a:lstStyle/>
+          <a:p>
+            <a:fld id="{F7021451-1387-4CA6-816F-3879F97B5CBC}" type="slidenum">
+              <a:rPr lang="en-US"/>
+              <a:t>19</a:t>
             </a:fld>
             <a:endParaRPr lang="en-US"/>
           </a:p>
@@ -6893,6 +7338,2731 @@
   <p:cSld name="Slide 14">
     <p:bg>
       <p:bgPr>
+        <a:solidFill>
+          <a:srgbClr val="000000"/>
+        </a:solidFill>
+      </p:bgPr>
+    </p:bg>
+    <p:spTree>
+      <p:nvGrpSpPr>
+        <p:cNvPr id="1" name=""/>
+        <p:cNvGrpSpPr/>
+        <p:nvPr/>
+      </p:nvGrpSpPr>
+      <p:grpSpPr>
+        <a:xfrm>
+          <a:off x="0" y="0"/>
+          <a:ext cx="0" cy="0"/>
+          <a:chOff x="0" y="0"/>
+          <a:chExt cx="0" cy="0"/>
+        </a:xfrm>
+      </p:grpSpPr>
+      <p:sp>
+        <p:nvSpPr>
+          <p:cNvPr id="2" name="Text 0"/>
+          <p:cNvSpPr/>
+          <p:nvPr/>
+        </p:nvSpPr>
+        <p:spPr>
+          <a:xfrm>
+            <a:off x="566928" y="566928"/>
+            <a:ext cx="8229600" cy="274320"/>
+          </a:xfrm>
+          <a:prstGeom prst="rect">
+            <a:avLst/>
+          </a:prstGeom>
+          <a:noFill/>
+          <a:ln/>
+        </p:spPr>
+        <p:txBody>
+          <a:bodyPr wrap="square" lIns="0" tIns="0" rIns="0" bIns="0" rtlCol="0" anchor="ctr"/>
+          <a:lstStyle/>
+          <a:p>
+            <a:pPr algn="l" indent="0" marL="0">
+              <a:buNone/>
+            </a:pPr>
+            <a:r>
+              <a:rPr lang="en-US" sz="1150" b="1" spc="300" kern="0" dirty="0">
+                <a:solidFill>
+                  <a:srgbClr val="3291FF"/>
+                </a:solidFill>
+                <a:latin typeface="Consolas" pitchFamily="34" charset="0"/>
+                <a:ea typeface="Consolas" pitchFamily="34" charset="-122"/>
+                <a:cs typeface="Consolas" pitchFamily="34" charset="-120"/>
+              </a:rPr>
+              <a:t>APÊNDICE TÉCNICO · TREINO</a:t>
+            </a:r>
+            <a:endParaRPr lang="en-US" sz="1150" dirty="0"/>
+          </a:p>
+        </p:txBody>
+      </p:sp>
+      <p:sp>
+        <p:nvSpPr>
+          <p:cNvPr id="3" name="Text 1"/>
+          <p:cNvSpPr/>
+          <p:nvPr/>
+        </p:nvSpPr>
+        <p:spPr>
+          <a:xfrm>
+            <a:off x="566928" y="896112"/>
+            <a:ext cx="11247120" cy="914400"/>
+          </a:xfrm>
+          <a:prstGeom prst="rect">
+            <a:avLst/>
+          </a:prstGeom>
+          <a:noFill/>
+          <a:ln/>
+        </p:spPr>
+        <p:txBody>
+          <a:bodyPr wrap="square" lIns="0" tIns="0" rIns="0" bIns="0" rtlCol="0" anchor="t"/>
+          <a:lstStyle/>
+          <a:p>
+            <a:pPr algn="l" indent="0" marL="0">
+              <a:lnSpc>
+                <a:spcPct val="95000"/>
+              </a:lnSpc>
+              <a:buNone/>
+            </a:pPr>
+            <a:r>
+              <a:rPr lang="en-US" sz="2600" b="1" dirty="0">
+                <a:solidFill>
+                  <a:srgbClr val="EDEDED"/>
+                </a:solidFill>
+                <a:latin typeface="Trebuchet MS" pitchFamily="34" charset="0"/>
+                <a:ea typeface="Trebuchet MS" pitchFamily="34" charset="-122"/>
+                <a:cs typeface="Trebuchet MS" pitchFamily="34" charset="-120"/>
+              </a:rPr>
+              <a:t>Como treinamos na base real</a:t>
+            </a:r>
+            <a:endParaRPr lang="en-US" sz="2600" dirty="0"/>
+          </a:p>
+        </p:txBody>
+      </p:sp>
+      <p:sp>
+        <p:nvSpPr>
+          <p:cNvPr id="4" name="Shape 2"/>
+          <p:cNvSpPr/>
+          <p:nvPr/>
+        </p:nvSpPr>
+        <p:spPr>
+          <a:xfrm>
+            <a:off x="566928" y="1783080"/>
+            <a:ext cx="4526280" cy="2240280"/>
+          </a:xfrm>
+          <a:prstGeom prst="roundRect">
+            <a:avLst>
+              <a:gd name="adj" fmla="val 3673"/>
+            </a:avLst>
+          </a:prstGeom>
+          <a:solidFill>
+            <a:srgbClr val="0C0C0E"/>
+          </a:solidFill>
+          <a:ln w="12700">
+            <a:solidFill>
+              <a:srgbClr val="2A2A30"/>
+            </a:solidFill>
+            <a:prstDash val="solid"/>
+          </a:ln>
+          <a:effectLst>
+            <a:outerShdw sx="100000" sy="100000" kx="0" ky="0" algn="bl" rotWithShape="0" blurRad="114300" dist="38100" dir="8100000">
+              <a:srgbClr val="000000">
+                <a:alpha val="45000"/>
+              </a:srgbClr>
+            </a:outerShdw>
+          </a:effectLst>
+        </p:spPr>
+      </p:sp>
+      <p:sp>
+        <p:nvSpPr>
+          <p:cNvPr id="5" name="Text 3"/>
+          <p:cNvSpPr/>
+          <p:nvPr/>
+        </p:nvSpPr>
+        <p:spPr>
+          <a:xfrm>
+            <a:off x="795528" y="1938528"/>
+            <a:ext cx="4069080" cy="256032"/>
+          </a:xfrm>
+          <a:prstGeom prst="rect">
+            <a:avLst/>
+          </a:prstGeom>
+          <a:noFill/>
+          <a:ln/>
+        </p:spPr>
+        <p:txBody>
+          <a:bodyPr wrap="square" lIns="0" tIns="0" rIns="0" bIns="0" rtlCol="0" anchor="ctr"/>
+          <a:lstStyle/>
+          <a:p>
+            <a:pPr indent="0" marL="0">
+              <a:buNone/>
+            </a:pPr>
+            <a:r>
+              <a:rPr lang="en-US" sz="1000" b="1" spc="200" kern="0" dirty="0">
+                <a:solidFill>
+                  <a:srgbClr val="3291FF"/>
+                </a:solidFill>
+                <a:latin typeface="Consolas" pitchFamily="34" charset="0"/>
+                <a:ea typeface="Consolas" pitchFamily="34" charset="-122"/>
+                <a:cs typeface="Consolas" pitchFamily="34" charset="-120"/>
+              </a:rPr>
+              <a:t>MATEMÁTICA</a:t>
+            </a:r>
+            <a:endParaRPr lang="en-US" sz="1000" dirty="0"/>
+          </a:p>
+        </p:txBody>
+      </p:sp>
+      <p:pic>
+        <p:nvPicPr>
+          <p:cNvPr id="6" name="Image 0" descr="C:\Users\Dione\Desktop\datathon-7mlet-grupo-64\datathon-7mlet-grupo-64\.pptx-build/tech/eq_reward.png">    </p:cNvPr>
+          <p:cNvPicPr>
+            <a:picLocks noChangeAspect="1"/>
+          </p:cNvPicPr>
+          <p:nvPr/>
+        </p:nvPicPr>
+        <p:blipFill>
+          <a:blip r:embed="rId1"/>
+          <a:srcRect l="0" r="0" t="0" b="0"/>
+          <a:stretch/>
+        </p:blipFill>
+        <p:spPr>
+          <a:xfrm>
+            <a:off x="749808" y="2249424"/>
+            <a:ext cx="4160520" cy="1627632"/>
+          </a:xfrm>
+          <a:prstGeom prst="rect">
+            <a:avLst/>
+          </a:prstGeom>
+        </p:spPr>
+      </p:pic>
+      <p:sp>
+        <p:nvSpPr>
+          <p:cNvPr id="7" name="Text 4"/>
+          <p:cNvSpPr/>
+          <p:nvPr/>
+        </p:nvSpPr>
+        <p:spPr>
+          <a:xfrm>
+            <a:off x="585216" y="4206240"/>
+            <a:ext cx="4526280" cy="237744"/>
+          </a:xfrm>
+          <a:prstGeom prst="rect">
+            <a:avLst/>
+          </a:prstGeom>
+          <a:noFill/>
+          <a:ln/>
+        </p:spPr>
+        <p:txBody>
+          <a:bodyPr wrap="square" lIns="0" tIns="0" rIns="0" bIns="0" rtlCol="0" anchor="ctr"/>
+          <a:lstStyle/>
+          <a:p>
+            <a:pPr indent="0" marL="0">
+              <a:buNone/>
+            </a:pPr>
+            <a:r>
+              <a:rPr lang="en-US" sz="950" b="1" spc="200" kern="0" dirty="0">
+                <a:solidFill>
+                  <a:srgbClr val="9A9AA6"/>
+                </a:solidFill>
+                <a:latin typeface="Consolas" pitchFamily="34" charset="0"/>
+                <a:ea typeface="Consolas" pitchFamily="34" charset="-122"/>
+                <a:cs typeface="Consolas" pitchFamily="34" charset="-120"/>
+              </a:rPr>
+              <a:t>REFERÊNCIA</a:t>
+            </a:r>
+            <a:endParaRPr lang="en-US" sz="950" dirty="0"/>
+          </a:p>
+        </p:txBody>
+      </p:sp>
+      <p:sp>
+        <p:nvSpPr>
+          <p:cNvPr id="8" name="Text 5"/>
+          <p:cNvSpPr/>
+          <p:nvPr/>
+        </p:nvSpPr>
+        <p:spPr>
+          <a:xfrm>
+            <a:off x="585216" y="4443984"/>
+            <a:ext cx="4663440" cy="566928"/>
+          </a:xfrm>
+          <a:prstGeom prst="rect">
+            <a:avLst/>
+          </a:prstGeom>
+          <a:noFill/>
+          <a:ln/>
+        </p:spPr>
+        <p:txBody>
+          <a:bodyPr wrap="square" lIns="0" tIns="0" rIns="0" bIns="0" rtlCol="0" anchor="ctr"/>
+          <a:lstStyle/>
+          <a:p>
+            <a:pPr indent="0" marL="0">
+              <a:lnSpc>
+                <a:spcPct val="103000"/>
+              </a:lnSpc>
+              <a:buNone/>
+            </a:pPr>
+            <a:r>
+              <a:rPr lang="en-US" sz="1250" b="1" dirty="0">
+                <a:solidFill>
+                  <a:srgbClr val="EDEDED"/>
+                </a:solidFill>
+                <a:latin typeface="Calibri" pitchFamily="34" charset="0"/>
+                <a:ea typeface="Calibri" pitchFamily="34" charset="-122"/>
+                <a:cs typeface="Calibri" pitchFamily="34" charset="-120"/>
+              </a:rPr>
+              <a:t>Off-policy replay sobre os eventos reais do Bank Marketing.</a:t>
+            </a:r>
+            <a:endParaRPr lang="en-US" sz="1250" dirty="0"/>
+          </a:p>
+        </p:txBody>
+      </p:sp>
+      <p:sp>
+        <p:nvSpPr>
+          <p:cNvPr id="9" name="Text 6"/>
+          <p:cNvSpPr/>
+          <p:nvPr/>
+        </p:nvSpPr>
+        <p:spPr>
+          <a:xfrm>
+            <a:off x="585216" y="5074920"/>
+            <a:ext cx="4663440" cy="868680"/>
+          </a:xfrm>
+          <a:prstGeom prst="rect">
+            <a:avLst/>
+          </a:prstGeom>
+          <a:noFill/>
+          <a:ln/>
+        </p:spPr>
+        <p:txBody>
+          <a:bodyPr wrap="square" lIns="0" tIns="0" rIns="0" bIns="0" rtlCol="0" anchor="ctr"/>
+          <a:lstStyle/>
+          <a:p>
+            <a:pPr indent="0" marL="0">
+              <a:lnSpc>
+                <a:spcPct val="105000"/>
+              </a:lnSpc>
+              <a:buNone/>
+            </a:pPr>
+            <a:r>
+              <a:rPr lang="en-US" sz="1250" dirty="0">
+                <a:solidFill>
+                  <a:srgbClr val="9A9AA6"/>
+                </a:solidFill>
+                <a:latin typeface="Calibri" pitchFamily="34" charset="0"/>
+                <a:ea typeface="Calibri" pitchFamily="34" charset="-122"/>
+                <a:cs typeface="Calibri" pitchFamily="34" charset="-120"/>
+              </a:rPr>
+              <a:t>value = margem × conversão · regret = soma das diferenças vs. oráculo · a recompensa pode chegar atrasada (delayed reward).</a:t>
+            </a:r>
+            <a:endParaRPr lang="en-US" sz="1250" dirty="0"/>
+          </a:p>
+        </p:txBody>
+      </p:sp>
+      <p:sp>
+        <p:nvSpPr>
+          <p:cNvPr id="10" name="Shape 7"/>
+          <p:cNvSpPr/>
+          <p:nvPr/>
+        </p:nvSpPr>
+        <p:spPr>
+          <a:xfrm>
+            <a:off x="5349240" y="1783080"/>
+            <a:ext cx="6272784" cy="4114800"/>
+          </a:xfrm>
+          <a:prstGeom prst="roundRect">
+            <a:avLst>
+              <a:gd name="adj" fmla="val 2000"/>
+            </a:avLst>
+          </a:prstGeom>
+          <a:solidFill>
+            <a:srgbClr val="272822"/>
+          </a:solidFill>
+          <a:ln w="12700">
+            <a:solidFill>
+              <a:srgbClr val="2A2A30"/>
+            </a:solidFill>
+            <a:prstDash val="solid"/>
+          </a:ln>
+          <a:effectLst>
+            <a:outerShdw sx="100000" sy="100000" kx="0" ky="0" algn="bl" rotWithShape="0" blurRad="114300" dist="38100" dir="8100000">
+              <a:srgbClr val="000000">
+                <a:alpha val="45000"/>
+              </a:srgbClr>
+            </a:outerShdw>
+          </a:effectLst>
+        </p:spPr>
+      </p:sp>
+      <p:pic>
+        <p:nvPicPr>
+          <p:cNvPr id="11" name="Image 1" descr="C:\Users\Dione\Desktop\datathon-7mlet-grupo-64\datathon-7mlet-grupo-64\.pptx-build/tech/code_train.png">    </p:cNvPr>
+          <p:cNvPicPr>
+            <a:picLocks noChangeAspect="1"/>
+          </p:cNvPicPr>
+          <p:nvPr/>
+        </p:nvPicPr>
+        <p:blipFill>
+          <a:blip r:embed="rId2"/>
+          <a:srcRect l="0" r="0" t="0" b="0"/>
+          <a:stretch/>
+        </p:blipFill>
+        <p:spPr>
+          <a:xfrm>
+            <a:off x="5532120" y="1938528"/>
+            <a:ext cx="5907024" cy="3566160"/>
+          </a:xfrm>
+          <a:prstGeom prst="rect">
+            <a:avLst/>
+          </a:prstGeom>
+        </p:spPr>
+      </p:pic>
+      <p:sp>
+        <p:nvSpPr>
+          <p:cNvPr id="12" name="Text 8"/>
+          <p:cNvSpPr/>
+          <p:nvPr/>
+        </p:nvSpPr>
+        <p:spPr>
+          <a:xfrm>
+            <a:off x="5550408" y="5541264"/>
+            <a:ext cx="5870448" cy="274320"/>
+          </a:xfrm>
+          <a:prstGeom prst="rect">
+            <a:avLst/>
+          </a:prstGeom>
+          <a:noFill/>
+          <a:ln/>
+        </p:spPr>
+        <p:txBody>
+          <a:bodyPr wrap="square" lIns="0" tIns="0" rIns="0" bIns="0" rtlCol="0" anchor="ctr"/>
+          <a:lstStyle/>
+          <a:p>
+            <a:pPr indent="0" marL="0">
+              <a:buNone/>
+            </a:pPr>
+            <a:r>
+              <a:rPr lang="en-US" sz="1050" b="1" dirty="0">
+                <a:solidFill>
+                  <a:srgbClr val="3291FF"/>
+                </a:solidFill>
+                <a:latin typeface="Consolas" pitchFamily="34" charset="0"/>
+                <a:ea typeface="Consolas" pitchFamily="34" charset="-122"/>
+                <a:cs typeface="Consolas" pitchFamily="34" charset="-120"/>
+              </a:rPr>
+              <a:t>src/adaptive_offers/simulation/environment.py</a:t>
+            </a:r>
+            <a:endParaRPr lang="en-US" sz="1050" dirty="0"/>
+          </a:p>
+        </p:txBody>
+      </p:sp>
+      <p:sp>
+        <p:nvSpPr>
+          <p:cNvPr id="13" name="Text 9"/>
+          <p:cNvSpPr/>
+          <p:nvPr/>
+        </p:nvSpPr>
+        <p:spPr>
+          <a:xfrm>
+            <a:off x="566928" y="6437376"/>
+            <a:ext cx="4572000" cy="274320"/>
+          </a:xfrm>
+          <a:prstGeom prst="rect">
+            <a:avLst/>
+          </a:prstGeom>
+          <a:noFill/>
+          <a:ln/>
+        </p:spPr>
+        <p:txBody>
+          <a:bodyPr wrap="square" lIns="0" tIns="0" rIns="0" bIns="0" rtlCol="0" anchor="ctr"/>
+          <a:lstStyle/>
+          <a:p>
+            <a:pPr algn="l" indent="0" marL="0">
+              <a:buNone/>
+            </a:pPr>
+            <a:r>
+              <a:rPr lang="en-US" sz="850" spc="200" kern="0" dirty="0">
+                <a:solidFill>
+                  <a:srgbClr val="5A5A63"/>
+                </a:solidFill>
+                <a:latin typeface="Consolas" pitchFamily="34" charset="0"/>
+                <a:ea typeface="Consolas" pitchFamily="34" charset="-122"/>
+                <a:cs typeface="Consolas" pitchFamily="34" charset="-120"/>
+              </a:rPr>
+              <a:t>ADAPTIVE OFFERS PLATFORM</a:t>
+            </a:r>
+            <a:endParaRPr lang="en-US" sz="850" dirty="0"/>
+          </a:p>
+        </p:txBody>
+      </p:sp>
+      <p:sp>
+        <p:nvSpPr>
+          <p:cNvPr id="14" name="Text 10"/>
+          <p:cNvSpPr/>
+          <p:nvPr/>
+        </p:nvSpPr>
+        <p:spPr>
+          <a:xfrm>
+            <a:off x="7050024" y="6437376"/>
+            <a:ext cx="4572000" cy="274320"/>
+          </a:xfrm>
+          <a:prstGeom prst="rect">
+            <a:avLst/>
+          </a:prstGeom>
+          <a:noFill/>
+          <a:ln/>
+        </p:spPr>
+        <p:txBody>
+          <a:bodyPr wrap="square" lIns="0" tIns="0" rIns="0" bIns="0" rtlCol="0" anchor="ctr"/>
+          <a:lstStyle/>
+          <a:p>
+            <a:pPr algn="r" indent="0" marL="0">
+              <a:buNone/>
+            </a:pPr>
+            <a:r>
+              <a:rPr lang="en-US" sz="850" spc="200" kern="0" dirty="0">
+                <a:solidFill>
+                  <a:srgbClr val="5A5A63"/>
+                </a:solidFill>
+                <a:latin typeface="Consolas" pitchFamily="34" charset="0"/>
+                <a:ea typeface="Consolas" pitchFamily="34" charset="-122"/>
+                <a:cs typeface="Consolas" pitchFamily="34" charset="-120"/>
+              </a:rPr>
+              <a:t>GRUPO 64 · FIAP PÓS-TECH 7MLET</a:t>
+            </a:r>
+            <a:endParaRPr lang="en-US" sz="850" dirty="0"/>
+          </a:p>
+        </p:txBody>
+      </p:sp>
+      <p:sp>
+        <p:nvSpPr>
+          <p:cNvPr id="15" name="Text 11"/>
+          <p:cNvSpPr/>
+          <p:nvPr/>
+        </p:nvSpPr>
+        <p:spPr>
+          <a:xfrm>
+            <a:off x="5820156" y="6437376"/>
+            <a:ext cx="548640" cy="274320"/>
+          </a:xfrm>
+          <a:prstGeom prst="rect">
+            <a:avLst/>
+          </a:prstGeom>
+          <a:noFill/>
+          <a:ln/>
+        </p:spPr>
+        <p:txBody>
+          <a:bodyPr wrap="square" lIns="0" tIns="0" rIns="0" bIns="0" rtlCol="0" anchor="ctr"/>
+          <a:lstStyle/>
+          <a:p>
+            <a:pPr algn="ctr" indent="0" marL="0">
+              <a:buNone/>
+            </a:pPr>
+            <a:r>
+              <a:rPr lang="en-US" sz="850" b="1" dirty="0">
+                <a:solidFill>
+                  <a:srgbClr val="0070F3"/>
+                </a:solidFill>
+                <a:latin typeface="Consolas" pitchFamily="34" charset="0"/>
+                <a:ea typeface="Consolas" pitchFamily="34" charset="-122"/>
+                <a:cs typeface="Consolas" pitchFamily="34" charset="-120"/>
+              </a:rPr>
+              <a:t>14</a:t>
+            </a:r>
+            <a:endParaRPr lang="en-US" sz="850" dirty="0"/>
+          </a:p>
+        </p:txBody>
+      </p:sp>
+    </p:spTree>
+  </p:cSld>
+  <p:clrMapOvr>
+    <a:masterClrMapping/>
+  </p:clrMapOvr>
+</p:sld>
+</file>
+
+<file path=ppt/slides/slide15.xml><?xml version="1.0" encoding="utf-8"?>
+<p:sld xmlns:a="http://schemas.openxmlformats.org/drawingml/2006/main" xmlns:r="http://schemas.openxmlformats.org/officeDocument/2006/relationships" xmlns:p="http://schemas.openxmlformats.org/presentationml/2006/main">
+  <p:cSld name="Slide 15">
+    <p:bg>
+      <p:bgPr>
+        <a:solidFill>
+          <a:srgbClr val="000000"/>
+        </a:solidFill>
+      </p:bgPr>
+    </p:bg>
+    <p:spTree>
+      <p:nvGrpSpPr>
+        <p:cNvPr id="1" name=""/>
+        <p:cNvGrpSpPr/>
+        <p:nvPr/>
+      </p:nvGrpSpPr>
+      <p:grpSpPr>
+        <a:xfrm>
+          <a:off x="0" y="0"/>
+          <a:ext cx="0" cy="0"/>
+          <a:chOff x="0" y="0"/>
+          <a:chExt cx="0" cy="0"/>
+        </a:xfrm>
+      </p:grpSpPr>
+      <p:sp>
+        <p:nvSpPr>
+          <p:cNvPr id="2" name="Text 0"/>
+          <p:cNvSpPr/>
+          <p:nvPr/>
+        </p:nvSpPr>
+        <p:spPr>
+          <a:xfrm>
+            <a:off x="566928" y="566928"/>
+            <a:ext cx="8229600" cy="274320"/>
+          </a:xfrm>
+          <a:prstGeom prst="rect">
+            <a:avLst/>
+          </a:prstGeom>
+          <a:noFill/>
+          <a:ln/>
+        </p:spPr>
+        <p:txBody>
+          <a:bodyPr wrap="square" lIns="0" tIns="0" rIns="0" bIns="0" rtlCol="0" anchor="ctr"/>
+          <a:lstStyle/>
+          <a:p>
+            <a:pPr algn="l" indent="0" marL="0">
+              <a:buNone/>
+            </a:pPr>
+            <a:r>
+              <a:rPr lang="en-US" sz="1150" b="1" spc="300" kern="0" dirty="0">
+                <a:solidFill>
+                  <a:srgbClr val="3291FF"/>
+                </a:solidFill>
+                <a:latin typeface="Consolas" pitchFamily="34" charset="0"/>
+                <a:ea typeface="Consolas" pitchFamily="34" charset="-122"/>
+                <a:cs typeface="Consolas" pitchFamily="34" charset="-120"/>
+              </a:rPr>
+              <a:t>APÊNDICE TÉCNICO · CONTROLE</a:t>
+            </a:r>
+            <a:endParaRPr lang="en-US" sz="1150" dirty="0"/>
+          </a:p>
+        </p:txBody>
+      </p:sp>
+      <p:sp>
+        <p:nvSpPr>
+          <p:cNvPr id="3" name="Text 1"/>
+          <p:cNvSpPr/>
+          <p:nvPr/>
+        </p:nvSpPr>
+        <p:spPr>
+          <a:xfrm>
+            <a:off x="566928" y="896112"/>
+            <a:ext cx="11247120" cy="914400"/>
+          </a:xfrm>
+          <a:prstGeom prst="rect">
+            <a:avLst/>
+          </a:prstGeom>
+          <a:noFill/>
+          <a:ln/>
+        </p:spPr>
+        <p:txBody>
+          <a:bodyPr wrap="square" lIns="0" tIns="0" rIns="0" bIns="0" rtlCol="0" anchor="t"/>
+          <a:lstStyle/>
+          <a:p>
+            <a:pPr algn="l" indent="0" marL="0">
+              <a:lnSpc>
+                <a:spcPct val="95000"/>
+              </a:lnSpc>
+              <a:buNone/>
+            </a:pPr>
+            <a:r>
+              <a:rPr lang="en-US" sz="2600" b="1" dirty="0">
+                <a:solidFill>
+                  <a:srgbClr val="EDEDED"/>
+                </a:solidFill>
+                <a:latin typeface="Trebuchet MS" pitchFamily="34" charset="0"/>
+                <a:ea typeface="Trebuchet MS" pitchFamily="34" charset="-122"/>
+                <a:cs typeface="Trebuchet MS" pitchFamily="34" charset="-120"/>
+              </a:rPr>
+              <a:t>Baseline — guloso (controle)</a:t>
+            </a:r>
+            <a:endParaRPr lang="en-US" sz="2600" dirty="0"/>
+          </a:p>
+        </p:txBody>
+      </p:sp>
+      <p:sp>
+        <p:nvSpPr>
+          <p:cNvPr id="4" name="Shape 2"/>
+          <p:cNvSpPr/>
+          <p:nvPr/>
+        </p:nvSpPr>
+        <p:spPr>
+          <a:xfrm>
+            <a:off x="566928" y="1783080"/>
+            <a:ext cx="4526280" cy="2240280"/>
+          </a:xfrm>
+          <a:prstGeom prst="roundRect">
+            <a:avLst>
+              <a:gd name="adj" fmla="val 3673"/>
+            </a:avLst>
+          </a:prstGeom>
+          <a:solidFill>
+            <a:srgbClr val="0C0C0E"/>
+          </a:solidFill>
+          <a:ln w="12700">
+            <a:solidFill>
+              <a:srgbClr val="2A2A30"/>
+            </a:solidFill>
+            <a:prstDash val="solid"/>
+          </a:ln>
+          <a:effectLst>
+            <a:outerShdw sx="100000" sy="100000" kx="0" ky="0" algn="bl" rotWithShape="0" blurRad="114300" dist="38100" dir="8100000">
+              <a:srgbClr val="000000">
+                <a:alpha val="45000"/>
+              </a:srgbClr>
+            </a:outerShdw>
+          </a:effectLst>
+        </p:spPr>
+      </p:sp>
+      <p:sp>
+        <p:nvSpPr>
+          <p:cNvPr id="5" name="Text 3"/>
+          <p:cNvSpPr/>
+          <p:nvPr/>
+        </p:nvSpPr>
+        <p:spPr>
+          <a:xfrm>
+            <a:off x="795528" y="1938528"/>
+            <a:ext cx="4069080" cy="256032"/>
+          </a:xfrm>
+          <a:prstGeom prst="rect">
+            <a:avLst/>
+          </a:prstGeom>
+          <a:noFill/>
+          <a:ln/>
+        </p:spPr>
+        <p:txBody>
+          <a:bodyPr wrap="square" lIns="0" tIns="0" rIns="0" bIns="0" rtlCol="0" anchor="ctr"/>
+          <a:lstStyle/>
+          <a:p>
+            <a:pPr indent="0" marL="0">
+              <a:buNone/>
+            </a:pPr>
+            <a:r>
+              <a:rPr lang="en-US" sz="1000" b="1" spc="200" kern="0" dirty="0">
+                <a:solidFill>
+                  <a:srgbClr val="3291FF"/>
+                </a:solidFill>
+                <a:latin typeface="Consolas" pitchFamily="34" charset="0"/>
+                <a:ea typeface="Consolas" pitchFamily="34" charset="-122"/>
+                <a:cs typeface="Consolas" pitchFamily="34" charset="-120"/>
+              </a:rPr>
+              <a:t>MATEMÁTICA</a:t>
+            </a:r>
+            <a:endParaRPr lang="en-US" sz="1000" dirty="0"/>
+          </a:p>
+        </p:txBody>
+      </p:sp>
+      <p:pic>
+        <p:nvPicPr>
+          <p:cNvPr id="6" name="Image 0" descr="C:\Users\Dione\Desktop\datathon-7mlet-grupo-64\datathon-7mlet-grupo-64\.pptx-build/tech/eq_baseline.png">    </p:cNvPr>
+          <p:cNvPicPr>
+            <a:picLocks noChangeAspect="1"/>
+          </p:cNvPicPr>
+          <p:nvPr/>
+        </p:nvPicPr>
+        <p:blipFill>
+          <a:blip r:embed="rId1"/>
+          <a:srcRect l="0" r="0" t="0" b="0"/>
+          <a:stretch/>
+        </p:blipFill>
+        <p:spPr>
+          <a:xfrm>
+            <a:off x="749808" y="2249424"/>
+            <a:ext cx="4160520" cy="1627632"/>
+          </a:xfrm>
+          <a:prstGeom prst="rect">
+            <a:avLst/>
+          </a:prstGeom>
+        </p:spPr>
+      </p:pic>
+      <p:sp>
+        <p:nvSpPr>
+          <p:cNvPr id="7" name="Text 4"/>
+          <p:cNvSpPr/>
+          <p:nvPr/>
+        </p:nvSpPr>
+        <p:spPr>
+          <a:xfrm>
+            <a:off x="585216" y="4206240"/>
+            <a:ext cx="4526280" cy="237744"/>
+          </a:xfrm>
+          <a:prstGeom prst="rect">
+            <a:avLst/>
+          </a:prstGeom>
+          <a:noFill/>
+          <a:ln/>
+        </p:spPr>
+        <p:txBody>
+          <a:bodyPr wrap="square" lIns="0" tIns="0" rIns="0" bIns="0" rtlCol="0" anchor="ctr"/>
+          <a:lstStyle/>
+          <a:p>
+            <a:pPr indent="0" marL="0">
+              <a:buNone/>
+            </a:pPr>
+            <a:r>
+              <a:rPr lang="en-US" sz="950" b="1" spc="200" kern="0" dirty="0">
+                <a:solidFill>
+                  <a:srgbClr val="9A9AA6"/>
+                </a:solidFill>
+                <a:latin typeface="Consolas" pitchFamily="34" charset="0"/>
+                <a:ea typeface="Consolas" pitchFamily="34" charset="-122"/>
+                <a:cs typeface="Consolas" pitchFamily="34" charset="-120"/>
+              </a:rPr>
+              <a:t>REFERÊNCIA</a:t>
+            </a:r>
+            <a:endParaRPr lang="en-US" sz="950" dirty="0"/>
+          </a:p>
+        </p:txBody>
+      </p:sp>
+      <p:sp>
+        <p:nvSpPr>
+          <p:cNvPr id="8" name="Text 5"/>
+          <p:cNvSpPr/>
+          <p:nvPr/>
+        </p:nvSpPr>
+        <p:spPr>
+          <a:xfrm>
+            <a:off x="585216" y="4443984"/>
+            <a:ext cx="4663440" cy="566928"/>
+          </a:xfrm>
+          <a:prstGeom prst="rect">
+            <a:avLst/>
+          </a:prstGeom>
+          <a:noFill/>
+          <a:ln/>
+        </p:spPr>
+        <p:txBody>
+          <a:bodyPr wrap="square" lIns="0" tIns="0" rIns="0" bIns="0" rtlCol="0" anchor="ctr"/>
+          <a:lstStyle/>
+          <a:p>
+            <a:pPr indent="0" marL="0">
+              <a:lnSpc>
+                <a:spcPct val="103000"/>
+              </a:lnSpc>
+              <a:buNone/>
+            </a:pPr>
+            <a:r>
+              <a:rPr lang="en-US" sz="1250" b="1" dirty="0">
+                <a:solidFill>
+                  <a:srgbClr val="EDEDED"/>
+                </a:solidFill>
+                <a:latin typeface="Calibri" pitchFamily="34" charset="0"/>
+                <a:ea typeface="Calibri" pitchFamily="34" charset="-122"/>
+                <a:cs typeface="Calibri" pitchFamily="34" charset="-120"/>
+              </a:rPr>
+              <a:t>Greedy com início otimista · sem exploração ativa.</a:t>
+            </a:r>
+            <a:endParaRPr lang="en-US" sz="1250" dirty="0"/>
+          </a:p>
+        </p:txBody>
+      </p:sp>
+      <p:sp>
+        <p:nvSpPr>
+          <p:cNvPr id="9" name="Text 6"/>
+          <p:cNvSpPr/>
+          <p:nvPr/>
+        </p:nvSpPr>
+        <p:spPr>
+          <a:xfrm>
+            <a:off x="585216" y="5074920"/>
+            <a:ext cx="4663440" cy="868680"/>
+          </a:xfrm>
+          <a:prstGeom prst="rect">
+            <a:avLst/>
+          </a:prstGeom>
+          <a:noFill/>
+          <a:ln/>
+        </p:spPr>
+        <p:txBody>
+          <a:bodyPr wrap="square" lIns="0" tIns="0" rIns="0" bIns="0" rtlCol="0" anchor="ctr"/>
+          <a:lstStyle/>
+          <a:p>
+            <a:pPr indent="0" marL="0">
+              <a:lnSpc>
+                <a:spcPct val="105000"/>
+              </a:lnSpc>
+              <a:buNone/>
+            </a:pPr>
+            <a:r>
+              <a:rPr lang="en-US" sz="1250" dirty="0">
+                <a:solidFill>
+                  <a:srgbClr val="9A9AA6"/>
+                </a:solidFill>
+                <a:latin typeface="Calibri" pitchFamily="34" charset="0"/>
+                <a:ea typeface="Calibri" pitchFamily="34" charset="-122"/>
+                <a:cs typeface="Calibri" pitchFamily="34" charset="-120"/>
+              </a:rPr>
+              <a:t>É o controle exigido pelo edital — a referência que as políticas adaptativas precisam superar.</a:t>
+            </a:r>
+            <a:endParaRPr lang="en-US" sz="1250" dirty="0"/>
+          </a:p>
+        </p:txBody>
+      </p:sp>
+      <p:sp>
+        <p:nvSpPr>
+          <p:cNvPr id="10" name="Shape 7"/>
+          <p:cNvSpPr/>
+          <p:nvPr/>
+        </p:nvSpPr>
+        <p:spPr>
+          <a:xfrm>
+            <a:off x="5349240" y="1783080"/>
+            <a:ext cx="6272784" cy="4114800"/>
+          </a:xfrm>
+          <a:prstGeom prst="roundRect">
+            <a:avLst>
+              <a:gd name="adj" fmla="val 2000"/>
+            </a:avLst>
+          </a:prstGeom>
+          <a:solidFill>
+            <a:srgbClr val="272822"/>
+          </a:solidFill>
+          <a:ln w="12700">
+            <a:solidFill>
+              <a:srgbClr val="2A2A30"/>
+            </a:solidFill>
+            <a:prstDash val="solid"/>
+          </a:ln>
+          <a:effectLst>
+            <a:outerShdw sx="100000" sy="100000" kx="0" ky="0" algn="bl" rotWithShape="0" blurRad="114300" dist="38100" dir="8100000">
+              <a:srgbClr val="000000">
+                <a:alpha val="45000"/>
+              </a:srgbClr>
+            </a:outerShdw>
+          </a:effectLst>
+        </p:spPr>
+      </p:sp>
+      <p:pic>
+        <p:nvPicPr>
+          <p:cNvPr id="11" name="Image 1" descr="C:\Users\Dione\Desktop\datathon-7mlet-grupo-64\datathon-7mlet-grupo-64\.pptx-build/tech/code_baseline.png">    </p:cNvPr>
+          <p:cNvPicPr>
+            <a:picLocks noChangeAspect="1"/>
+          </p:cNvPicPr>
+          <p:nvPr/>
+        </p:nvPicPr>
+        <p:blipFill>
+          <a:blip r:embed="rId2"/>
+          <a:srcRect l="0" r="0" t="0" b="0"/>
+          <a:stretch/>
+        </p:blipFill>
+        <p:spPr>
+          <a:xfrm>
+            <a:off x="5532120" y="1938528"/>
+            <a:ext cx="5907024" cy="3566160"/>
+          </a:xfrm>
+          <a:prstGeom prst="rect">
+            <a:avLst/>
+          </a:prstGeom>
+        </p:spPr>
+      </p:pic>
+      <p:sp>
+        <p:nvSpPr>
+          <p:cNvPr id="12" name="Text 8"/>
+          <p:cNvSpPr/>
+          <p:nvPr/>
+        </p:nvSpPr>
+        <p:spPr>
+          <a:xfrm>
+            <a:off x="5550408" y="5541264"/>
+            <a:ext cx="5870448" cy="274320"/>
+          </a:xfrm>
+          <a:prstGeom prst="rect">
+            <a:avLst/>
+          </a:prstGeom>
+          <a:noFill/>
+          <a:ln/>
+        </p:spPr>
+        <p:txBody>
+          <a:bodyPr wrap="square" lIns="0" tIns="0" rIns="0" bIns="0" rtlCol="0" anchor="ctr"/>
+          <a:lstStyle/>
+          <a:p>
+            <a:pPr indent="0" marL="0">
+              <a:buNone/>
+            </a:pPr>
+            <a:r>
+              <a:rPr lang="en-US" sz="1050" b="1" dirty="0">
+                <a:solidFill>
+                  <a:srgbClr val="3291FF"/>
+                </a:solidFill>
+                <a:latin typeface="Consolas" pitchFamily="34" charset="0"/>
+                <a:ea typeface="Consolas" pitchFamily="34" charset="-122"/>
+                <a:cs typeface="Consolas" pitchFamily="34" charset="-120"/>
+              </a:rPr>
+              <a:t>src/adaptive_offers/bandits/baseline.py</a:t>
+            </a:r>
+            <a:endParaRPr lang="en-US" sz="1050" dirty="0"/>
+          </a:p>
+        </p:txBody>
+      </p:sp>
+      <p:sp>
+        <p:nvSpPr>
+          <p:cNvPr id="13" name="Text 9"/>
+          <p:cNvSpPr/>
+          <p:nvPr/>
+        </p:nvSpPr>
+        <p:spPr>
+          <a:xfrm>
+            <a:off x="566928" y="6437376"/>
+            <a:ext cx="4572000" cy="274320"/>
+          </a:xfrm>
+          <a:prstGeom prst="rect">
+            <a:avLst/>
+          </a:prstGeom>
+          <a:noFill/>
+          <a:ln/>
+        </p:spPr>
+        <p:txBody>
+          <a:bodyPr wrap="square" lIns="0" tIns="0" rIns="0" bIns="0" rtlCol="0" anchor="ctr"/>
+          <a:lstStyle/>
+          <a:p>
+            <a:pPr algn="l" indent="0" marL="0">
+              <a:buNone/>
+            </a:pPr>
+            <a:r>
+              <a:rPr lang="en-US" sz="850" spc="200" kern="0" dirty="0">
+                <a:solidFill>
+                  <a:srgbClr val="5A5A63"/>
+                </a:solidFill>
+                <a:latin typeface="Consolas" pitchFamily="34" charset="0"/>
+                <a:ea typeface="Consolas" pitchFamily="34" charset="-122"/>
+                <a:cs typeface="Consolas" pitchFamily="34" charset="-120"/>
+              </a:rPr>
+              <a:t>ADAPTIVE OFFERS PLATFORM</a:t>
+            </a:r>
+            <a:endParaRPr lang="en-US" sz="850" dirty="0"/>
+          </a:p>
+        </p:txBody>
+      </p:sp>
+      <p:sp>
+        <p:nvSpPr>
+          <p:cNvPr id="14" name="Text 10"/>
+          <p:cNvSpPr/>
+          <p:nvPr/>
+        </p:nvSpPr>
+        <p:spPr>
+          <a:xfrm>
+            <a:off x="7050024" y="6437376"/>
+            <a:ext cx="4572000" cy="274320"/>
+          </a:xfrm>
+          <a:prstGeom prst="rect">
+            <a:avLst/>
+          </a:prstGeom>
+          <a:noFill/>
+          <a:ln/>
+        </p:spPr>
+        <p:txBody>
+          <a:bodyPr wrap="square" lIns="0" tIns="0" rIns="0" bIns="0" rtlCol="0" anchor="ctr"/>
+          <a:lstStyle/>
+          <a:p>
+            <a:pPr algn="r" indent="0" marL="0">
+              <a:buNone/>
+            </a:pPr>
+            <a:r>
+              <a:rPr lang="en-US" sz="850" spc="200" kern="0" dirty="0">
+                <a:solidFill>
+                  <a:srgbClr val="5A5A63"/>
+                </a:solidFill>
+                <a:latin typeface="Consolas" pitchFamily="34" charset="0"/>
+                <a:ea typeface="Consolas" pitchFamily="34" charset="-122"/>
+                <a:cs typeface="Consolas" pitchFamily="34" charset="-120"/>
+              </a:rPr>
+              <a:t>GRUPO 64 · FIAP PÓS-TECH 7MLET</a:t>
+            </a:r>
+            <a:endParaRPr lang="en-US" sz="850" dirty="0"/>
+          </a:p>
+        </p:txBody>
+      </p:sp>
+      <p:sp>
+        <p:nvSpPr>
+          <p:cNvPr id="15" name="Text 11"/>
+          <p:cNvSpPr/>
+          <p:nvPr/>
+        </p:nvSpPr>
+        <p:spPr>
+          <a:xfrm>
+            <a:off x="5820156" y="6437376"/>
+            <a:ext cx="548640" cy="274320"/>
+          </a:xfrm>
+          <a:prstGeom prst="rect">
+            <a:avLst/>
+          </a:prstGeom>
+          <a:noFill/>
+          <a:ln/>
+        </p:spPr>
+        <p:txBody>
+          <a:bodyPr wrap="square" lIns="0" tIns="0" rIns="0" bIns="0" rtlCol="0" anchor="ctr"/>
+          <a:lstStyle/>
+          <a:p>
+            <a:pPr algn="ctr" indent="0" marL="0">
+              <a:buNone/>
+            </a:pPr>
+            <a:r>
+              <a:rPr lang="en-US" sz="850" b="1" dirty="0">
+                <a:solidFill>
+                  <a:srgbClr val="0070F3"/>
+                </a:solidFill>
+                <a:latin typeface="Consolas" pitchFamily="34" charset="0"/>
+                <a:ea typeface="Consolas" pitchFamily="34" charset="-122"/>
+                <a:cs typeface="Consolas" pitchFamily="34" charset="-120"/>
+              </a:rPr>
+              <a:t>15</a:t>
+            </a:r>
+            <a:endParaRPr lang="en-US" sz="850" dirty="0"/>
+          </a:p>
+        </p:txBody>
+      </p:sp>
+    </p:spTree>
+  </p:cSld>
+  <p:clrMapOvr>
+    <a:masterClrMapping/>
+  </p:clrMapOvr>
+</p:sld>
+</file>
+
+<file path=ppt/slides/slide16.xml><?xml version="1.0" encoding="utf-8"?>
+<p:sld xmlns:a="http://schemas.openxmlformats.org/drawingml/2006/main" xmlns:r="http://schemas.openxmlformats.org/officeDocument/2006/relationships" xmlns:p="http://schemas.openxmlformats.org/presentationml/2006/main">
+  <p:cSld name="Slide 16">
+    <p:bg>
+      <p:bgPr>
+        <a:solidFill>
+          <a:srgbClr val="000000"/>
+        </a:solidFill>
+      </p:bgPr>
+    </p:bg>
+    <p:spTree>
+      <p:nvGrpSpPr>
+        <p:cNvPr id="1" name=""/>
+        <p:cNvGrpSpPr/>
+        <p:nvPr/>
+      </p:nvGrpSpPr>
+      <p:grpSpPr>
+        <a:xfrm>
+          <a:off x="0" y="0"/>
+          <a:ext cx="0" cy="0"/>
+          <a:chOff x="0" y="0"/>
+          <a:chExt cx="0" cy="0"/>
+        </a:xfrm>
+      </p:grpSpPr>
+      <p:sp>
+        <p:nvSpPr>
+          <p:cNvPr id="2" name="Text 0"/>
+          <p:cNvSpPr/>
+          <p:nvPr/>
+        </p:nvSpPr>
+        <p:spPr>
+          <a:xfrm>
+            <a:off x="566928" y="566928"/>
+            <a:ext cx="8229600" cy="274320"/>
+          </a:xfrm>
+          <a:prstGeom prst="rect">
+            <a:avLst/>
+          </a:prstGeom>
+          <a:noFill/>
+          <a:ln/>
+        </p:spPr>
+        <p:txBody>
+          <a:bodyPr wrap="square" lIns="0" tIns="0" rIns="0" bIns="0" rtlCol="0" anchor="ctr"/>
+          <a:lstStyle/>
+          <a:p>
+            <a:pPr algn="l" indent="0" marL="0">
+              <a:buNone/>
+            </a:pPr>
+            <a:r>
+              <a:rPr lang="en-US" sz="1150" b="1" spc="300" kern="0" dirty="0">
+                <a:solidFill>
+                  <a:srgbClr val="3291FF"/>
+                </a:solidFill>
+                <a:latin typeface="Consolas" pitchFamily="34" charset="0"/>
+                <a:ea typeface="Consolas" pitchFamily="34" charset="-122"/>
+                <a:cs typeface="Consolas" pitchFamily="34" charset="-120"/>
+              </a:rPr>
+              <a:t>APÊNDICE TÉCNICO · BAYESIANO</a:t>
+            </a:r>
+            <a:endParaRPr lang="en-US" sz="1150" dirty="0"/>
+          </a:p>
+        </p:txBody>
+      </p:sp>
+      <p:sp>
+        <p:nvSpPr>
+          <p:cNvPr id="3" name="Text 1"/>
+          <p:cNvSpPr/>
+          <p:nvPr/>
+        </p:nvSpPr>
+        <p:spPr>
+          <a:xfrm>
+            <a:off x="566928" y="896112"/>
+            <a:ext cx="11247120" cy="914400"/>
+          </a:xfrm>
+          <a:prstGeom prst="rect">
+            <a:avLst/>
+          </a:prstGeom>
+          <a:noFill/>
+          <a:ln/>
+        </p:spPr>
+        <p:txBody>
+          <a:bodyPr wrap="square" lIns="0" tIns="0" rIns="0" bIns="0" rtlCol="0" anchor="t"/>
+          <a:lstStyle/>
+          <a:p>
+            <a:pPr algn="l" indent="0" marL="0">
+              <a:lnSpc>
+                <a:spcPct val="95000"/>
+              </a:lnSpc>
+              <a:buNone/>
+            </a:pPr>
+            <a:r>
+              <a:rPr lang="en-US" sz="2600" b="1" dirty="0">
+                <a:solidFill>
+                  <a:srgbClr val="EDEDED"/>
+                </a:solidFill>
+                <a:latin typeface="Trebuchet MS" pitchFamily="34" charset="0"/>
+                <a:ea typeface="Trebuchet MS" pitchFamily="34" charset="-122"/>
+                <a:cs typeface="Trebuchet MS" pitchFamily="34" charset="-120"/>
+              </a:rPr>
+              <a:t>Thompson Sampling (Beta-Bernoulli)</a:t>
+            </a:r>
+            <a:endParaRPr lang="en-US" sz="2600" dirty="0"/>
+          </a:p>
+        </p:txBody>
+      </p:sp>
+      <p:sp>
+        <p:nvSpPr>
+          <p:cNvPr id="4" name="Shape 2"/>
+          <p:cNvSpPr/>
+          <p:nvPr/>
+        </p:nvSpPr>
+        <p:spPr>
+          <a:xfrm>
+            <a:off x="566928" y="1783080"/>
+            <a:ext cx="4526280" cy="2240280"/>
+          </a:xfrm>
+          <a:prstGeom prst="roundRect">
+            <a:avLst>
+              <a:gd name="adj" fmla="val 3673"/>
+            </a:avLst>
+          </a:prstGeom>
+          <a:solidFill>
+            <a:srgbClr val="0C0C0E"/>
+          </a:solidFill>
+          <a:ln w="12700">
+            <a:solidFill>
+              <a:srgbClr val="2A2A30"/>
+            </a:solidFill>
+            <a:prstDash val="solid"/>
+          </a:ln>
+          <a:effectLst>
+            <a:outerShdw sx="100000" sy="100000" kx="0" ky="0" algn="bl" rotWithShape="0" blurRad="114300" dist="38100" dir="8100000">
+              <a:srgbClr val="000000">
+                <a:alpha val="45000"/>
+              </a:srgbClr>
+            </a:outerShdw>
+          </a:effectLst>
+        </p:spPr>
+      </p:sp>
+      <p:sp>
+        <p:nvSpPr>
+          <p:cNvPr id="5" name="Text 3"/>
+          <p:cNvSpPr/>
+          <p:nvPr/>
+        </p:nvSpPr>
+        <p:spPr>
+          <a:xfrm>
+            <a:off x="795528" y="1938528"/>
+            <a:ext cx="4069080" cy="256032"/>
+          </a:xfrm>
+          <a:prstGeom prst="rect">
+            <a:avLst/>
+          </a:prstGeom>
+          <a:noFill/>
+          <a:ln/>
+        </p:spPr>
+        <p:txBody>
+          <a:bodyPr wrap="square" lIns="0" tIns="0" rIns="0" bIns="0" rtlCol="0" anchor="ctr"/>
+          <a:lstStyle/>
+          <a:p>
+            <a:pPr indent="0" marL="0">
+              <a:buNone/>
+            </a:pPr>
+            <a:r>
+              <a:rPr lang="en-US" sz="1000" b="1" spc="200" kern="0" dirty="0">
+                <a:solidFill>
+                  <a:srgbClr val="34D399"/>
+                </a:solidFill>
+                <a:latin typeface="Consolas" pitchFamily="34" charset="0"/>
+                <a:ea typeface="Consolas" pitchFamily="34" charset="-122"/>
+                <a:cs typeface="Consolas" pitchFamily="34" charset="-120"/>
+              </a:rPr>
+              <a:t>MATEMÁTICA</a:t>
+            </a:r>
+            <a:endParaRPr lang="en-US" sz="1000" dirty="0"/>
+          </a:p>
+        </p:txBody>
+      </p:sp>
+      <p:pic>
+        <p:nvPicPr>
+          <p:cNvPr id="6" name="Image 0" descr="C:\Users\Dione\Desktop\datathon-7mlet-grupo-64\datathon-7mlet-grupo-64\.pptx-build/tech/eq_thompson.png">    </p:cNvPr>
+          <p:cNvPicPr>
+            <a:picLocks noChangeAspect="1"/>
+          </p:cNvPicPr>
+          <p:nvPr/>
+        </p:nvPicPr>
+        <p:blipFill>
+          <a:blip r:embed="rId1"/>
+          <a:srcRect l="0" r="0" t="0" b="0"/>
+          <a:stretch/>
+        </p:blipFill>
+        <p:spPr>
+          <a:xfrm>
+            <a:off x="749808" y="2249424"/>
+            <a:ext cx="4160520" cy="1627632"/>
+          </a:xfrm>
+          <a:prstGeom prst="rect">
+            <a:avLst/>
+          </a:prstGeom>
+        </p:spPr>
+      </p:pic>
+      <p:sp>
+        <p:nvSpPr>
+          <p:cNvPr id="7" name="Text 4"/>
+          <p:cNvSpPr/>
+          <p:nvPr/>
+        </p:nvSpPr>
+        <p:spPr>
+          <a:xfrm>
+            <a:off x="585216" y="4206240"/>
+            <a:ext cx="4526280" cy="237744"/>
+          </a:xfrm>
+          <a:prstGeom prst="rect">
+            <a:avLst/>
+          </a:prstGeom>
+          <a:noFill/>
+          <a:ln/>
+        </p:spPr>
+        <p:txBody>
+          <a:bodyPr wrap="square" lIns="0" tIns="0" rIns="0" bIns="0" rtlCol="0" anchor="ctr"/>
+          <a:lstStyle/>
+          <a:p>
+            <a:pPr indent="0" marL="0">
+              <a:buNone/>
+            </a:pPr>
+            <a:r>
+              <a:rPr lang="en-US" sz="950" b="1" spc="200" kern="0" dirty="0">
+                <a:solidFill>
+                  <a:srgbClr val="9A9AA6"/>
+                </a:solidFill>
+                <a:latin typeface="Consolas" pitchFamily="34" charset="0"/>
+                <a:ea typeface="Consolas" pitchFamily="34" charset="-122"/>
+                <a:cs typeface="Consolas" pitchFamily="34" charset="-120"/>
+              </a:rPr>
+              <a:t>REFERÊNCIA</a:t>
+            </a:r>
+            <a:endParaRPr lang="en-US" sz="950" dirty="0"/>
+          </a:p>
+        </p:txBody>
+      </p:sp>
+      <p:sp>
+        <p:nvSpPr>
+          <p:cNvPr id="8" name="Text 5"/>
+          <p:cNvSpPr/>
+          <p:nvPr/>
+        </p:nvSpPr>
+        <p:spPr>
+          <a:xfrm>
+            <a:off x="585216" y="4443984"/>
+            <a:ext cx="4663440" cy="566928"/>
+          </a:xfrm>
+          <a:prstGeom prst="rect">
+            <a:avLst/>
+          </a:prstGeom>
+          <a:noFill/>
+          <a:ln/>
+        </p:spPr>
+        <p:txBody>
+          <a:bodyPr wrap="square" lIns="0" tIns="0" rIns="0" bIns="0" rtlCol="0" anchor="ctr"/>
+          <a:lstStyle/>
+          <a:p>
+            <a:pPr indent="0" marL="0">
+              <a:lnSpc>
+                <a:spcPct val="103000"/>
+              </a:lnSpc>
+              <a:buNone/>
+            </a:pPr>
+            <a:r>
+              <a:rPr lang="en-US" sz="1250" b="1" dirty="0">
+                <a:solidFill>
+                  <a:srgbClr val="EDEDED"/>
+                </a:solidFill>
+                <a:latin typeface="Calibri" pitchFamily="34" charset="0"/>
+                <a:ea typeface="Calibri" pitchFamily="34" charset="-122"/>
+                <a:cs typeface="Calibri" pitchFamily="34" charset="-120"/>
+              </a:rPr>
+              <a:t>Thompson (1933) · Agrawal &amp; Goyal (2012).</a:t>
+            </a:r>
+            <a:endParaRPr lang="en-US" sz="1250" dirty="0"/>
+          </a:p>
+        </p:txBody>
+      </p:sp>
+      <p:sp>
+        <p:nvSpPr>
+          <p:cNvPr id="9" name="Text 6"/>
+          <p:cNvSpPr/>
+          <p:nvPr/>
+        </p:nvSpPr>
+        <p:spPr>
+          <a:xfrm>
+            <a:off x="585216" y="5074920"/>
+            <a:ext cx="4663440" cy="868680"/>
+          </a:xfrm>
+          <a:prstGeom prst="rect">
+            <a:avLst/>
+          </a:prstGeom>
+          <a:noFill/>
+          <a:ln/>
+        </p:spPr>
+        <p:txBody>
+          <a:bodyPr wrap="square" lIns="0" tIns="0" rIns="0" bIns="0" rtlCol="0" anchor="ctr"/>
+          <a:lstStyle/>
+          <a:p>
+            <a:pPr indent="0" marL="0">
+              <a:lnSpc>
+                <a:spcPct val="105000"/>
+              </a:lnSpc>
+              <a:buNone/>
+            </a:pPr>
+            <a:r>
+              <a:rPr lang="en-US" sz="1250" dirty="0">
+                <a:solidFill>
+                  <a:srgbClr val="9A9AA6"/>
+                </a:solidFill>
+                <a:latin typeface="Calibri" pitchFamily="34" charset="0"/>
+                <a:ea typeface="Calibri" pitchFamily="34" charset="-122"/>
+                <a:cs typeface="Calibri" pitchFamily="34" charset="-120"/>
+              </a:rPr>
+              <a:t>Amostrar do posterior É a exploração: braços com pouca evidência têm posterior largo e às vezes são sorteados alto.</a:t>
+            </a:r>
+            <a:endParaRPr lang="en-US" sz="1250" dirty="0"/>
+          </a:p>
+        </p:txBody>
+      </p:sp>
+      <p:sp>
+        <p:nvSpPr>
+          <p:cNvPr id="10" name="Shape 7"/>
+          <p:cNvSpPr/>
+          <p:nvPr/>
+        </p:nvSpPr>
+        <p:spPr>
+          <a:xfrm>
+            <a:off x="5349240" y="1783080"/>
+            <a:ext cx="6272784" cy="4114800"/>
+          </a:xfrm>
+          <a:prstGeom prst="roundRect">
+            <a:avLst>
+              <a:gd name="adj" fmla="val 2000"/>
+            </a:avLst>
+          </a:prstGeom>
+          <a:solidFill>
+            <a:srgbClr val="272822"/>
+          </a:solidFill>
+          <a:ln w="12700">
+            <a:solidFill>
+              <a:srgbClr val="2A2A30"/>
+            </a:solidFill>
+            <a:prstDash val="solid"/>
+          </a:ln>
+          <a:effectLst>
+            <a:outerShdw sx="100000" sy="100000" kx="0" ky="0" algn="bl" rotWithShape="0" blurRad="114300" dist="38100" dir="8100000">
+              <a:srgbClr val="000000">
+                <a:alpha val="45000"/>
+              </a:srgbClr>
+            </a:outerShdw>
+          </a:effectLst>
+        </p:spPr>
+      </p:sp>
+      <p:pic>
+        <p:nvPicPr>
+          <p:cNvPr id="11" name="Image 1" descr="C:\Users\Dione\Desktop\datathon-7mlet-grupo-64\datathon-7mlet-grupo-64\.pptx-build/tech/code_thompson.png">    </p:cNvPr>
+          <p:cNvPicPr>
+            <a:picLocks noChangeAspect="1"/>
+          </p:cNvPicPr>
+          <p:nvPr/>
+        </p:nvPicPr>
+        <p:blipFill>
+          <a:blip r:embed="rId2"/>
+          <a:srcRect l="0" r="0" t="0" b="0"/>
+          <a:stretch/>
+        </p:blipFill>
+        <p:spPr>
+          <a:xfrm>
+            <a:off x="5532120" y="1938528"/>
+            <a:ext cx="5907024" cy="3566160"/>
+          </a:xfrm>
+          <a:prstGeom prst="rect">
+            <a:avLst/>
+          </a:prstGeom>
+        </p:spPr>
+      </p:pic>
+      <p:sp>
+        <p:nvSpPr>
+          <p:cNvPr id="12" name="Text 8"/>
+          <p:cNvSpPr/>
+          <p:nvPr/>
+        </p:nvSpPr>
+        <p:spPr>
+          <a:xfrm>
+            <a:off x="5550408" y="5541264"/>
+            <a:ext cx="5870448" cy="274320"/>
+          </a:xfrm>
+          <a:prstGeom prst="rect">
+            <a:avLst/>
+          </a:prstGeom>
+          <a:noFill/>
+          <a:ln/>
+        </p:spPr>
+        <p:txBody>
+          <a:bodyPr wrap="square" lIns="0" tIns="0" rIns="0" bIns="0" rtlCol="0" anchor="ctr"/>
+          <a:lstStyle/>
+          <a:p>
+            <a:pPr indent="0" marL="0">
+              <a:buNone/>
+            </a:pPr>
+            <a:r>
+              <a:rPr lang="en-US" sz="1050" b="1" dirty="0">
+                <a:solidFill>
+                  <a:srgbClr val="34D399"/>
+                </a:solidFill>
+                <a:latin typeface="Consolas" pitchFamily="34" charset="0"/>
+                <a:ea typeface="Consolas" pitchFamily="34" charset="-122"/>
+                <a:cs typeface="Consolas" pitchFamily="34" charset="-120"/>
+              </a:rPr>
+              <a:t>src/adaptive_offers/bandits/thompson.py</a:t>
+            </a:r>
+            <a:endParaRPr lang="en-US" sz="1050" dirty="0"/>
+          </a:p>
+        </p:txBody>
+      </p:sp>
+      <p:sp>
+        <p:nvSpPr>
+          <p:cNvPr id="13" name="Text 9"/>
+          <p:cNvSpPr/>
+          <p:nvPr/>
+        </p:nvSpPr>
+        <p:spPr>
+          <a:xfrm>
+            <a:off x="566928" y="6437376"/>
+            <a:ext cx="4572000" cy="274320"/>
+          </a:xfrm>
+          <a:prstGeom prst="rect">
+            <a:avLst/>
+          </a:prstGeom>
+          <a:noFill/>
+          <a:ln/>
+        </p:spPr>
+        <p:txBody>
+          <a:bodyPr wrap="square" lIns="0" tIns="0" rIns="0" bIns="0" rtlCol="0" anchor="ctr"/>
+          <a:lstStyle/>
+          <a:p>
+            <a:pPr algn="l" indent="0" marL="0">
+              <a:buNone/>
+            </a:pPr>
+            <a:r>
+              <a:rPr lang="en-US" sz="850" spc="200" kern="0" dirty="0">
+                <a:solidFill>
+                  <a:srgbClr val="5A5A63"/>
+                </a:solidFill>
+                <a:latin typeface="Consolas" pitchFamily="34" charset="0"/>
+                <a:ea typeface="Consolas" pitchFamily="34" charset="-122"/>
+                <a:cs typeface="Consolas" pitchFamily="34" charset="-120"/>
+              </a:rPr>
+              <a:t>ADAPTIVE OFFERS PLATFORM</a:t>
+            </a:r>
+            <a:endParaRPr lang="en-US" sz="850" dirty="0"/>
+          </a:p>
+        </p:txBody>
+      </p:sp>
+      <p:sp>
+        <p:nvSpPr>
+          <p:cNvPr id="14" name="Text 10"/>
+          <p:cNvSpPr/>
+          <p:nvPr/>
+        </p:nvSpPr>
+        <p:spPr>
+          <a:xfrm>
+            <a:off x="7050024" y="6437376"/>
+            <a:ext cx="4572000" cy="274320"/>
+          </a:xfrm>
+          <a:prstGeom prst="rect">
+            <a:avLst/>
+          </a:prstGeom>
+          <a:noFill/>
+          <a:ln/>
+        </p:spPr>
+        <p:txBody>
+          <a:bodyPr wrap="square" lIns="0" tIns="0" rIns="0" bIns="0" rtlCol="0" anchor="ctr"/>
+          <a:lstStyle/>
+          <a:p>
+            <a:pPr algn="r" indent="0" marL="0">
+              <a:buNone/>
+            </a:pPr>
+            <a:r>
+              <a:rPr lang="en-US" sz="850" spc="200" kern="0" dirty="0">
+                <a:solidFill>
+                  <a:srgbClr val="5A5A63"/>
+                </a:solidFill>
+                <a:latin typeface="Consolas" pitchFamily="34" charset="0"/>
+                <a:ea typeface="Consolas" pitchFamily="34" charset="-122"/>
+                <a:cs typeface="Consolas" pitchFamily="34" charset="-120"/>
+              </a:rPr>
+              <a:t>GRUPO 64 · FIAP PÓS-TECH 7MLET</a:t>
+            </a:r>
+            <a:endParaRPr lang="en-US" sz="850" dirty="0"/>
+          </a:p>
+        </p:txBody>
+      </p:sp>
+      <p:sp>
+        <p:nvSpPr>
+          <p:cNvPr id="15" name="Text 11"/>
+          <p:cNvSpPr/>
+          <p:nvPr/>
+        </p:nvSpPr>
+        <p:spPr>
+          <a:xfrm>
+            <a:off x="5820156" y="6437376"/>
+            <a:ext cx="548640" cy="274320"/>
+          </a:xfrm>
+          <a:prstGeom prst="rect">
+            <a:avLst/>
+          </a:prstGeom>
+          <a:noFill/>
+          <a:ln/>
+        </p:spPr>
+        <p:txBody>
+          <a:bodyPr wrap="square" lIns="0" tIns="0" rIns="0" bIns="0" rtlCol="0" anchor="ctr"/>
+          <a:lstStyle/>
+          <a:p>
+            <a:pPr algn="ctr" indent="0" marL="0">
+              <a:buNone/>
+            </a:pPr>
+            <a:r>
+              <a:rPr lang="en-US" sz="850" b="1" dirty="0">
+                <a:solidFill>
+                  <a:srgbClr val="0070F3"/>
+                </a:solidFill>
+                <a:latin typeface="Consolas" pitchFamily="34" charset="0"/>
+                <a:ea typeface="Consolas" pitchFamily="34" charset="-122"/>
+                <a:cs typeface="Consolas" pitchFamily="34" charset="-120"/>
+              </a:rPr>
+              <a:t>16</a:t>
+            </a:r>
+            <a:endParaRPr lang="en-US" sz="850" dirty="0"/>
+          </a:p>
+        </p:txBody>
+      </p:sp>
+    </p:spTree>
+  </p:cSld>
+  <p:clrMapOvr>
+    <a:masterClrMapping/>
+  </p:clrMapOvr>
+</p:sld>
+</file>
+
+<file path=ppt/slides/slide17.xml><?xml version="1.0" encoding="utf-8"?>
+<p:sld xmlns:a="http://schemas.openxmlformats.org/drawingml/2006/main" xmlns:r="http://schemas.openxmlformats.org/officeDocument/2006/relationships" xmlns:p="http://schemas.openxmlformats.org/presentationml/2006/main">
+  <p:cSld name="Slide 17">
+    <p:bg>
+      <p:bgPr>
+        <a:solidFill>
+          <a:srgbClr val="000000"/>
+        </a:solidFill>
+      </p:bgPr>
+    </p:bg>
+    <p:spTree>
+      <p:nvGrpSpPr>
+        <p:cNvPr id="1" name=""/>
+        <p:cNvGrpSpPr/>
+        <p:nvPr/>
+      </p:nvGrpSpPr>
+      <p:grpSpPr>
+        <a:xfrm>
+          <a:off x="0" y="0"/>
+          <a:ext cx="0" cy="0"/>
+          <a:chOff x="0" y="0"/>
+          <a:chExt cx="0" cy="0"/>
+        </a:xfrm>
+      </p:grpSpPr>
+      <p:sp>
+        <p:nvSpPr>
+          <p:cNvPr id="2" name="Text 0"/>
+          <p:cNvSpPr/>
+          <p:nvPr/>
+        </p:nvSpPr>
+        <p:spPr>
+          <a:xfrm>
+            <a:off x="566928" y="566928"/>
+            <a:ext cx="8229600" cy="274320"/>
+          </a:xfrm>
+          <a:prstGeom prst="rect">
+            <a:avLst/>
+          </a:prstGeom>
+          <a:noFill/>
+          <a:ln/>
+        </p:spPr>
+        <p:txBody>
+          <a:bodyPr wrap="square" lIns="0" tIns="0" rIns="0" bIns="0" rtlCol="0" anchor="ctr"/>
+          <a:lstStyle/>
+          <a:p>
+            <a:pPr algn="l" indent="0" marL="0">
+              <a:buNone/>
+            </a:pPr>
+            <a:r>
+              <a:rPr lang="en-US" sz="1150" b="1" spc="300" kern="0" dirty="0">
+                <a:solidFill>
+                  <a:srgbClr val="3291FF"/>
+                </a:solidFill>
+                <a:latin typeface="Consolas" pitchFamily="34" charset="0"/>
+                <a:ea typeface="Consolas" pitchFamily="34" charset="-122"/>
+                <a:cs typeface="Consolas" pitchFamily="34" charset="-120"/>
+              </a:rPr>
+              <a:t>APÊNDICE TÉCNICO · UCB</a:t>
+            </a:r>
+            <a:endParaRPr lang="en-US" sz="1150" dirty="0"/>
+          </a:p>
+        </p:txBody>
+      </p:sp>
+      <p:sp>
+        <p:nvSpPr>
+          <p:cNvPr id="3" name="Text 1"/>
+          <p:cNvSpPr/>
+          <p:nvPr/>
+        </p:nvSpPr>
+        <p:spPr>
+          <a:xfrm>
+            <a:off x="566928" y="896112"/>
+            <a:ext cx="11247120" cy="914400"/>
+          </a:xfrm>
+          <a:prstGeom prst="rect">
+            <a:avLst/>
+          </a:prstGeom>
+          <a:noFill/>
+          <a:ln/>
+        </p:spPr>
+        <p:txBody>
+          <a:bodyPr wrap="square" lIns="0" tIns="0" rIns="0" bIns="0" rtlCol="0" anchor="t"/>
+          <a:lstStyle/>
+          <a:p>
+            <a:pPr algn="l" indent="0" marL="0">
+              <a:lnSpc>
+                <a:spcPct val="95000"/>
+              </a:lnSpc>
+              <a:buNone/>
+            </a:pPr>
+            <a:r>
+              <a:rPr lang="en-US" sz="2600" b="1" dirty="0">
+                <a:solidFill>
+                  <a:srgbClr val="EDEDED"/>
+                </a:solidFill>
+                <a:latin typeface="Trebuchet MS" pitchFamily="34" charset="0"/>
+                <a:ea typeface="Trebuchet MS" pitchFamily="34" charset="-122"/>
+                <a:cs typeface="Trebuchet MS" pitchFamily="34" charset="-120"/>
+              </a:rPr>
+              <a:t>Nilos-UCB — UCB-V (consciente de variância)</a:t>
+            </a:r>
+            <a:endParaRPr lang="en-US" sz="2600" dirty="0"/>
+          </a:p>
+        </p:txBody>
+      </p:sp>
+      <p:sp>
+        <p:nvSpPr>
+          <p:cNvPr id="4" name="Shape 2"/>
+          <p:cNvSpPr/>
+          <p:nvPr/>
+        </p:nvSpPr>
+        <p:spPr>
+          <a:xfrm>
+            <a:off x="566928" y="1783080"/>
+            <a:ext cx="4526280" cy="2240280"/>
+          </a:xfrm>
+          <a:prstGeom prst="roundRect">
+            <a:avLst>
+              <a:gd name="adj" fmla="val 3673"/>
+            </a:avLst>
+          </a:prstGeom>
+          <a:solidFill>
+            <a:srgbClr val="0C0C0E"/>
+          </a:solidFill>
+          <a:ln w="12700">
+            <a:solidFill>
+              <a:srgbClr val="2A2A30"/>
+            </a:solidFill>
+            <a:prstDash val="solid"/>
+          </a:ln>
+          <a:effectLst>
+            <a:outerShdw sx="100000" sy="100000" kx="0" ky="0" algn="bl" rotWithShape="0" blurRad="114300" dist="38100" dir="8100000">
+              <a:srgbClr val="000000">
+                <a:alpha val="45000"/>
+              </a:srgbClr>
+            </a:outerShdw>
+          </a:effectLst>
+        </p:spPr>
+      </p:sp>
+      <p:sp>
+        <p:nvSpPr>
+          <p:cNvPr id="5" name="Text 3"/>
+          <p:cNvSpPr/>
+          <p:nvPr/>
+        </p:nvSpPr>
+        <p:spPr>
+          <a:xfrm>
+            <a:off x="795528" y="1938528"/>
+            <a:ext cx="4069080" cy="256032"/>
+          </a:xfrm>
+          <a:prstGeom prst="rect">
+            <a:avLst/>
+          </a:prstGeom>
+          <a:noFill/>
+          <a:ln/>
+        </p:spPr>
+        <p:txBody>
+          <a:bodyPr wrap="square" lIns="0" tIns="0" rIns="0" bIns="0" rtlCol="0" anchor="ctr"/>
+          <a:lstStyle/>
+          <a:p>
+            <a:pPr indent="0" marL="0">
+              <a:buNone/>
+            </a:pPr>
+            <a:r>
+              <a:rPr lang="en-US" sz="1000" b="1" spc="200" kern="0" dirty="0">
+                <a:solidFill>
+                  <a:srgbClr val="F5A623"/>
+                </a:solidFill>
+                <a:latin typeface="Consolas" pitchFamily="34" charset="0"/>
+                <a:ea typeface="Consolas" pitchFamily="34" charset="-122"/>
+                <a:cs typeface="Consolas" pitchFamily="34" charset="-120"/>
+              </a:rPr>
+              <a:t>MATEMÁTICA</a:t>
+            </a:r>
+            <a:endParaRPr lang="en-US" sz="1000" dirty="0"/>
+          </a:p>
+        </p:txBody>
+      </p:sp>
+      <p:pic>
+        <p:nvPicPr>
+          <p:cNvPr id="6" name="Image 0" descr="C:\Users\Dione\Desktop\datathon-7mlet-grupo-64\datathon-7mlet-grupo-64\.pptx-build/tech/eq_nilos.png">    </p:cNvPr>
+          <p:cNvPicPr>
+            <a:picLocks noChangeAspect="1"/>
+          </p:cNvPicPr>
+          <p:nvPr/>
+        </p:nvPicPr>
+        <p:blipFill>
+          <a:blip r:embed="rId1"/>
+          <a:srcRect l="0" r="0" t="0" b="0"/>
+          <a:stretch/>
+        </p:blipFill>
+        <p:spPr>
+          <a:xfrm>
+            <a:off x="749808" y="2249424"/>
+            <a:ext cx="4160520" cy="1627632"/>
+          </a:xfrm>
+          <a:prstGeom prst="rect">
+            <a:avLst/>
+          </a:prstGeom>
+        </p:spPr>
+      </p:pic>
+      <p:sp>
+        <p:nvSpPr>
+          <p:cNvPr id="7" name="Text 4"/>
+          <p:cNvSpPr/>
+          <p:nvPr/>
+        </p:nvSpPr>
+        <p:spPr>
+          <a:xfrm>
+            <a:off x="585216" y="4206240"/>
+            <a:ext cx="4526280" cy="237744"/>
+          </a:xfrm>
+          <a:prstGeom prst="rect">
+            <a:avLst/>
+          </a:prstGeom>
+          <a:noFill/>
+          <a:ln/>
+        </p:spPr>
+        <p:txBody>
+          <a:bodyPr wrap="square" lIns="0" tIns="0" rIns="0" bIns="0" rtlCol="0" anchor="ctr"/>
+          <a:lstStyle/>
+          <a:p>
+            <a:pPr indent="0" marL="0">
+              <a:buNone/>
+            </a:pPr>
+            <a:r>
+              <a:rPr lang="en-US" sz="950" b="1" spc="200" kern="0" dirty="0">
+                <a:solidFill>
+                  <a:srgbClr val="9A9AA6"/>
+                </a:solidFill>
+                <a:latin typeface="Consolas" pitchFamily="34" charset="0"/>
+                <a:ea typeface="Consolas" pitchFamily="34" charset="-122"/>
+                <a:cs typeface="Consolas" pitchFamily="34" charset="-120"/>
+              </a:rPr>
+              <a:t>REFERÊNCIA</a:t>
+            </a:r>
+            <a:endParaRPr lang="en-US" sz="950" dirty="0"/>
+          </a:p>
+        </p:txBody>
+      </p:sp>
+      <p:sp>
+        <p:nvSpPr>
+          <p:cNvPr id="8" name="Text 5"/>
+          <p:cNvSpPr/>
+          <p:nvPr/>
+        </p:nvSpPr>
+        <p:spPr>
+          <a:xfrm>
+            <a:off x="585216" y="4443984"/>
+            <a:ext cx="4663440" cy="566928"/>
+          </a:xfrm>
+          <a:prstGeom prst="rect">
+            <a:avLst/>
+          </a:prstGeom>
+          <a:noFill/>
+          <a:ln/>
+        </p:spPr>
+        <p:txBody>
+          <a:bodyPr wrap="square" lIns="0" tIns="0" rIns="0" bIns="0" rtlCol="0" anchor="ctr"/>
+          <a:lstStyle/>
+          <a:p>
+            <a:pPr indent="0" marL="0">
+              <a:lnSpc>
+                <a:spcPct val="103000"/>
+              </a:lnSpc>
+              <a:buNone/>
+            </a:pPr>
+            <a:r>
+              <a:rPr lang="en-US" sz="1250" b="1" dirty="0">
+                <a:solidFill>
+                  <a:srgbClr val="EDEDED"/>
+                </a:solidFill>
+                <a:latin typeface="Calibri" pitchFamily="34" charset="0"/>
+                <a:ea typeface="Calibri" pitchFamily="34" charset="-122"/>
+                <a:cs typeface="Calibri" pitchFamily="34" charset="-120"/>
+              </a:rPr>
+              <a:t>Audibert, Munos &amp; Szepesvári (2009) — UCB-V.</a:t>
+            </a:r>
+            <a:endParaRPr lang="en-US" sz="1250" dirty="0"/>
+          </a:p>
+        </p:txBody>
+      </p:sp>
+      <p:sp>
+        <p:nvSpPr>
+          <p:cNvPr id="9" name="Text 6"/>
+          <p:cNvSpPr/>
+          <p:nvPr/>
+        </p:nvSpPr>
+        <p:spPr>
+          <a:xfrm>
+            <a:off x="585216" y="5074920"/>
+            <a:ext cx="4663440" cy="868680"/>
+          </a:xfrm>
+          <a:prstGeom prst="rect">
+            <a:avLst/>
+          </a:prstGeom>
+          <a:noFill/>
+          <a:ln/>
+        </p:spPr>
+        <p:txBody>
+          <a:bodyPr wrap="square" lIns="0" tIns="0" rIns="0" bIns="0" rtlCol="0" anchor="ctr"/>
+          <a:lstStyle/>
+          <a:p>
+            <a:pPr indent="0" marL="0">
+              <a:lnSpc>
+                <a:spcPct val="105000"/>
+              </a:lnSpc>
+              <a:buNone/>
+            </a:pPr>
+            <a:r>
+              <a:rPr lang="en-US" sz="1250" dirty="0">
+                <a:solidFill>
+                  <a:srgbClr val="9A9AA6"/>
+                </a:solidFill>
+                <a:latin typeface="Calibri" pitchFamily="34" charset="0"/>
+                <a:ea typeface="Calibri" pitchFamily="34" charset="-122"/>
+                <a:cs typeface="Calibri" pitchFamily="34" charset="-120"/>
+              </a:rPr>
+              <a:t>O bônus usa a variância empírica do braço (Welford online); ofertas de alta incerteza são exploradas mais cedo.</a:t>
+            </a:r>
+            <a:endParaRPr lang="en-US" sz="1250" dirty="0"/>
+          </a:p>
+        </p:txBody>
+      </p:sp>
+      <p:sp>
+        <p:nvSpPr>
+          <p:cNvPr id="10" name="Shape 7"/>
+          <p:cNvSpPr/>
+          <p:nvPr/>
+        </p:nvSpPr>
+        <p:spPr>
+          <a:xfrm>
+            <a:off x="5349240" y="1783080"/>
+            <a:ext cx="6272784" cy="4114800"/>
+          </a:xfrm>
+          <a:prstGeom prst="roundRect">
+            <a:avLst>
+              <a:gd name="adj" fmla="val 2000"/>
+            </a:avLst>
+          </a:prstGeom>
+          <a:solidFill>
+            <a:srgbClr val="272822"/>
+          </a:solidFill>
+          <a:ln w="12700">
+            <a:solidFill>
+              <a:srgbClr val="2A2A30"/>
+            </a:solidFill>
+            <a:prstDash val="solid"/>
+          </a:ln>
+          <a:effectLst>
+            <a:outerShdw sx="100000" sy="100000" kx="0" ky="0" algn="bl" rotWithShape="0" blurRad="114300" dist="38100" dir="8100000">
+              <a:srgbClr val="000000">
+                <a:alpha val="45000"/>
+              </a:srgbClr>
+            </a:outerShdw>
+          </a:effectLst>
+        </p:spPr>
+      </p:sp>
+      <p:pic>
+        <p:nvPicPr>
+          <p:cNvPr id="11" name="Image 1" descr="C:\Users\Dione\Desktop\datathon-7mlet-grupo-64\datathon-7mlet-grupo-64\.pptx-build/tech/code_nilos.png">    </p:cNvPr>
+          <p:cNvPicPr>
+            <a:picLocks noChangeAspect="1"/>
+          </p:cNvPicPr>
+          <p:nvPr/>
+        </p:nvPicPr>
+        <p:blipFill>
+          <a:blip r:embed="rId2"/>
+          <a:srcRect l="0" r="0" t="0" b="0"/>
+          <a:stretch/>
+        </p:blipFill>
+        <p:spPr>
+          <a:xfrm>
+            <a:off x="5532120" y="1938528"/>
+            <a:ext cx="5907024" cy="3566160"/>
+          </a:xfrm>
+          <a:prstGeom prst="rect">
+            <a:avLst/>
+          </a:prstGeom>
+        </p:spPr>
+      </p:pic>
+      <p:sp>
+        <p:nvSpPr>
+          <p:cNvPr id="12" name="Text 8"/>
+          <p:cNvSpPr/>
+          <p:nvPr/>
+        </p:nvSpPr>
+        <p:spPr>
+          <a:xfrm>
+            <a:off x="5550408" y="5541264"/>
+            <a:ext cx="5870448" cy="274320"/>
+          </a:xfrm>
+          <a:prstGeom prst="rect">
+            <a:avLst/>
+          </a:prstGeom>
+          <a:noFill/>
+          <a:ln/>
+        </p:spPr>
+        <p:txBody>
+          <a:bodyPr wrap="square" lIns="0" tIns="0" rIns="0" bIns="0" rtlCol="0" anchor="ctr"/>
+          <a:lstStyle/>
+          <a:p>
+            <a:pPr indent="0" marL="0">
+              <a:buNone/>
+            </a:pPr>
+            <a:r>
+              <a:rPr lang="en-US" sz="1050" b="1" dirty="0">
+                <a:solidFill>
+                  <a:srgbClr val="F5A623"/>
+                </a:solidFill>
+                <a:latin typeface="Consolas" pitchFamily="34" charset="0"/>
+                <a:ea typeface="Consolas" pitchFamily="34" charset="-122"/>
+                <a:cs typeface="Consolas" pitchFamily="34" charset="-120"/>
+              </a:rPr>
+              <a:t>src/adaptive_offers/bandits/ucb.py</a:t>
+            </a:r>
+            <a:endParaRPr lang="en-US" sz="1050" dirty="0"/>
+          </a:p>
+        </p:txBody>
+      </p:sp>
+      <p:sp>
+        <p:nvSpPr>
+          <p:cNvPr id="13" name="Text 9"/>
+          <p:cNvSpPr/>
+          <p:nvPr/>
+        </p:nvSpPr>
+        <p:spPr>
+          <a:xfrm>
+            <a:off x="566928" y="6437376"/>
+            <a:ext cx="4572000" cy="274320"/>
+          </a:xfrm>
+          <a:prstGeom prst="rect">
+            <a:avLst/>
+          </a:prstGeom>
+          <a:noFill/>
+          <a:ln/>
+        </p:spPr>
+        <p:txBody>
+          <a:bodyPr wrap="square" lIns="0" tIns="0" rIns="0" bIns="0" rtlCol="0" anchor="ctr"/>
+          <a:lstStyle/>
+          <a:p>
+            <a:pPr algn="l" indent="0" marL="0">
+              <a:buNone/>
+            </a:pPr>
+            <a:r>
+              <a:rPr lang="en-US" sz="850" spc="200" kern="0" dirty="0">
+                <a:solidFill>
+                  <a:srgbClr val="5A5A63"/>
+                </a:solidFill>
+                <a:latin typeface="Consolas" pitchFamily="34" charset="0"/>
+                <a:ea typeface="Consolas" pitchFamily="34" charset="-122"/>
+                <a:cs typeface="Consolas" pitchFamily="34" charset="-120"/>
+              </a:rPr>
+              <a:t>ADAPTIVE OFFERS PLATFORM</a:t>
+            </a:r>
+            <a:endParaRPr lang="en-US" sz="850" dirty="0"/>
+          </a:p>
+        </p:txBody>
+      </p:sp>
+      <p:sp>
+        <p:nvSpPr>
+          <p:cNvPr id="14" name="Text 10"/>
+          <p:cNvSpPr/>
+          <p:nvPr/>
+        </p:nvSpPr>
+        <p:spPr>
+          <a:xfrm>
+            <a:off x="7050024" y="6437376"/>
+            <a:ext cx="4572000" cy="274320"/>
+          </a:xfrm>
+          <a:prstGeom prst="rect">
+            <a:avLst/>
+          </a:prstGeom>
+          <a:noFill/>
+          <a:ln/>
+        </p:spPr>
+        <p:txBody>
+          <a:bodyPr wrap="square" lIns="0" tIns="0" rIns="0" bIns="0" rtlCol="0" anchor="ctr"/>
+          <a:lstStyle/>
+          <a:p>
+            <a:pPr algn="r" indent="0" marL="0">
+              <a:buNone/>
+            </a:pPr>
+            <a:r>
+              <a:rPr lang="en-US" sz="850" spc="200" kern="0" dirty="0">
+                <a:solidFill>
+                  <a:srgbClr val="5A5A63"/>
+                </a:solidFill>
+                <a:latin typeface="Consolas" pitchFamily="34" charset="0"/>
+                <a:ea typeface="Consolas" pitchFamily="34" charset="-122"/>
+                <a:cs typeface="Consolas" pitchFamily="34" charset="-120"/>
+              </a:rPr>
+              <a:t>GRUPO 64 · FIAP PÓS-TECH 7MLET</a:t>
+            </a:r>
+            <a:endParaRPr lang="en-US" sz="850" dirty="0"/>
+          </a:p>
+        </p:txBody>
+      </p:sp>
+      <p:sp>
+        <p:nvSpPr>
+          <p:cNvPr id="15" name="Text 11"/>
+          <p:cNvSpPr/>
+          <p:nvPr/>
+        </p:nvSpPr>
+        <p:spPr>
+          <a:xfrm>
+            <a:off x="5820156" y="6437376"/>
+            <a:ext cx="548640" cy="274320"/>
+          </a:xfrm>
+          <a:prstGeom prst="rect">
+            <a:avLst/>
+          </a:prstGeom>
+          <a:noFill/>
+          <a:ln/>
+        </p:spPr>
+        <p:txBody>
+          <a:bodyPr wrap="square" lIns="0" tIns="0" rIns="0" bIns="0" rtlCol="0" anchor="ctr"/>
+          <a:lstStyle/>
+          <a:p>
+            <a:pPr algn="ctr" indent="0" marL="0">
+              <a:buNone/>
+            </a:pPr>
+            <a:r>
+              <a:rPr lang="en-US" sz="850" b="1" dirty="0">
+                <a:solidFill>
+                  <a:srgbClr val="0070F3"/>
+                </a:solidFill>
+                <a:latin typeface="Consolas" pitchFamily="34" charset="0"/>
+                <a:ea typeface="Consolas" pitchFamily="34" charset="-122"/>
+                <a:cs typeface="Consolas" pitchFamily="34" charset="-120"/>
+              </a:rPr>
+              <a:t>17</a:t>
+            </a:r>
+            <a:endParaRPr lang="en-US" sz="850" dirty="0"/>
+          </a:p>
+        </p:txBody>
+      </p:sp>
+    </p:spTree>
+  </p:cSld>
+  <p:clrMapOvr>
+    <a:masterClrMapping/>
+  </p:clrMapOvr>
+</p:sld>
+</file>
+
+<file path=ppt/slides/slide18.xml><?xml version="1.0" encoding="utf-8"?>
+<p:sld xmlns:a="http://schemas.openxmlformats.org/drawingml/2006/main" xmlns:r="http://schemas.openxmlformats.org/officeDocument/2006/relationships" xmlns:p="http://schemas.openxmlformats.org/presentationml/2006/main">
+  <p:cSld name="Slide 18">
+    <p:bg>
+      <p:bgPr>
+        <a:solidFill>
+          <a:srgbClr val="000000"/>
+        </a:solidFill>
+      </p:bgPr>
+    </p:bg>
+    <p:spTree>
+      <p:nvGrpSpPr>
+        <p:cNvPr id="1" name=""/>
+        <p:cNvGrpSpPr/>
+        <p:nvPr/>
+      </p:nvGrpSpPr>
+      <p:grpSpPr>
+        <a:xfrm>
+          <a:off x="0" y="0"/>
+          <a:ext cx="0" cy="0"/>
+          <a:chOff x="0" y="0"/>
+          <a:chExt cx="0" cy="0"/>
+        </a:xfrm>
+      </p:grpSpPr>
+      <p:sp>
+        <p:nvSpPr>
+          <p:cNvPr id="2" name="Text 0"/>
+          <p:cNvSpPr/>
+          <p:nvPr/>
+        </p:nvSpPr>
+        <p:spPr>
+          <a:xfrm>
+            <a:off x="566928" y="566928"/>
+            <a:ext cx="8229600" cy="274320"/>
+          </a:xfrm>
+          <a:prstGeom prst="rect">
+            <a:avLst/>
+          </a:prstGeom>
+          <a:noFill/>
+          <a:ln/>
+        </p:spPr>
+        <p:txBody>
+          <a:bodyPr wrap="square" lIns="0" tIns="0" rIns="0" bIns="0" rtlCol="0" anchor="ctr"/>
+          <a:lstStyle/>
+          <a:p>
+            <a:pPr algn="l" indent="0" marL="0">
+              <a:buNone/>
+            </a:pPr>
+            <a:r>
+              <a:rPr lang="en-US" sz="1150" b="1" spc="300" kern="0" dirty="0">
+                <a:solidFill>
+                  <a:srgbClr val="3291FF"/>
+                </a:solidFill>
+                <a:latin typeface="Consolas" pitchFamily="34" charset="0"/>
+                <a:ea typeface="Consolas" pitchFamily="34" charset="-122"/>
+                <a:cs typeface="Consolas" pitchFamily="34" charset="-120"/>
+              </a:rPr>
+              <a:t>APÊNDICE TÉCNICO · CONTEXTUAL</a:t>
+            </a:r>
+            <a:endParaRPr lang="en-US" sz="1150" dirty="0"/>
+          </a:p>
+        </p:txBody>
+      </p:sp>
+      <p:sp>
+        <p:nvSpPr>
+          <p:cNvPr id="3" name="Text 1"/>
+          <p:cNvSpPr/>
+          <p:nvPr/>
+        </p:nvSpPr>
+        <p:spPr>
+          <a:xfrm>
+            <a:off x="566928" y="896112"/>
+            <a:ext cx="11247120" cy="914400"/>
+          </a:xfrm>
+          <a:prstGeom prst="rect">
+            <a:avLst/>
+          </a:prstGeom>
+          <a:noFill/>
+          <a:ln/>
+        </p:spPr>
+        <p:txBody>
+          <a:bodyPr wrap="square" lIns="0" tIns="0" rIns="0" bIns="0" rtlCol="0" anchor="t"/>
+          <a:lstStyle/>
+          <a:p>
+            <a:pPr algn="l" indent="0" marL="0">
+              <a:lnSpc>
+                <a:spcPct val="95000"/>
+              </a:lnSpc>
+              <a:buNone/>
+            </a:pPr>
+            <a:r>
+              <a:rPr lang="en-US" sz="2600" b="1" dirty="0">
+                <a:solidFill>
+                  <a:srgbClr val="EDEDED"/>
+                </a:solidFill>
+                <a:latin typeface="Trebuchet MS" pitchFamily="34" charset="0"/>
+                <a:ea typeface="Trebuchet MS" pitchFamily="34" charset="-122"/>
+                <a:cs typeface="Trebuchet MS" pitchFamily="34" charset="-120"/>
+              </a:rPr>
+              <a:t>LinUCB — bandit contextual (vencedor)</a:t>
+            </a:r>
+            <a:endParaRPr lang="en-US" sz="2600" dirty="0"/>
+          </a:p>
+        </p:txBody>
+      </p:sp>
+      <p:sp>
+        <p:nvSpPr>
+          <p:cNvPr id="4" name="Shape 2"/>
+          <p:cNvSpPr/>
+          <p:nvPr/>
+        </p:nvSpPr>
+        <p:spPr>
+          <a:xfrm>
+            <a:off x="566928" y="1783080"/>
+            <a:ext cx="4526280" cy="2240280"/>
+          </a:xfrm>
+          <a:prstGeom prst="roundRect">
+            <a:avLst>
+              <a:gd name="adj" fmla="val 3673"/>
+            </a:avLst>
+          </a:prstGeom>
+          <a:solidFill>
+            <a:srgbClr val="0C0C0E"/>
+          </a:solidFill>
+          <a:ln w="12700">
+            <a:solidFill>
+              <a:srgbClr val="2A2A30"/>
+            </a:solidFill>
+            <a:prstDash val="solid"/>
+          </a:ln>
+          <a:effectLst>
+            <a:outerShdw sx="100000" sy="100000" kx="0" ky="0" algn="bl" rotWithShape="0" blurRad="114300" dist="38100" dir="8100000">
+              <a:srgbClr val="000000">
+                <a:alpha val="45000"/>
+              </a:srgbClr>
+            </a:outerShdw>
+          </a:effectLst>
+        </p:spPr>
+      </p:sp>
+      <p:sp>
+        <p:nvSpPr>
+          <p:cNvPr id="5" name="Text 3"/>
+          <p:cNvSpPr/>
+          <p:nvPr/>
+        </p:nvSpPr>
+        <p:spPr>
+          <a:xfrm>
+            <a:off x="795528" y="1938528"/>
+            <a:ext cx="4069080" cy="256032"/>
+          </a:xfrm>
+          <a:prstGeom prst="rect">
+            <a:avLst/>
+          </a:prstGeom>
+          <a:noFill/>
+          <a:ln/>
+        </p:spPr>
+        <p:txBody>
+          <a:bodyPr wrap="square" lIns="0" tIns="0" rIns="0" bIns="0" rtlCol="0" anchor="ctr"/>
+          <a:lstStyle/>
+          <a:p>
+            <a:pPr indent="0" marL="0">
+              <a:buNone/>
+            </a:pPr>
+            <a:r>
+              <a:rPr lang="en-US" sz="1000" b="1" spc="200" kern="0" dirty="0">
+                <a:solidFill>
+                  <a:srgbClr val="34D399"/>
+                </a:solidFill>
+                <a:latin typeface="Consolas" pitchFamily="34" charset="0"/>
+                <a:ea typeface="Consolas" pitchFamily="34" charset="-122"/>
+                <a:cs typeface="Consolas" pitchFamily="34" charset="-120"/>
+              </a:rPr>
+              <a:t>MATEMÁTICA</a:t>
+            </a:r>
+            <a:endParaRPr lang="en-US" sz="1000" dirty="0"/>
+          </a:p>
+        </p:txBody>
+      </p:sp>
+      <p:pic>
+        <p:nvPicPr>
+          <p:cNvPr id="6" name="Image 0" descr="C:\Users\Dione\Desktop\datathon-7mlet-grupo-64\datathon-7mlet-grupo-64\.pptx-build/tech/eq_linucb.png">    </p:cNvPr>
+          <p:cNvPicPr>
+            <a:picLocks noChangeAspect="1"/>
+          </p:cNvPicPr>
+          <p:nvPr/>
+        </p:nvPicPr>
+        <p:blipFill>
+          <a:blip r:embed="rId1"/>
+          <a:srcRect l="0" r="0" t="0" b="0"/>
+          <a:stretch/>
+        </p:blipFill>
+        <p:spPr>
+          <a:xfrm>
+            <a:off x="749808" y="2249424"/>
+            <a:ext cx="4160520" cy="1627632"/>
+          </a:xfrm>
+          <a:prstGeom prst="rect">
+            <a:avLst/>
+          </a:prstGeom>
+        </p:spPr>
+      </p:pic>
+      <p:sp>
+        <p:nvSpPr>
+          <p:cNvPr id="7" name="Text 4"/>
+          <p:cNvSpPr/>
+          <p:nvPr/>
+        </p:nvSpPr>
+        <p:spPr>
+          <a:xfrm>
+            <a:off x="585216" y="4206240"/>
+            <a:ext cx="4526280" cy="237744"/>
+          </a:xfrm>
+          <a:prstGeom prst="rect">
+            <a:avLst/>
+          </a:prstGeom>
+          <a:noFill/>
+          <a:ln/>
+        </p:spPr>
+        <p:txBody>
+          <a:bodyPr wrap="square" lIns="0" tIns="0" rIns="0" bIns="0" rtlCol="0" anchor="ctr"/>
+          <a:lstStyle/>
+          <a:p>
+            <a:pPr indent="0" marL="0">
+              <a:buNone/>
+            </a:pPr>
+            <a:r>
+              <a:rPr lang="en-US" sz="950" b="1" spc="200" kern="0" dirty="0">
+                <a:solidFill>
+                  <a:srgbClr val="9A9AA6"/>
+                </a:solidFill>
+                <a:latin typeface="Consolas" pitchFamily="34" charset="0"/>
+                <a:ea typeface="Consolas" pitchFamily="34" charset="-122"/>
+                <a:cs typeface="Consolas" pitchFamily="34" charset="-120"/>
+              </a:rPr>
+              <a:t>REFERÊNCIA</a:t>
+            </a:r>
+            <a:endParaRPr lang="en-US" sz="950" dirty="0"/>
+          </a:p>
+        </p:txBody>
+      </p:sp>
+      <p:sp>
+        <p:nvSpPr>
+          <p:cNvPr id="8" name="Text 5"/>
+          <p:cNvSpPr/>
+          <p:nvPr/>
+        </p:nvSpPr>
+        <p:spPr>
+          <a:xfrm>
+            <a:off x="585216" y="4443984"/>
+            <a:ext cx="4663440" cy="566928"/>
+          </a:xfrm>
+          <a:prstGeom prst="rect">
+            <a:avLst/>
+          </a:prstGeom>
+          <a:noFill/>
+          <a:ln/>
+        </p:spPr>
+        <p:txBody>
+          <a:bodyPr wrap="square" lIns="0" tIns="0" rIns="0" bIns="0" rtlCol="0" anchor="ctr"/>
+          <a:lstStyle/>
+          <a:p>
+            <a:pPr indent="0" marL="0">
+              <a:lnSpc>
+                <a:spcPct val="103000"/>
+              </a:lnSpc>
+              <a:buNone/>
+            </a:pPr>
+            <a:r>
+              <a:rPr lang="en-US" sz="1250" b="1" dirty="0">
+                <a:solidFill>
+                  <a:srgbClr val="EDEDED"/>
+                </a:solidFill>
+                <a:latin typeface="Calibri" pitchFamily="34" charset="0"/>
+                <a:ea typeface="Calibri" pitchFamily="34" charset="-122"/>
+                <a:cs typeface="Calibri" pitchFamily="34" charset="-120"/>
+              </a:rPr>
+              <a:t>Li, Chu, Langford &amp; Schapire (2010).</a:t>
+            </a:r>
+            <a:endParaRPr lang="en-US" sz="1250" dirty="0"/>
+          </a:p>
+        </p:txBody>
+      </p:sp>
+      <p:sp>
+        <p:nvSpPr>
+          <p:cNvPr id="9" name="Text 6"/>
+          <p:cNvSpPr/>
+          <p:nvPr/>
+        </p:nvSpPr>
+        <p:spPr>
+          <a:xfrm>
+            <a:off x="585216" y="5074920"/>
+            <a:ext cx="4663440" cy="868680"/>
+          </a:xfrm>
+          <a:prstGeom prst="rect">
+            <a:avLst/>
+          </a:prstGeom>
+          <a:noFill/>
+          <a:ln/>
+        </p:spPr>
+        <p:txBody>
+          <a:bodyPr wrap="square" lIns="0" tIns="0" rIns="0" bIns="0" rtlCol="0" anchor="ctr"/>
+          <a:lstStyle/>
+          <a:p>
+            <a:pPr indent="0" marL="0">
+              <a:lnSpc>
+                <a:spcPct val="105000"/>
+              </a:lnSpc>
+              <a:buNone/>
+            </a:pPr>
+            <a:r>
+              <a:rPr lang="en-US" sz="1250" dirty="0">
+                <a:solidFill>
+                  <a:srgbClr val="9A9AA6"/>
+                </a:solidFill>
+                <a:latin typeface="Calibri" pitchFamily="34" charset="0"/>
+                <a:ea typeface="Calibri" pitchFamily="34" charset="-122"/>
+                <a:cs typeface="Calibri" pitchFamily="34" charset="-120"/>
+              </a:rPr>
+              <a:t>Ridge por braço sobre o contexto + bônus de incerteza → roteia a oferta certa para o perfil certo. Foi a política vencedora (+59,9%).</a:t>
+            </a:r>
+            <a:endParaRPr lang="en-US" sz="1250" dirty="0"/>
+          </a:p>
+        </p:txBody>
+      </p:sp>
+      <p:sp>
+        <p:nvSpPr>
+          <p:cNvPr id="10" name="Shape 7"/>
+          <p:cNvSpPr/>
+          <p:nvPr/>
+        </p:nvSpPr>
+        <p:spPr>
+          <a:xfrm>
+            <a:off x="5349240" y="1783080"/>
+            <a:ext cx="6272784" cy="4114800"/>
+          </a:xfrm>
+          <a:prstGeom prst="roundRect">
+            <a:avLst>
+              <a:gd name="adj" fmla="val 2000"/>
+            </a:avLst>
+          </a:prstGeom>
+          <a:solidFill>
+            <a:srgbClr val="272822"/>
+          </a:solidFill>
+          <a:ln w="12700">
+            <a:solidFill>
+              <a:srgbClr val="2A2A30"/>
+            </a:solidFill>
+            <a:prstDash val="solid"/>
+          </a:ln>
+          <a:effectLst>
+            <a:outerShdw sx="100000" sy="100000" kx="0" ky="0" algn="bl" rotWithShape="0" blurRad="114300" dist="38100" dir="8100000">
+              <a:srgbClr val="000000">
+                <a:alpha val="45000"/>
+              </a:srgbClr>
+            </a:outerShdw>
+          </a:effectLst>
+        </p:spPr>
+      </p:sp>
+      <p:pic>
+        <p:nvPicPr>
+          <p:cNvPr id="11" name="Image 1" descr="C:\Users\Dione\Desktop\datathon-7mlet-grupo-64\datathon-7mlet-grupo-64\.pptx-build/tech/code_linucb.png">    </p:cNvPr>
+          <p:cNvPicPr>
+            <a:picLocks noChangeAspect="1"/>
+          </p:cNvPicPr>
+          <p:nvPr/>
+        </p:nvPicPr>
+        <p:blipFill>
+          <a:blip r:embed="rId2"/>
+          <a:srcRect l="0" r="0" t="0" b="0"/>
+          <a:stretch/>
+        </p:blipFill>
+        <p:spPr>
+          <a:xfrm>
+            <a:off x="5532120" y="1938528"/>
+            <a:ext cx="5907024" cy="3566160"/>
+          </a:xfrm>
+          <a:prstGeom prst="rect">
+            <a:avLst/>
+          </a:prstGeom>
+        </p:spPr>
+      </p:pic>
+      <p:sp>
+        <p:nvSpPr>
+          <p:cNvPr id="12" name="Text 8"/>
+          <p:cNvSpPr/>
+          <p:nvPr/>
+        </p:nvSpPr>
+        <p:spPr>
+          <a:xfrm>
+            <a:off x="5550408" y="5541264"/>
+            <a:ext cx="5870448" cy="274320"/>
+          </a:xfrm>
+          <a:prstGeom prst="rect">
+            <a:avLst/>
+          </a:prstGeom>
+          <a:noFill/>
+          <a:ln/>
+        </p:spPr>
+        <p:txBody>
+          <a:bodyPr wrap="square" lIns="0" tIns="0" rIns="0" bIns="0" rtlCol="0" anchor="ctr"/>
+          <a:lstStyle/>
+          <a:p>
+            <a:pPr indent="0" marL="0">
+              <a:buNone/>
+            </a:pPr>
+            <a:r>
+              <a:rPr lang="en-US" sz="1050" b="1" dirty="0">
+                <a:solidFill>
+                  <a:srgbClr val="34D399"/>
+                </a:solidFill>
+                <a:latin typeface="Consolas" pitchFamily="34" charset="0"/>
+                <a:ea typeface="Consolas" pitchFamily="34" charset="-122"/>
+                <a:cs typeface="Consolas" pitchFamily="34" charset="-120"/>
+              </a:rPr>
+              <a:t>src/adaptive_offers/bandits/linucb.py</a:t>
+            </a:r>
+            <a:endParaRPr lang="en-US" sz="1050" dirty="0"/>
+          </a:p>
+        </p:txBody>
+      </p:sp>
+      <p:sp>
+        <p:nvSpPr>
+          <p:cNvPr id="13" name="Text 9"/>
+          <p:cNvSpPr/>
+          <p:nvPr/>
+        </p:nvSpPr>
+        <p:spPr>
+          <a:xfrm>
+            <a:off x="566928" y="6437376"/>
+            <a:ext cx="4572000" cy="274320"/>
+          </a:xfrm>
+          <a:prstGeom prst="rect">
+            <a:avLst/>
+          </a:prstGeom>
+          <a:noFill/>
+          <a:ln/>
+        </p:spPr>
+        <p:txBody>
+          <a:bodyPr wrap="square" lIns="0" tIns="0" rIns="0" bIns="0" rtlCol="0" anchor="ctr"/>
+          <a:lstStyle/>
+          <a:p>
+            <a:pPr algn="l" indent="0" marL="0">
+              <a:buNone/>
+            </a:pPr>
+            <a:r>
+              <a:rPr lang="en-US" sz="850" spc="200" kern="0" dirty="0">
+                <a:solidFill>
+                  <a:srgbClr val="5A5A63"/>
+                </a:solidFill>
+                <a:latin typeface="Consolas" pitchFamily="34" charset="0"/>
+                <a:ea typeface="Consolas" pitchFamily="34" charset="-122"/>
+                <a:cs typeface="Consolas" pitchFamily="34" charset="-120"/>
+              </a:rPr>
+              <a:t>ADAPTIVE OFFERS PLATFORM</a:t>
+            </a:r>
+            <a:endParaRPr lang="en-US" sz="850" dirty="0"/>
+          </a:p>
+        </p:txBody>
+      </p:sp>
+      <p:sp>
+        <p:nvSpPr>
+          <p:cNvPr id="14" name="Text 10"/>
+          <p:cNvSpPr/>
+          <p:nvPr/>
+        </p:nvSpPr>
+        <p:spPr>
+          <a:xfrm>
+            <a:off x="7050024" y="6437376"/>
+            <a:ext cx="4572000" cy="274320"/>
+          </a:xfrm>
+          <a:prstGeom prst="rect">
+            <a:avLst/>
+          </a:prstGeom>
+          <a:noFill/>
+          <a:ln/>
+        </p:spPr>
+        <p:txBody>
+          <a:bodyPr wrap="square" lIns="0" tIns="0" rIns="0" bIns="0" rtlCol="0" anchor="ctr"/>
+          <a:lstStyle/>
+          <a:p>
+            <a:pPr algn="r" indent="0" marL="0">
+              <a:buNone/>
+            </a:pPr>
+            <a:r>
+              <a:rPr lang="en-US" sz="850" spc="200" kern="0" dirty="0">
+                <a:solidFill>
+                  <a:srgbClr val="5A5A63"/>
+                </a:solidFill>
+                <a:latin typeface="Consolas" pitchFamily="34" charset="0"/>
+                <a:ea typeface="Consolas" pitchFamily="34" charset="-122"/>
+                <a:cs typeface="Consolas" pitchFamily="34" charset="-120"/>
+              </a:rPr>
+              <a:t>GRUPO 64 · FIAP PÓS-TECH 7MLET</a:t>
+            </a:r>
+            <a:endParaRPr lang="en-US" sz="850" dirty="0"/>
+          </a:p>
+        </p:txBody>
+      </p:sp>
+      <p:sp>
+        <p:nvSpPr>
+          <p:cNvPr id="15" name="Text 11"/>
+          <p:cNvSpPr/>
+          <p:nvPr/>
+        </p:nvSpPr>
+        <p:spPr>
+          <a:xfrm>
+            <a:off x="5820156" y="6437376"/>
+            <a:ext cx="548640" cy="274320"/>
+          </a:xfrm>
+          <a:prstGeom prst="rect">
+            <a:avLst/>
+          </a:prstGeom>
+          <a:noFill/>
+          <a:ln/>
+        </p:spPr>
+        <p:txBody>
+          <a:bodyPr wrap="square" lIns="0" tIns="0" rIns="0" bIns="0" rtlCol="0" anchor="ctr"/>
+          <a:lstStyle/>
+          <a:p>
+            <a:pPr algn="ctr" indent="0" marL="0">
+              <a:buNone/>
+            </a:pPr>
+            <a:r>
+              <a:rPr lang="en-US" sz="850" b="1" dirty="0">
+                <a:solidFill>
+                  <a:srgbClr val="0070F3"/>
+                </a:solidFill>
+                <a:latin typeface="Consolas" pitchFamily="34" charset="0"/>
+                <a:ea typeface="Consolas" pitchFamily="34" charset="-122"/>
+                <a:cs typeface="Consolas" pitchFamily="34" charset="-120"/>
+              </a:rPr>
+              <a:t>18</a:t>
+            </a:r>
+            <a:endParaRPr lang="en-US" sz="850" dirty="0"/>
+          </a:p>
+        </p:txBody>
+      </p:sp>
+    </p:spTree>
+  </p:cSld>
+  <p:clrMapOvr>
+    <a:masterClrMapping/>
+  </p:clrMapOvr>
+</p:sld>
+</file>
+
+<file path=ppt/slides/slide19.xml><?xml version="1.0" encoding="utf-8"?>
+<p:sld xmlns:a="http://schemas.openxmlformats.org/drawingml/2006/main" xmlns:r="http://schemas.openxmlformats.org/officeDocument/2006/relationships" xmlns:p="http://schemas.openxmlformats.org/presentationml/2006/main">
+  <p:cSld name="Slide 19">
+    <p:bg>
+      <p:bgPr>
         <a:blipFill dpi="0" rotWithShape="1">
           <a:blip r:embed="rId1">
             <a:lum/>

</xml_diff>

<commit_message>
docs(pitch): rerun on REAL UCI Bank Marketing base — honest results
Real data (data/kaggle/raw/bank-additional-full.csv, 41,188 rows, provenance
"real") replaces the facsimile. The lift collapses from the facsimile's +60% to
realistic single digits: Thompson leads by value (+9.2%), LinUCB has the lowest
regret (8.3%) and highest conversion (9.1%), Nilos-UCB falls below baseline
(-2.6%). Slides 4/5/8/18/19 and all six charts rebuilt with the real numbers;
no embellishment.

Co-Authored-By: Claude Opus 4.8 <noreply@anthropic.com>
</commit_message>
<xml_diff>
--- a/docs/Adaptive-Offers-Pitch-Grupo64.pptx
+++ b/docs/Adaptive-Offers-Pitch-Grupo64.pptx
@@ -9612,7 +9612,7 @@
                 <a:ea typeface="Trebuchet MS" pitchFamily="34" charset="-122"/>
                 <a:cs typeface="Trebuchet MS" pitchFamily="34" charset="-120"/>
               </a:rPr>
-              <a:t>LinUCB — bandit contextual (vencedor)</a:t>
+              <a:t>LinUCB — bandit contextual (menor regret)</a:t>
             </a:r>
             <a:endParaRPr lang="en-US" sz="2600" dirty="0"/>
           </a:p>
@@ -9831,7 +9831,7 @@
                 <a:ea typeface="Calibri" pitchFamily="34" charset="-122"/>
                 <a:cs typeface="Calibri" pitchFamily="34" charset="-120"/>
               </a:rPr>
-              <a:t>Ridge por braço sobre o contexto + bônus de incerteza → roteia a oferta certa para o perfil certo. Foi a política vencedora (+59,9%).</a:t>
+              <a:t>Ridge por braço sobre o contexto + bônus de incerteza → roteia a oferta certa para o perfil certo. Na base real teve o menor regret (8,3%) e a maior conversão (9,1%); ganho de valor modesto (~+8%).</a:t>
             </a:r>
             <a:endParaRPr lang="en-US" sz="1250" dirty="0"/>
           </a:p>
@@ -10264,7 +10264,7 @@
                 <a:ea typeface="Trebuchet MS" pitchFamily="34" charset="-122"/>
                 <a:cs typeface="Trebuchet MS" pitchFamily="34" charset="-120"/>
               </a:rPr>
-              <a:t>+60%</a:t>
+              <a:t>+9%</a:t>
             </a:r>
             <a:endParaRPr lang="en-US" sz="3600" dirty="0"/>
           </a:p>
@@ -10303,7 +10303,7 @@
                 <a:ea typeface="Calibri" pitchFamily="34" charset="-122"/>
                 <a:cs typeface="Calibri" pitchFamily="34" charset="-120"/>
               </a:rPr>
-              <a:t>valor vs. baseline</a:t>
+              <a:t>melhor vs. baseline</a:t>
             </a:r>
             <a:endParaRPr lang="en-US" sz="1250" dirty="0"/>
           </a:p>
@@ -10342,7 +10342,7 @@
                 <a:ea typeface="Trebuchet MS" pitchFamily="34" charset="-122"/>
                 <a:cs typeface="Trebuchet MS" pitchFamily="34" charset="-120"/>
               </a:rPr>
-              <a:t>9,1%</a:t>
+              <a:t>8,3%</a:t>
             </a:r>
             <a:endParaRPr lang="en-US" sz="3600" dirty="0"/>
           </a:p>
@@ -10381,7 +10381,7 @@
                 <a:ea typeface="Calibri" pitchFamily="34" charset="-122"/>
                 <a:cs typeface="Calibri" pitchFamily="34" charset="-120"/>
               </a:rPr>
-              <a:t>regret ratio</a:t>
+              <a:t>menor regret</a:t>
             </a:r>
             <a:endParaRPr lang="en-US" sz="1250" dirty="0"/>
           </a:p>
@@ -12526,7 +12526,7 @@
                 <a:ea typeface="Trebuchet MS" pitchFamily="34" charset="-122"/>
                 <a:cs typeface="Trebuchet MS" pitchFamily="34" charset="-120"/>
               </a:rPr>
-              <a:t>Base factual</a:t>
+              <a:t>Base factual real</a:t>
             </a:r>
             <a:endParaRPr lang="en-US" sz="1700" dirty="0"/>
           </a:p>
@@ -12568,7 +12568,7 @@
                 <a:ea typeface="Calibri" pitchFamily="34" charset="-122"/>
                 <a:cs typeface="Calibri" pitchFamily="34" charset="-120"/>
               </a:rPr>
-              <a:t>Bank Marketing (Kaggle/UCI). Sem vazamento: duration removido. Nenhum dado real de cliente.</a:t>
+              <a:t>Bank Marketing real (UCI · 41.188 contatos públicos). Sem vazamento: duration removido.</a:t>
             </a:r>
             <a:endParaRPr lang="en-US" sz="1350" dirty="0"/>
           </a:p>
@@ -13804,7 +13804,7 @@
                 <a:ea typeface="Calibri" pitchFamily="34" charset="-122"/>
                 <a:cs typeface="Calibri" pitchFamily="34" charset="-120"/>
               </a:rPr>
-              <a:t>Ridge linear sobre o contexto — a política vencedora.</a:t>
+              <a:t>Ridge linear sobre o contexto — menor regret nos dados reais.</a:t>
             </a:r>
             <a:endParaRPr lang="en-US" sz="1350" dirty="0"/>
           </a:p>
@@ -16828,7 +16828,7 @@
                 <a:ea typeface="Consolas" pitchFamily="34" charset="-122"/>
                 <a:cs typeface="Consolas" pitchFamily="34" charset="-120"/>
               </a:rPr>
-              <a:t>EVIDÊNCIAS</a:t>
+              <a:t>EVIDÊNCIAS · BASE REAL (KAGGLE/UCI)</a:t>
             </a:r>
             <a:endParaRPr lang="en-US" sz="1150" dirty="0"/>
           </a:p>
@@ -16843,7 +16843,7 @@
         <p:spPr>
           <a:xfrm>
             <a:off x="566928" y="896112"/>
-            <a:ext cx="10515600" cy="914400"/>
+            <a:ext cx="10972800" cy="914400"/>
           </a:xfrm>
           <a:prstGeom prst="rect">
             <a:avLst/>
@@ -16862,7 +16862,7 @@
               <a:buNone/>
             </a:pPr>
             <a:r>
-              <a:rPr lang="en-US" sz="3000" b="1" dirty="0">
+              <a:rPr lang="en-US" sz="2800" b="1" dirty="0">
                 <a:solidFill>
                   <a:srgbClr val="EDEDED"/>
                 </a:solidFill>
@@ -16870,9 +16870,9 @@
                 <a:ea typeface="Trebuchet MS" pitchFamily="34" charset="-122"/>
                 <a:cs typeface="Trebuchet MS" pitchFamily="34" charset="-120"/>
               </a:rPr>
-              <a:t>LinUCB capturou +60% de valor vs. baseline</a:t>
-            </a:r>
-            <a:endParaRPr lang="en-US" sz="3000" dirty="0"/>
+              <a:t>Na base real, o aprendizado supera a regra fixa</a:t>
+            </a:r>
+            <a:endParaRPr lang="en-US" sz="2800" dirty="0"/>
           </a:p>
         </p:txBody>
       </p:sp>
@@ -16935,7 +16935,7 @@
               <a:buNone/>
             </a:pPr>
             <a:r>
-              <a:rPr lang="en-US" sz="3300" b="1" dirty="0">
+              <a:rPr lang="en-US" sz="3200" b="1" dirty="0">
                 <a:solidFill>
                   <a:srgbClr val="34D399"/>
                 </a:solidFill>
@@ -16943,9 +16943,9 @@
                 <a:ea typeface="Trebuchet MS" pitchFamily="34" charset="-122"/>
                 <a:cs typeface="Trebuchet MS" pitchFamily="34" charset="-120"/>
               </a:rPr>
-              <a:t>+59,9%</a:t>
-            </a:r>
-            <a:endParaRPr lang="en-US" sz="3300" dirty="0"/>
+              <a:t>+9,2%</a:t>
+            </a:r>
+            <a:endParaRPr lang="en-US" sz="3200" dirty="0"/>
           </a:p>
         </p:txBody>
       </p:sp>
@@ -16982,7 +16982,7 @@
                 <a:ea typeface="Calibri" pitchFamily="34" charset="-122"/>
                 <a:cs typeface="Calibri" pitchFamily="34" charset="-120"/>
               </a:rPr>
-              <a:t>valor vs. baseline</a:t>
+              <a:t>melhor valor vs. baseline</a:t>
             </a:r>
             <a:endParaRPr lang="en-US" sz="1150" dirty="0"/>
           </a:p>
@@ -17047,7 +17047,7 @@
               <a:buNone/>
             </a:pPr>
             <a:r>
-              <a:rPr lang="en-US" sz="3300" b="1" dirty="0">
+              <a:rPr lang="en-US" sz="3200" b="1" dirty="0">
                 <a:solidFill>
                   <a:srgbClr val="3291FF"/>
                 </a:solidFill>
@@ -17055,9 +17055,9 @@
                 <a:ea typeface="Trebuchet MS" pitchFamily="34" charset="-122"/>
                 <a:cs typeface="Trebuchet MS" pitchFamily="34" charset="-120"/>
               </a:rPr>
-              <a:t>9,1%</a:t>
-            </a:r>
-            <a:endParaRPr lang="en-US" sz="3300" dirty="0"/>
+              <a:t>8,3%</a:t>
+            </a:r>
+            <a:endParaRPr lang="en-US" sz="3200" dirty="0"/>
           </a:p>
         </p:txBody>
       </p:sp>
@@ -17094,7 +17094,7 @@
                 <a:ea typeface="Calibri" pitchFamily="34" charset="-122"/>
                 <a:cs typeface="Calibri" pitchFamily="34" charset="-120"/>
               </a:rPr>
-              <a:t>regret ratio (↓ é melhor)</a:t>
+              <a:t>menor regret (LinUCB)</a:t>
             </a:r>
             <a:endParaRPr lang="en-US" sz="1150" dirty="0"/>
           </a:p>
@@ -17159,17 +17159,17 @@
               <a:buNone/>
             </a:pPr>
             <a:r>
-              <a:rPr lang="en-US" sz="3300" b="1" dirty="0">
-                <a:solidFill>
-                  <a:srgbClr val="F5A623"/>
+              <a:rPr lang="en-US" sz="3200" b="1" dirty="0">
+                <a:solidFill>
+                  <a:srgbClr val="3291FF"/>
                 </a:solidFill>
                 <a:latin typeface="Trebuchet MS" pitchFamily="34" charset="0"/>
                 <a:ea typeface="Trebuchet MS" pitchFamily="34" charset="-122"/>
                 <a:cs typeface="Trebuchet MS" pitchFamily="34" charset="-120"/>
               </a:rPr>
-              <a:t>6 / 6</a:t>
-            </a:r>
-            <a:endParaRPr lang="en-US" sz="3300" dirty="0"/>
+              <a:t>9,1%</a:t>
+            </a:r>
+            <a:endParaRPr lang="en-US" sz="3200" dirty="0"/>
           </a:p>
         </p:txBody>
       </p:sp>
@@ -17206,7 +17206,7 @@
                 <a:ea typeface="Calibri" pitchFamily="34" charset="-122"/>
                 <a:cs typeface="Calibri" pitchFamily="34" charset="-120"/>
               </a:rPr>
-              <a:t>ofertas usadas (baseline: 1)</a:t>
+              <a:t>maior conversão (LinUCB)</a:t>
             </a:r>
             <a:endParaRPr lang="en-US" sz="1150" dirty="0"/>
           </a:p>
@@ -17271,17 +17271,17 @@
               <a:buNone/>
             </a:pPr>
             <a:r>
-              <a:rPr lang="en-US" sz="3300" b="1" dirty="0">
-                <a:solidFill>
-                  <a:srgbClr val="EDEDED"/>
+              <a:rPr lang="en-US" sz="3200" b="1" dirty="0">
+                <a:solidFill>
+                  <a:srgbClr val="F5A623"/>
                 </a:solidFill>
                 <a:latin typeface="Trebuchet MS" pitchFamily="34" charset="0"/>
                 <a:ea typeface="Trebuchet MS" pitchFamily="34" charset="-122"/>
                 <a:cs typeface="Trebuchet MS" pitchFamily="34" charset="-120"/>
               </a:rPr>
-              <a:t>13%</a:t>
-            </a:r>
-            <a:endParaRPr lang="en-US" sz="3300" dirty="0"/>
+              <a:t>41.188</a:t>
+            </a:r>
+            <a:endParaRPr lang="en-US" sz="3200" dirty="0"/>
           </a:p>
         </p:txBody>
       </p:sp>
@@ -17318,7 +17318,7 @@
                 <a:ea typeface="Calibri" pitchFamily="34" charset="-122"/>
                 <a:cs typeface="Calibri" pitchFamily="34" charset="-120"/>
               </a:rPr>
-              <a:t>taxa de exploração saudável</a:t>
+              <a:t>contatos reais (UCI)</a:t>
             </a:r>
             <a:endParaRPr lang="en-US" sz="1150" dirty="0"/>
           </a:p>
@@ -17333,7 +17333,7 @@
         <p:spPr>
           <a:xfrm>
             <a:off x="566928" y="3310128"/>
-            <a:ext cx="6400800" cy="274320"/>
+            <a:ext cx="6949440" cy="274320"/>
           </a:xfrm>
           <a:prstGeom prst="rect">
             <a:avLst/>
@@ -17349,7 +17349,7 @@
               <a:buNone/>
             </a:pPr>
             <a:r>
-              <a:rPr lang="en-US" sz="1100" b="1" spc="100" kern="0" dirty="0">
+              <a:rPr lang="en-US" sz="1050" b="1" spc="100" kern="0" dirty="0">
                 <a:solidFill>
                   <a:srgbClr val="9A9AA6"/>
                 </a:solidFill>
@@ -17357,9 +17357,9 @@
                 <a:ea typeface="Consolas" pitchFamily="34" charset="-122"/>
                 <a:cs typeface="Consolas" pitchFamily="34" charset="-120"/>
               </a:rPr>
-              <a:t>VALOR ACUMULADO POR POLÍTICA (R$)</a:t>
-            </a:r>
-            <a:endParaRPr lang="en-US" sz="1100" dirty="0"/>
+              <a:t>VALOR ACUMULADO POR POLÍTICA (R$ · 6.000 rodadas)</a:t>
+            </a:r>
+            <a:endParaRPr lang="en-US" sz="1050" dirty="0"/>
           </a:p>
         </p:txBody>
       </p:sp>
@@ -17388,7 +17388,7 @@
               <a:buNone/>
             </a:pPr>
             <a:r>
-              <a:rPr lang="en-US" sz="1350" b="1" dirty="0">
+              <a:rPr lang="en-US" sz="1300" b="1" dirty="0">
                 <a:solidFill>
                   <a:srgbClr val="EDEDED"/>
                 </a:solidFill>
@@ -17396,9 +17396,9 @@
                 <a:ea typeface="Trebuchet MS" pitchFamily="34" charset="-122"/>
                 <a:cs typeface="Trebuchet MS" pitchFamily="34" charset="-120"/>
               </a:rPr>
-              <a:t>LinUCB</a:t>
-            </a:r>
-            <a:endParaRPr lang="en-US" sz="1350" dirty="0"/>
+              <a:t>Thompson</a:t>
+            </a:r>
+            <a:endParaRPr lang="en-US" sz="1300" dirty="0"/>
           </a:p>
         </p:txBody>
       </p:sp>
@@ -17479,7 +17479,7 @@
                 <a:ea typeface="Trebuchet MS" pitchFamily="34" charset="-122"/>
                 <a:cs typeface="Trebuchet MS" pitchFamily="34" charset="-120"/>
               </a:rPr>
-              <a:t>R$ 118.080</a:t>
+              <a:t>R$ 114.290</a:t>
             </a:r>
             <a:endParaRPr lang="en-US" sz="1200" dirty="0"/>
           </a:p>
@@ -17510,7 +17510,7 @@
               <a:buNone/>
             </a:pPr>
             <a:r>
-              <a:rPr lang="en-US" sz="1350" b="1" dirty="0">
+              <a:rPr lang="en-US" sz="1300" b="1" dirty="0">
                 <a:solidFill>
                   <a:srgbClr val="EDEDED"/>
                 </a:solidFill>
@@ -17518,9 +17518,9 @@
                 <a:ea typeface="Trebuchet MS" pitchFamily="34" charset="-122"/>
                 <a:cs typeface="Trebuchet MS" pitchFamily="34" charset="-120"/>
               </a:rPr>
-              <a:t>Nilos-UCB</a:t>
-            </a:r>
-            <a:endParaRPr lang="en-US" sz="1350" dirty="0"/>
+              <a:t>LinUCB</a:t>
+            </a:r>
+            <a:endParaRPr lang="en-US" sz="1300" dirty="0"/>
           </a:p>
         </p:txBody>
       </p:sp>
@@ -17555,7 +17555,7 @@
         <p:spPr>
           <a:xfrm>
             <a:off x="2057400" y="4270248"/>
-            <a:ext cx="4385972" cy="292608"/>
+            <a:ext cx="5027852" cy="292608"/>
           </a:xfrm>
           <a:prstGeom prst="roundRect">
             <a:avLst>
@@ -17563,7 +17563,7 @@
             </a:avLst>
           </a:prstGeom>
           <a:solidFill>
-            <a:srgbClr val="0070F3"/>
+            <a:srgbClr val="3291FF"/>
           </a:solidFill>
           <a:ln/>
         </p:spPr>
@@ -17576,7 +17576,7 @@
         </p:nvSpPr>
         <p:spPr>
           <a:xfrm>
-            <a:off x="6553100" y="4233672"/>
+            <a:off x="7194980" y="4233672"/>
             <a:ext cx="1417320" cy="365760"/>
           </a:xfrm>
           <a:prstGeom prst="rect">
@@ -17601,7 +17601,7 @@
                 <a:ea typeface="Trebuchet MS" pitchFamily="34" charset="-122"/>
                 <a:cs typeface="Trebuchet MS" pitchFamily="34" charset="-120"/>
               </a:rPr>
-              <a:t>R$ 102.050</a:t>
+              <a:t>R$ 113.230</a:t>
             </a:r>
             <a:endParaRPr lang="en-US" sz="1200" dirty="0"/>
           </a:p>
@@ -17632,7 +17632,7 @@
               <a:buNone/>
             </a:pPr>
             <a:r>
-              <a:rPr lang="en-US" sz="1350" b="1" dirty="0">
+              <a:rPr lang="en-US" sz="1300" b="1" dirty="0">
                 <a:solidFill>
                   <a:srgbClr val="EDEDED"/>
                 </a:solidFill>
@@ -17640,9 +17640,9 @@
                 <a:ea typeface="Trebuchet MS" pitchFamily="34" charset="-122"/>
                 <a:cs typeface="Trebuchet MS" pitchFamily="34" charset="-120"/>
               </a:rPr>
-              <a:t>Thompson</a:t>
-            </a:r>
-            <a:endParaRPr lang="en-US" sz="1350" dirty="0"/>
+              <a:t>Baseline</a:t>
+            </a:r>
+            <a:endParaRPr lang="en-US" sz="1300" dirty="0"/>
           </a:p>
         </p:txBody>
       </p:sp>
@@ -17677,7 +17677,7 @@
         <p:spPr>
           <a:xfrm>
             <a:off x="2057400" y="4800600"/>
-            <a:ext cx="4224372" cy="292608"/>
+            <a:ext cx="4649087" cy="292608"/>
           </a:xfrm>
           <a:prstGeom prst="roundRect">
             <a:avLst>
@@ -17685,7 +17685,7 @@
             </a:avLst>
           </a:prstGeom>
           <a:solidFill>
-            <a:srgbClr val="0070F3"/>
+            <a:srgbClr val="52525B"/>
           </a:solidFill>
           <a:ln/>
         </p:spPr>
@@ -17698,7 +17698,7 @@
         </p:nvSpPr>
         <p:spPr>
           <a:xfrm>
-            <a:off x="6391500" y="4764024"/>
+            <a:off x="6816215" y="4764024"/>
             <a:ext cx="1417320" cy="365760"/>
           </a:xfrm>
           <a:prstGeom prst="rect">
@@ -17723,7 +17723,7 @@
                 <a:ea typeface="Trebuchet MS" pitchFamily="34" charset="-122"/>
                 <a:cs typeface="Trebuchet MS" pitchFamily="34" charset="-120"/>
               </a:rPr>
-              <a:t>R$ 98.290</a:t>
+              <a:t>R$ 104.700</a:t>
             </a:r>
             <a:endParaRPr lang="en-US" sz="1200" dirty="0"/>
           </a:p>
@@ -17754,7 +17754,7 @@
               <a:buNone/>
             </a:pPr>
             <a:r>
-              <a:rPr lang="en-US" sz="1350" b="1" dirty="0">
+              <a:rPr lang="en-US" sz="1300" b="1" dirty="0">
                 <a:solidFill>
                   <a:srgbClr val="EDEDED"/>
                 </a:solidFill>
@@ -17762,9 +17762,9 @@
                 <a:ea typeface="Trebuchet MS" pitchFamily="34" charset="-122"/>
                 <a:cs typeface="Trebuchet MS" pitchFamily="34" charset="-120"/>
               </a:rPr>
-              <a:t>Baseline</a:t>
-            </a:r>
-            <a:endParaRPr lang="en-US" sz="1350" dirty="0"/>
+              <a:t>Nilos-UCB</a:t>
+            </a:r>
+            <a:endParaRPr lang="en-US" sz="1300" dirty="0"/>
           </a:p>
         </p:txBody>
       </p:sp>
@@ -17799,7 +17799,7 @@
         <p:spPr>
           <a:xfrm>
             <a:off x="2057400" y="5330952"/>
-            <a:ext cx="3173114" cy="292608"/>
+            <a:ext cx="4530084" cy="292608"/>
           </a:xfrm>
           <a:prstGeom prst="roundRect">
             <a:avLst>
@@ -17807,7 +17807,7 @@
             </a:avLst>
           </a:prstGeom>
           <a:solidFill>
-            <a:srgbClr val="52525B"/>
+            <a:srgbClr val="EF4444"/>
           </a:solidFill>
           <a:ln/>
         </p:spPr>
@@ -17820,7 +17820,7 @@
         </p:nvSpPr>
         <p:spPr>
           <a:xfrm>
-            <a:off x="5340242" y="5294376"/>
+            <a:off x="6697212" y="5294376"/>
             <a:ext cx="1417320" cy="365760"/>
           </a:xfrm>
           <a:prstGeom prst="rect">
@@ -17845,7 +17845,7 @@
                 <a:ea typeface="Trebuchet MS" pitchFamily="34" charset="-122"/>
                 <a:cs typeface="Trebuchet MS" pitchFamily="34" charset="-120"/>
               </a:rPr>
-              <a:t>R$ 73.830</a:t>
+              <a:t>R$ 102.020</a:t>
             </a:r>
             <a:endParaRPr lang="en-US" sz="1200" dirty="0"/>
           </a:p>
@@ -17893,7 +17893,7 @@
         </p:nvSpPr>
         <p:spPr>
           <a:xfrm>
-            <a:off x="9217152" y="3401568"/>
+            <a:off x="9217152" y="3383280"/>
             <a:ext cx="2130552" cy="274320"/>
           </a:xfrm>
           <a:prstGeom prst="rect">
@@ -17910,7 +17910,7 @@
               <a:buNone/>
             </a:pPr>
             <a:r>
-              <a:rPr lang="en-US" sz="1050" b="1" spc="200" kern="0" dirty="0">
+              <a:rPr lang="en-US" sz="1050" b="1" spc="150" kern="0" dirty="0">
                 <a:solidFill>
                   <a:srgbClr val="3291FF"/>
                 </a:solidFill>
@@ -17918,7 +17918,7 @@
                 <a:ea typeface="Consolas" pitchFamily="34" charset="-122"/>
                 <a:cs typeface="Consolas" pitchFamily="34" charset="-120"/>
               </a:rPr>
-              <a:t>O INSIGHT</a:t>
+              <a:t>A LEITURA HONESTA</a:t>
             </a:r>
             <a:endParaRPr lang="en-US" sz="1050" dirty="0"/>
           </a:p>
@@ -17932,8 +17932,8 @@
         </p:nvSpPr>
         <p:spPr>
           <a:xfrm>
-            <a:off x="9217152" y="3712464"/>
-            <a:ext cx="2130552" cy="960120"/>
+            <a:off x="9217152" y="3657600"/>
+            <a:ext cx="2176272" cy="822960"/>
           </a:xfrm>
           <a:prstGeom prst="rect">
             <a:avLst/>
@@ -17947,12 +17947,12 @@
           <a:p>
             <a:pPr indent="0" marL="0">
               <a:lnSpc>
-                <a:spcPct val="106000"/>
+                <a:spcPct val="104000"/>
               </a:lnSpc>
               <a:buNone/>
             </a:pPr>
             <a:r>
-              <a:rPr lang="en-US" sz="1250" b="1" dirty="0">
+              <a:rPr lang="en-US" sz="1200" b="1" dirty="0">
                 <a:solidFill>
                   <a:srgbClr val="EDEDED"/>
                 </a:solidFill>
@@ -17960,16 +17960,16 @@
                 <a:ea typeface="Calibri" pitchFamily="34" charset="-122"/>
                 <a:cs typeface="Calibri" pitchFamily="34" charset="-120"/>
               </a:rPr>
-              <a:t>O baseline converte MAIS </a:t>
+              <a:t>Ganho real, mas modesto </a:t>
             </a:r>
             <a:pPr indent="0" marL="0">
               <a:lnSpc>
-                <a:spcPct val="106000"/>
+                <a:spcPct val="104000"/>
               </a:lnSpc>
               <a:buNone/>
             </a:pPr>
             <a:r>
-              <a:rPr lang="en-US" sz="1250" dirty="0">
+              <a:rPr lang="en-US" sz="1200" dirty="0">
                 <a:solidFill>
                   <a:srgbClr val="9A9AA6"/>
                 </a:solidFill>
@@ -17977,9 +17977,9 @@
                 <a:ea typeface="Calibri" pitchFamily="34" charset="-122"/>
                 <a:cs typeface="Calibri" pitchFamily="34" charset="-120"/>
               </a:rPr>
-              <a:t>(10,3%) — mas joga 5.924 das 6.000 decisões no Cashback (margem baixa).</a:t>
-            </a:r>
-            <a:endParaRPr lang="en-US" sz="1250" dirty="0"/>
+              <a:t>(~+8–9%) — realista, sem número mágico.</a:t>
+            </a:r>
+            <a:endParaRPr lang="en-US" sz="1200" dirty="0"/>
           </a:p>
         </p:txBody>
       </p:sp>
@@ -17991,8 +17991,8 @@
         </p:nvSpPr>
         <p:spPr>
           <a:xfrm>
-            <a:off x="9217152" y="4736592"/>
-            <a:ext cx="2130552" cy="914400"/>
+            <a:off x="9217152" y="4480560"/>
+            <a:ext cx="2176272" cy="1051560"/>
           </a:xfrm>
           <a:prstGeom prst="rect">
             <a:avLst/>
@@ -18006,39 +18006,39 @@
           <a:p>
             <a:pPr indent="0" marL="0">
               <a:lnSpc>
-                <a:spcPct val="106000"/>
+                <a:spcPct val="104000"/>
               </a:lnSpc>
               <a:buNone/>
             </a:pPr>
             <a:r>
-              <a:rPr lang="en-US" sz="1250" b="1" dirty="0">
-                <a:solidFill>
-                  <a:srgbClr val="34D399"/>
+              <a:rPr lang="en-US" sz="1200" dirty="0">
+                <a:solidFill>
+                  <a:srgbClr val="9A9AA6"/>
                 </a:solidFill>
                 <a:latin typeface="Calibri" pitchFamily="34" charset="0"/>
                 <a:ea typeface="Calibri" pitchFamily="34" charset="-122"/>
                 <a:cs typeface="Calibri" pitchFamily="34" charset="-120"/>
               </a:rPr>
-              <a:t>O LinUCB converte menos, </a:t>
+              <a:t>Baseline aposta 85% no Empréstimo; o LinUCB diversifica pelo contexto → </a:t>
             </a:r>
             <a:pPr indent="0" marL="0">
               <a:lnSpc>
-                <a:spcPct val="106000"/>
+                <a:spcPct val="104000"/>
               </a:lnSpc>
               <a:buNone/>
             </a:pPr>
             <a:r>
-              <a:rPr lang="en-US" sz="1250" dirty="0">
-                <a:solidFill>
-                  <a:srgbClr val="9A9AA6"/>
+              <a:rPr lang="en-US" sz="1200" b="1" dirty="0">
+                <a:solidFill>
+                  <a:srgbClr val="34D399"/>
                 </a:solidFill>
                 <a:latin typeface="Calibri" pitchFamily="34" charset="0"/>
                 <a:ea typeface="Calibri" pitchFamily="34" charset="-122"/>
                 <a:cs typeface="Calibri" pitchFamily="34" charset="-120"/>
               </a:rPr>
-              <a:t>mas diversifica para a margem alta e rende +60%.</a:t>
-            </a:r>
-            <a:endParaRPr lang="en-US" sz="1250" dirty="0"/>
+              <a:t>menor regret e maior conversão.</a:t>
+            </a:r>
+            <a:endParaRPr lang="en-US" sz="1200" dirty="0"/>
           </a:p>
         </p:txBody>
       </p:sp>
@@ -18050,34 +18050,54 @@
         </p:nvSpPr>
         <p:spPr>
           <a:xfrm>
-            <a:off x="9217152" y="5532120"/>
-            <a:ext cx="2130552" cy="320040"/>
-          </a:xfrm>
-          <a:prstGeom prst="rect">
-            <a:avLst/>
-          </a:prstGeom>
-          <a:noFill/>
-          <a:ln/>
-        </p:spPr>
-        <p:txBody>
-          <a:bodyPr wrap="square" lIns="0" tIns="0" rIns="0" bIns="0" rtlCol="0" anchor="ctr"/>
+            <a:off x="9217152" y="5504688"/>
+            <a:ext cx="2176272" cy="640080"/>
+          </a:xfrm>
+          <a:prstGeom prst="rect">
+            <a:avLst/>
+          </a:prstGeom>
+          <a:noFill/>
+          <a:ln/>
+        </p:spPr>
+        <p:txBody>
+          <a:bodyPr wrap="square" lIns="0" tIns="0" rIns="0" bIns="0" rtlCol="0" anchor="t"/>
           <a:lstStyle/>
           <a:p>
             <a:pPr indent="0" marL="0">
-              <a:buNone/>
-            </a:pPr>
-            <a:r>
-              <a:rPr lang="en-US" sz="1400" b="1" i="1" dirty="0">
-                <a:solidFill>
-                  <a:srgbClr val="3291FF"/>
-                </a:solidFill>
-                <a:latin typeface="Trebuchet MS" pitchFamily="34" charset="0"/>
-                <a:ea typeface="Trebuchet MS" pitchFamily="34" charset="-122"/>
-                <a:cs typeface="Trebuchet MS" pitchFamily="34" charset="-120"/>
-              </a:rPr>
-              <a:t>Conversão ≠ valor.</a:t>
-            </a:r>
-            <a:endParaRPr lang="en-US" sz="1400" dirty="0"/>
+              <a:lnSpc>
+                <a:spcPct val="104000"/>
+              </a:lnSpc>
+              <a:buNone/>
+            </a:pPr>
+            <a:r>
+              <a:rPr lang="en-US" sz="1200" b="1" dirty="0">
+                <a:solidFill>
+                  <a:srgbClr val="F5A623"/>
+                </a:solidFill>
+                <a:latin typeface="Calibri" pitchFamily="34" charset="0"/>
+                <a:ea typeface="Calibri" pitchFamily="34" charset="-122"/>
+                <a:cs typeface="Calibri" pitchFamily="34" charset="-120"/>
+              </a:rPr>
+              <a:t>Nem todo bandit vence: </a:t>
+            </a:r>
+            <a:pPr indent="0" marL="0">
+              <a:lnSpc>
+                <a:spcPct val="104000"/>
+              </a:lnSpc>
+              <a:buNone/>
+            </a:pPr>
+            <a:r>
+              <a:rPr lang="en-US" sz="1200" dirty="0">
+                <a:solidFill>
+                  <a:srgbClr val="9A9AA6"/>
+                </a:solidFill>
+                <a:latin typeface="Calibri" pitchFamily="34" charset="0"/>
+                <a:ea typeface="Calibri" pitchFamily="34" charset="-122"/>
+                <a:cs typeface="Calibri" pitchFamily="34" charset="-120"/>
+              </a:rPr>
+              <a:t>Nilos-UCB ficou abaixo do baseline (−2,6%).</a:t>
+            </a:r>
+            <a:endParaRPr lang="en-US" sz="1200" dirty="0"/>
           </a:p>
         </p:txBody>
       </p:sp>

</xml_diff>